<commit_message>
Add course-toolkit analysis: Chronos, fixed Prophet, impulse response, panel and break tests
Co-Authored-By: Claude Opus 5.5 <noreply@anthropic.com>
Claude-Session: https://claude.ai/code/session_01MGxrqNkCGgpin2owaUrbi7
</commit_message>
<xml_diff>
--- a/slides/LA_home_values_slides.pptx
+++ b/slides/LA_home_values_slides.pptx
@@ -233,46 +233,68 @@
             <c:idx val="10"/>
             <c:spPr>
               <a:solidFill>
+                <a:srgbClr val="B8BECC"/>
+              </a:solidFill>
+            </c:spPr>
+          </c:dPt>
+          <c:dPt>
+            <c:idx val="11"/>
+            <c:spPr>
+              <a:solidFill>
+                <a:srgbClr val="B8BECC"/>
+              </a:solidFill>
+            </c:spPr>
+          </c:dPt>
+          <c:dPt>
+            <c:idx val="12"/>
+            <c:spPr>
+              <a:solidFill>
                 <a:srgbClr val="1F6F8B"/>
               </a:solidFill>
             </c:spPr>
           </c:dPt>
           <c:cat>
             <c:strRef>
-              <c:f>Sheet1!$A$2:$A$12</c:f>
+              <c:f>Sheet1!$A$2:$A$14</c:f>
               <c:strCache>
-                <c:ptCount val="11"/>
+                <c:ptCount val="13"/>
                 <c:pt idx="0">
                   <c:v>Prophet</c:v>
                 </c:pt>
                 <c:pt idx="1">
+                  <c:v>Prophet + COVID &amp; rates</c:v>
+                </c:pt>
+                <c:pt idx="2">
                   <c:v>XGBoost</c:v>
                 </c:pt>
-                <c:pt idx="2">
+                <c:pt idx="3">
                   <c:v>Factor VAR (neighborhoods)</c:v>
                 </c:pt>
-                <c:pt idx="3">
+                <c:pt idx="4">
                   <c:v>LightGBM</c:v>
                 </c:pt>
-                <c:pt idx="4">
+                <c:pt idx="5">
+                  <c:v>Chronos (foundation model)</c:v>
+                </c:pt>
+                <c:pt idx="6">
                   <c:v>Holt (damped)</c:v>
                 </c:pt>
-                <c:pt idx="5">
+                <c:pt idx="7">
                   <c:v>Naive drift</c:v>
                 </c:pt>
-                <c:pt idx="6">
+                <c:pt idx="8">
                   <c:v>GRU</c:v>
                 </c:pt>
-                <c:pt idx="7">
+                <c:pt idx="9">
                   <c:v>LSTM</c:v>
                 </c:pt>
-                <c:pt idx="8">
+                <c:pt idx="10">
                   <c:v>VAR (growth + rate)</c:v>
                 </c:pt>
-                <c:pt idx="9">
+                <c:pt idx="11">
                   <c:v>ARIMA</c:v>
                 </c:pt>
-                <c:pt idx="10">
+                <c:pt idx="12">
                   <c:v>ARIMAX</c:v>
                 </c:pt>
               </c:strCache>
@@ -280,41 +302,47 @@
           </c:cat>
           <c:val>
             <c:numRef>
-              <c:f>Sheet1!$B$2:$B$12</c:f>
+              <c:f>Sheet1!$B$2:$B$14</c:f>
               <c:numCache>
                 <c:formatCode>General</c:formatCode>
-                <c:ptCount val="11"/>
+                <c:ptCount val="13"/>
                 <c:pt idx="0">
                   <c:v>6.89</c:v>
                 </c:pt>
                 <c:pt idx="1">
+                  <c:v>5.12</c:v>
+                </c:pt>
+                <c:pt idx="2">
                   <c:v>3.65</c:v>
                 </c:pt>
-                <c:pt idx="2">
+                <c:pt idx="3">
                   <c:v>3.64</c:v>
                 </c:pt>
-                <c:pt idx="3">
+                <c:pt idx="4">
                   <c:v>3.6</c:v>
                 </c:pt>
-                <c:pt idx="4">
+                <c:pt idx="5">
+                  <c:v>3.56</c:v>
+                </c:pt>
+                <c:pt idx="6">
                   <c:v>3.39</c:v>
                 </c:pt>
-                <c:pt idx="5">
+                <c:pt idx="7">
                   <c:v>3.27</c:v>
                 </c:pt>
-                <c:pt idx="6">
+                <c:pt idx="8">
                   <c:v>3.18</c:v>
                 </c:pt>
-                <c:pt idx="7">
+                <c:pt idx="9">
                   <c:v>3.02</c:v>
                 </c:pt>
-                <c:pt idx="8">
+                <c:pt idx="10">
                   <c:v>2.93</c:v>
                 </c:pt>
-                <c:pt idx="9">
+                <c:pt idx="11">
                   <c:v>2.77</c:v>
                 </c:pt>
-                <c:pt idx="10">
+                <c:pt idx="12">
                   <c:v>2.67</c:v>
                 </c:pt>
               </c:numCache>
@@ -410,377 +438,6 @@
       </c:valAx>
     </c:plotArea>
     <c:dispBlanksAs val="gap"/>
-  </c:chart>
-  <c:txPr>
-    <a:bodyPr/>
-    <a:lstStyle/>
-    <a:p>
-      <a:pPr>
-        <a:defRPr sz="1100">
-          <a:solidFill>
-            <a:srgbClr val="222A37"/>
-          </a:solidFill>
-          <a:latin typeface="Arial"/>
-          <a:ea typeface="Arial"/>
-        </a:defRPr>
-      </a:pPr>
-      <a:endParaRPr lang="en-US"/>
-    </a:p>
-  </c:txPr>
-  <c:externalData r:id="rId1">
-    <c:autoUpdate val="0"/>
-  </c:externalData>
-</c:chartSpace>
-</file>
-
-<file path=ppt/charts/chart2.xml><?xml version="1.0" encoding="utf-8"?>
-<c:chartSpace xmlns:c="http://schemas.openxmlformats.org/drawingml/2006/chart" xmlns:a="http://schemas.openxmlformats.org/drawingml/2006/main" xmlns:r="http://schemas.openxmlformats.org/officeDocument/2006/relationships">
-  <c:date1904 val="0"/>
-  <c:chart>
-    <c:autoTitleDeleted val="1"/>
-    <c:plotArea>
-      <c:lineChart>
-        <c:grouping val="standard"/>
-        <c:varyColors val="0"/>
-        <c:ser>
-          <c:idx val="0"/>
-          <c:order val="0"/>
-          <c:tx>
-            <c:strRef>
-              <c:f>Sheet1!$B$1</c:f>
-              <c:strCache>
-                <c:ptCount val="1"/>
-                <c:pt idx="0">
-                  <c:v>ARIMAX</c:v>
-                </c:pt>
-              </c:strCache>
-            </c:strRef>
-          </c:tx>
-          <c:spPr>
-            <a:ln w="31750">
-              <a:solidFill>
-                <a:srgbClr val="1F6F8B"/>
-              </a:solidFill>
-            </a:ln>
-          </c:spPr>
-          <c:marker>
-            <c:spPr>
-              <a:solidFill>
-                <a:srgbClr val="1F6F8B"/>
-              </a:solidFill>
-              <a:ln>
-                <a:solidFill>
-                  <a:srgbClr val="1F6F8B"/>
-                </a:solidFill>
-              </a:ln>
-            </c:spPr>
-          </c:marker>
-          <c:cat>
-            <c:strRef>
-              <c:f>Sheet1!$A$2:$A$5</c:f>
-              <c:strCache>
-                <c:ptCount val="4"/>
-                <c:pt idx="0">
-                  <c:v>1 month</c:v>
-                </c:pt>
-                <c:pt idx="1">
-                  <c:v>3 months</c:v>
-                </c:pt>
-                <c:pt idx="2">
-                  <c:v>6 months</c:v>
-                </c:pt>
-                <c:pt idx="3">
-                  <c:v>12 months</c:v>
-                </c:pt>
-              </c:strCache>
-            </c:strRef>
-          </c:cat>
-          <c:val>
-            <c:numRef>
-              <c:f>Sheet1!$B$2:$B$5</c:f>
-              <c:numCache>
-                <c:formatCode>General</c:formatCode>
-                <c:ptCount val="4"/>
-                <c:pt idx="0">
-                  <c:v>0.09</c:v>
-                </c:pt>
-                <c:pt idx="1">
-                  <c:v>0.8</c:v>
-                </c:pt>
-                <c:pt idx="2">
-                  <c:v>2.45</c:v>
-                </c:pt>
-                <c:pt idx="3">
-                  <c:v>4.98</c:v>
-                </c:pt>
-              </c:numCache>
-            </c:numRef>
-          </c:val>
-          <c:smooth val="0"/>
-        </c:ser>
-        <c:ser>
-          <c:idx val="1"/>
-          <c:order val="1"/>
-          <c:tx>
-            <c:strRef>
-              <c:f>Sheet1!$C$1</c:f>
-              <c:strCache>
-                <c:ptCount val="1"/>
-                <c:pt idx="0">
-                  <c:v>ARIMA</c:v>
-                </c:pt>
-              </c:strCache>
-            </c:strRef>
-          </c:tx>
-          <c:spPr>
-            <a:ln w="31750">
-              <a:solidFill>
-                <a:srgbClr val="009FBD"/>
-              </a:solidFill>
-            </a:ln>
-          </c:spPr>
-          <c:marker>
-            <c:spPr>
-              <a:solidFill>
-                <a:srgbClr val="009FBD"/>
-              </a:solidFill>
-              <a:ln>
-                <a:solidFill>
-                  <a:srgbClr val="009FBD"/>
-                </a:solidFill>
-              </a:ln>
-            </c:spPr>
-          </c:marker>
-          <c:cat>
-            <c:strRef>
-              <c:f>Sheet1!$A$2:$A$5</c:f>
-              <c:strCache>
-                <c:ptCount val="4"/>
-                <c:pt idx="0">
-                  <c:v>1 month</c:v>
-                </c:pt>
-                <c:pt idx="1">
-                  <c:v>3 months</c:v>
-                </c:pt>
-                <c:pt idx="2">
-                  <c:v>6 months</c:v>
-                </c:pt>
-                <c:pt idx="3">
-                  <c:v>12 months</c:v>
-                </c:pt>
-              </c:strCache>
-            </c:strRef>
-          </c:cat>
-          <c:val>
-            <c:numRef>
-              <c:f>Sheet1!$C$2:$C$5</c:f>
-              <c:numCache>
-                <c:formatCode>General</c:formatCode>
-                <c:ptCount val="4"/>
-                <c:pt idx="0">
-                  <c:v>0.09</c:v>
-                </c:pt>
-                <c:pt idx="1">
-                  <c:v>0.78</c:v>
-                </c:pt>
-                <c:pt idx="2">
-                  <c:v>2.53</c:v>
-                </c:pt>
-                <c:pt idx="3">
-                  <c:v>5.36</c:v>
-                </c:pt>
-              </c:numCache>
-            </c:numRef>
-          </c:val>
-          <c:smooth val="0"/>
-        </c:ser>
-        <c:ser>
-          <c:idx val="2"/>
-          <c:order val="2"/>
-          <c:tx>
-            <c:strRef>
-              <c:f>Sheet1!$D$1</c:f>
-              <c:strCache>
-                <c:ptCount val="1"/>
-                <c:pt idx="0">
-                  <c:v>Naive drift</c:v>
-                </c:pt>
-              </c:strCache>
-            </c:strRef>
-          </c:tx>
-          <c:spPr>
-            <a:ln w="31750">
-              <a:solidFill>
-                <a:srgbClr val="C0965C"/>
-              </a:solidFill>
-            </a:ln>
-          </c:spPr>
-          <c:marker>
-            <c:spPr>
-              <a:solidFill>
-                <a:srgbClr val="C0965C"/>
-              </a:solidFill>
-              <a:ln>
-                <a:solidFill>
-                  <a:srgbClr val="C0965C"/>
-                </a:solidFill>
-              </a:ln>
-            </c:spPr>
-          </c:marker>
-          <c:cat>
-            <c:strRef>
-              <c:f>Sheet1!$A$2:$A$5</c:f>
-              <c:strCache>
-                <c:ptCount val="4"/>
-                <c:pt idx="0">
-                  <c:v>1 month</c:v>
-                </c:pt>
-                <c:pt idx="1">
-                  <c:v>3 months</c:v>
-                </c:pt>
-                <c:pt idx="2">
-                  <c:v>6 months</c:v>
-                </c:pt>
-                <c:pt idx="3">
-                  <c:v>12 months</c:v>
-                </c:pt>
-              </c:strCache>
-            </c:strRef>
-          </c:cat>
-          <c:val>
-            <c:numRef>
-              <c:f>Sheet1!$D$2:$D$5</c:f>
-              <c:numCache>
-                <c:formatCode>General</c:formatCode>
-                <c:ptCount val="4"/>
-                <c:pt idx="0">
-                  <c:v>0.69</c:v>
-                </c:pt>
-                <c:pt idx="1">
-                  <c:v>1.93</c:v>
-                </c:pt>
-                <c:pt idx="2">
-                  <c:v>3.48</c:v>
-                </c:pt>
-                <c:pt idx="3">
-                  <c:v>4.92</c:v>
-                </c:pt>
-              </c:numCache>
-            </c:numRef>
-          </c:val>
-          <c:smooth val="0"/>
-        </c:ser>
-        <c:marker val="1"/>
-        <c:smooth val="0"/>
-        <c:axId val="2118791784"/>
-        <c:axId val="2140495176"/>
-      </c:lineChart>
-      <c:catAx>
-        <c:axId val="2118791784"/>
-        <c:scaling>
-          <c:orientation val="minMax"/>
-        </c:scaling>
-        <c:delete val="0"/>
-        <c:axPos val="b"/>
-        <c:majorTickMark val="out"/>
-        <c:minorTickMark val="none"/>
-        <c:tickLblPos val="nextTo"/>
-        <c:spPr>
-          <a:ln>
-            <a:solidFill>
-              <a:srgbClr val="E7E9F0"/>
-            </a:solidFill>
-          </a:ln>
-        </c:spPr>
-        <c:txPr>
-          <a:bodyPr/>
-          <a:lstStyle/>
-          <a:p>
-            <a:pPr>
-              <a:defRPr sz="1000">
-                <a:solidFill>
-                  <a:srgbClr val="222A37"/>
-                </a:solidFill>
-                <a:latin typeface="Arial"/>
-                <a:ea typeface="Arial"/>
-              </a:defRPr>
-            </a:pPr>
-          </a:p>
-        </c:txPr>
-        <c:crossAx val="2140495176"/>
-        <c:crosses val="autoZero"/>
-        <c:auto val="1"/>
-        <c:lblAlgn val="ctr"/>
-        <c:lblOffset val="100"/>
-        <c:noMultiLvlLbl val="0"/>
-      </c:catAx>
-      <c:valAx>
-        <c:axId val="2140495176"/>
-        <c:scaling/>
-        <c:delete val="0"/>
-        <c:axPos val="l"/>
-        <c:majorGridlines>
-          <c:spPr>
-            <a:ln w="6350">
-              <a:solidFill>
-                <a:srgbClr val="E7E9F0"/>
-              </a:solidFill>
-            </a:ln>
-          </c:spPr>
-        </c:majorGridlines>
-        <c:numFmt formatCode="0.0&quot;%&quot;" sourceLinked="0"/>
-        <c:majorTickMark val="out"/>
-        <c:minorTickMark val="none"/>
-        <c:tickLblPos val="nextTo"/>
-        <c:spPr>
-          <a:ln>
-            <a:solidFill>
-              <a:srgbClr val="E7E9F0"/>
-            </a:solidFill>
-          </a:ln>
-        </c:spPr>
-        <c:txPr>
-          <a:bodyPr/>
-          <a:lstStyle/>
-          <a:p>
-            <a:pPr>
-              <a:defRPr sz="1000">
-                <a:solidFill>
-                  <a:srgbClr val="222A37"/>
-                </a:solidFill>
-                <a:latin typeface="Arial"/>
-                <a:ea typeface="Arial"/>
-              </a:defRPr>
-            </a:pPr>
-          </a:p>
-        </c:txPr>
-        <c:crossAx val="2118791784"/>
-        <c:crosses val="autoZero"/>
-      </c:valAx>
-    </c:plotArea>
-    <c:legend>
-      <c:legendPos val="t"/>
-      <c:layout/>
-      <c:overlay val="0"/>
-      <c:txPr>
-        <a:bodyPr/>
-        <a:lstStyle/>
-        <a:p>
-          <a:pPr>
-            <a:defRPr>
-              <a:solidFill>
-                <a:srgbClr val="222A37"/>
-              </a:solidFill>
-              <a:latin typeface="Arial"/>
-              <a:ea typeface="Arial"/>
-            </a:defRPr>
-          </a:pPr>
-        </a:p>
-      </c:txPr>
-    </c:legend>
-    <c:plotVisOnly val="1"/>
-    <c:dispBlanksAs val="gap"/>
-    <c:showDLblsOverMax val="0"/>
   </c:chart>
   <c:txPr>
     <a:bodyPr/>
@@ -1269,7 +926,7 @@
           <a:lstStyle/>
           <a:p>
             <a:r>
-              <a:t>Four takeaways. First, for a smooth monthly housing index, simple models beat complex ones. Second, how you test decides who wins: one blind window would have picked the wrong model. Third, mortgage rates matter, but slowly, with about a two-year lag and a modest gain. And fourth, the metro average hides a split market. One common factor drives most of the movement across neighborhoods, but each neighborhood's own trend is what you need to forecast it. If you are buying or lending in LA, look at the neighborhood, not the metro number. Thank you.</a:t>
+              <a:t>Five takeaways. First, for a smooth monthly housing index, simple models beat complex ones, including the Chronos foundation model. Second, how you test decides who wins: one blind window would have picked the wrong model. Third, mortgage rates matter, but slowly: a one-point rise lowers values about nine percent over two years. Fourth, use the long history: training on all data since 2000 forecast better than starting in 2008, 2012 or 2016, even with the breaks in between. And fifth, the metro average hides a split market. One common factor drives most of the movement across neighborhoods, but each neighborhood's own trend is what you need to forecast it. If you are buying or lending in LA, look at the neighborhood, not the metro number. Thank you.</a:t>
             </a:r>
           </a:p>
         </p:txBody>
@@ -1409,7 +1066,7 @@
           <a:lstStyle/>
           <a:p>
             <a:r>
-              <a:t>Here is the setup. Three data sources: the Zillow index for the metro, 499 neighborhoods from Zillow's neighborhood file, and the 30-year mortgage rate from FRED. We compared eleven models in four families, from a naive drift baseline to LSTM and GRU networks, plus three models that use outside information. And we scored them two ways. A blind 80/20 split, like most projects use, and a rolling-origin test where we refit every three months and forecast twelve months ahead, eighteen times. One warning: Zillow smooths this index, so next month is almost the same as this month and every decent model is about 0.1 percent off one month ahead. That tells us nothing, so we judge models at six to twelve months.</a:t>
+              <a:t>Here is the setup. Three data sources: the Zillow index for the metro, 499 neighborhoods from Zillow's neighborhood file, and the 30-year mortgage rate from FRED. We compared thirteen models in four families, from a naive drift baseline to LSTM and GRU networks and Amazon's Chronos foundation model, plus three models that use outside information. And we scored them two ways. A blind 80/20 split, like most projects use, and a rolling-origin test where we refit every three months and forecast twelve months ahead, eighteen times. One warning: Zillow smooths this index, so next month is almost the same as this month and every decent model is about 0.1 percent off one month ahead. That tells us nothing, so we judge models at six to twelve months.</a:t>
             </a:r>
           </a:p>
         </p:txBody>
@@ -1549,7 +1206,7 @@
           <a:lstStyle/>
           <a:p>
             <a:r>
-              <a:t>Here is why the test design matters. In the single blind test, LightGBM won with a 2.2 percent error. It was the only model whose forecast bent, and it happened to bend in the right years. Across eighteen rolling tests it ranked eighth. Meanwhile VAR, LSTM and XGBoost took the 2021 boom and kept going, ending 25 to 35 percent too high. The lesson for us: one test window can crown the wrong model, so we trust the rolling test.</a:t>
+              <a:t>Here is why the test design matters. In the single blind test, LightGBM won with a 2.2 percent error. It was the only model whose forecast bent, and it happened to bend in the right years. Across eighteen rolling tests it ranked ninth. Meanwhile VAR, LSTM and XGBoost took the 2021 boom and kept going, ending 25 to 35 percent too high. The lesson for us: one test window can crown the wrong model, so we trust the rolling test.</a:t>
             </a:r>
           </a:p>
         </p:txBody>
@@ -1619,7 +1276,7 @@
           <a:lstStyle/>
           <a:p>
             <a:r>
-              <a:t>Do mortgage rates help? A little, and slowly. In the training data, a rise in rates shows up in LA home values about two years later, so our ARIMAX uses the rate change lagged 24 months. The coefficient has the right sign but a p-value of 0.16, so it is weak evidence. The chart shows where it helps: ARIMAX and ARIMA are tied at short horizons, and ARIMAX pulls ahead at 12 months, 4.98 versus 5.37 percent. But the honest finding is that a naive drift, just extending LA's long-run growth, is as good as anything we built a year out.</a:t>
+              <a:t>How much do mortgage rates matter? We used the VAR from class and traced an impulse response: what happens to LA home values after a one-point rise in the mortgage rate. Values barely move for the first few months, then fall steadily: about 4.5 percent lower after a year and about 9 percent lower after two, and the 90 percent band stays below zero from about a year on. A Granger causality test agrees on the direction: past rates help predict home values, but past home values do not help predict rates. The effect is slow, which is why it only helps our forecasts at the 12-month horizon, and even there a simple naive drift is about as good.</a:t>
             </a:r>
           </a:p>
         </p:txBody>
@@ -5443,7 +5100,7 @@
         </p:nvSpPr>
         <p:spPr>
           <a:xfrm>
-            <a:off x="502920" y="1380744"/>
+            <a:off x="502920" y="1289304"/>
             <a:ext cx="384048" cy="384048"/>
           </a:xfrm>
           <a:prstGeom prst="roundRect">
@@ -5475,7 +5132,7 @@
         </p:nvSpPr>
         <p:spPr>
           <a:xfrm>
-            <a:off x="502920" y="1380744"/>
+            <a:off x="502920" y="1289304"/>
             <a:ext cx="384048" cy="384048"/>
           </a:xfrm>
           <a:prstGeom prst="rect">
@@ -5521,7 +5178,7 @@
         </p:nvSpPr>
         <p:spPr>
           <a:xfrm>
-            <a:off x="1051560" y="1362456"/>
+            <a:off x="1051560" y="1271016"/>
             <a:ext cx="7589520" cy="292608"/>
           </a:xfrm>
           <a:prstGeom prst="rect">
@@ -5567,7 +5224,7 @@
         </p:nvSpPr>
         <p:spPr>
           <a:xfrm>
-            <a:off x="1051560" y="1655064"/>
+            <a:off x="1051560" y="1563624"/>
             <a:ext cx="7589520" cy="548640"/>
           </a:xfrm>
           <a:prstGeom prst="rect">
@@ -5600,7 +5257,7 @@
                 </a:solidFill>
                 <a:latin typeface="Arial"/>
               </a:rPr>
-              <a:t>ARIMA-family models won; LSTM, GRU and boosted trees never beat them.</a:t>
+              <a:t>ARIMA-family models beat LSTM, GRU, boosted trees and the Chronos foundation model.</a:t>
             </a:r>
           </a:p>
         </p:txBody>
@@ -5613,7 +5270,7 @@
         </p:nvSpPr>
         <p:spPr>
           <a:xfrm>
-            <a:off x="502920" y="2130552"/>
+            <a:off x="502920" y="1965960"/>
             <a:ext cx="384048" cy="384048"/>
           </a:xfrm>
           <a:prstGeom prst="roundRect">
@@ -5645,7 +5302,7 @@
         </p:nvSpPr>
         <p:spPr>
           <a:xfrm>
-            <a:off x="502920" y="2130552"/>
+            <a:off x="502920" y="1965960"/>
             <a:ext cx="384048" cy="384048"/>
           </a:xfrm>
           <a:prstGeom prst="rect">
@@ -5691,7 +5348,7 @@
         </p:nvSpPr>
         <p:spPr>
           <a:xfrm>
-            <a:off x="1051560" y="2112264"/>
+            <a:off x="1051560" y="1947672"/>
             <a:ext cx="7589520" cy="292608"/>
           </a:xfrm>
           <a:prstGeom prst="rect">
@@ -5737,7 +5394,7 @@
         </p:nvSpPr>
         <p:spPr>
           <a:xfrm>
-            <a:off x="1051560" y="2404872"/>
+            <a:off x="1051560" y="2240280"/>
             <a:ext cx="7589520" cy="548640"/>
           </a:xfrm>
           <a:prstGeom prst="rect">
@@ -5770,7 +5427,7 @@
                 </a:solidFill>
                 <a:latin typeface="Arial"/>
               </a:rPr>
-              <a:t>One blind window ranked LightGBM 1st; 18 rolling windows ranked it 8th.</a:t>
+              <a:t>One blind window ranked LightGBM 1st; 18 rolling windows, 9th.</a:t>
             </a:r>
           </a:p>
         </p:txBody>
@@ -5783,7 +5440,7 @@
         </p:nvSpPr>
         <p:spPr>
           <a:xfrm>
-            <a:off x="502920" y="2880360"/>
+            <a:off x="502920" y="2642616"/>
             <a:ext cx="384048" cy="384048"/>
           </a:xfrm>
           <a:prstGeom prst="roundRect">
@@ -5815,7 +5472,7 @@
         </p:nvSpPr>
         <p:spPr>
           <a:xfrm>
-            <a:off x="502920" y="2880360"/>
+            <a:off x="502920" y="2642616"/>
             <a:ext cx="384048" cy="384048"/>
           </a:xfrm>
           <a:prstGeom prst="rect">
@@ -5861,7 +5518,7 @@
         </p:nvSpPr>
         <p:spPr>
           <a:xfrm>
-            <a:off x="1051560" y="2862072"/>
+            <a:off x="1051560" y="2624328"/>
             <a:ext cx="7589520" cy="292608"/>
           </a:xfrm>
           <a:prstGeom prst="rect">
@@ -5894,7 +5551,7 @@
                 </a:solidFill>
                 <a:latin typeface="Arial"/>
               </a:rPr>
-              <a:t>Mortgage rates matter, slowly and modestly</a:t>
+              <a:t>Mortgage rates matter, slowly</a:t>
             </a:r>
           </a:p>
         </p:txBody>
@@ -5907,7 +5564,7 @@
         </p:nvSpPr>
         <p:spPr>
           <a:xfrm>
-            <a:off x="1051560" y="3154680"/>
+            <a:off x="1051560" y="2916936"/>
             <a:ext cx="7589520" cy="548640"/>
           </a:xfrm>
           <a:prstGeom prst="rect">
@@ -5940,7 +5597,7 @@
                 </a:solidFill>
                 <a:latin typeface="Arial"/>
               </a:rPr>
-              <a:t>About a two-year lag and a small gain at 12 months. Naive drift is as good a year out.</a:t>
+              <a:t>A 1-point rise lowers values about 9% over two years.</a:t>
             </a:r>
           </a:p>
         </p:txBody>
@@ -5953,7 +5610,7 @@
         </p:nvSpPr>
         <p:spPr>
           <a:xfrm>
-            <a:off x="502920" y="3630168"/>
+            <a:off x="502920" y="3319272"/>
             <a:ext cx="384048" cy="384048"/>
           </a:xfrm>
           <a:prstGeom prst="roundRect">
@@ -5985,7 +5642,7 @@
         </p:nvSpPr>
         <p:spPr>
           <a:xfrm>
-            <a:off x="502920" y="3630168"/>
+            <a:off x="502920" y="3319272"/>
             <a:ext cx="384048" cy="384048"/>
           </a:xfrm>
           <a:prstGeom prst="rect">
@@ -6031,7 +5688,7 @@
         </p:nvSpPr>
         <p:spPr>
           <a:xfrm>
-            <a:off x="1051560" y="3611880"/>
+            <a:off x="1051560" y="3300984"/>
             <a:ext cx="7589520" cy="292608"/>
           </a:xfrm>
           <a:prstGeom prst="rect">
@@ -6064,7 +5721,7 @@
                 </a:solidFill>
                 <a:latin typeface="Arial"/>
               </a:rPr>
-              <a:t>The metro average hides a split market</a:t>
+              <a:t>Use the long history</a:t>
             </a:r>
           </a:p>
         </p:txBody>
@@ -6077,7 +5734,7 @@
         </p:nvSpPr>
         <p:spPr>
           <a:xfrm>
-            <a:off x="1051560" y="3904488"/>
+            <a:off x="1051560" y="3593592"/>
             <a:ext cx="7589520" cy="548640"/>
           </a:xfrm>
           <a:prstGeom prst="rect">
@@ -6110,7 +5767,177 @@
                 </a:solidFill>
                 <a:latin typeface="Arial"/>
               </a:rPr>
-              <a:t>One shared factor drives most neighborhood movement, yet separate ARIMA models per neighborhood forecast better (2.8% vs 4.1% error).</a:t>
+              <a:t>Training from 2000 beat starting in 2008, 2012 or 2016.</a:t>
+            </a:r>
+          </a:p>
+        </p:txBody>
+      </p:sp>
+      <p:sp>
+        <p:nvSpPr>
+          <p:cNvPr id="23" name="Rounded Rectangle 22"/>
+          <p:cNvSpPr/>
+          <p:nvPr/>
+        </p:nvSpPr>
+        <p:spPr>
+          <a:xfrm>
+            <a:off x="502920" y="3995928"/>
+            <a:ext cx="384048" cy="384048"/>
+          </a:xfrm>
+          <a:prstGeom prst="roundRect">
+            <a:avLst>
+              <a:gd name="adj" fmla="val 50000"/>
+            </a:avLst>
+          </a:prstGeom>
+          <a:solidFill>
+            <a:srgbClr val="1F6F8B"/>
+          </a:solidFill>
+          <a:ln>
+            <a:noFill/>
+          </a:ln>
+          <a:effectLst/>
+        </p:spPr>
+        <p:txBody>
+          <a:bodyPr rtlCol="0" anchor="ctr"/>
+          <a:lstStyle/>
+          <a:p>
+            <a:pPr algn="ctr"/>
+          </a:p>
+        </p:txBody>
+      </p:sp>
+      <p:sp>
+        <p:nvSpPr>
+          <p:cNvPr id="24" name="TextBox 23"/>
+          <p:cNvSpPr txBox="1"/>
+          <p:nvPr/>
+        </p:nvSpPr>
+        <p:spPr>
+          <a:xfrm>
+            <a:off x="502920" y="3995928"/>
+            <a:ext cx="384048" cy="384048"/>
+          </a:xfrm>
+          <a:prstGeom prst="rect">
+            <a:avLst/>
+          </a:prstGeom>
+          <a:noFill/>
+          <a:ln/>
+        </p:spPr>
+        <p:txBody>
+          <a:bodyPr wrap="square" anchor="ctr" lIns="25400" rIns="25400" tIns="25400" bIns="25400">
+            <a:spAutoFit/>
+          </a:bodyPr>
+          <a:lstStyle/>
+          <a:p>
+            <a:pPr algn="ctr">
+              <a:lnSpc>
+                <a:spcPct val="100000"/>
+              </a:lnSpc>
+              <a:spcBef>
+                <a:spcPts val="0"/>
+              </a:spcBef>
+              <a:spcAft>
+                <a:spcPts val="0"/>
+              </a:spcAft>
+            </a:pPr>
+            <a:r>
+              <a:rPr sz="1400" b="1" i="0">
+                <a:solidFill>
+                  <a:srgbClr val="FFFFFF"/>
+                </a:solidFill>
+                <a:latin typeface="Arial"/>
+              </a:rPr>
+              <a:t>05</a:t>
+            </a:r>
+          </a:p>
+        </p:txBody>
+      </p:sp>
+      <p:sp>
+        <p:nvSpPr>
+          <p:cNvPr id="25" name="TextBox 24"/>
+          <p:cNvSpPr txBox="1"/>
+          <p:nvPr/>
+        </p:nvSpPr>
+        <p:spPr>
+          <a:xfrm>
+            <a:off x="1051560" y="3977640"/>
+            <a:ext cx="7589520" cy="292608"/>
+          </a:xfrm>
+          <a:prstGeom prst="rect">
+            <a:avLst/>
+          </a:prstGeom>
+          <a:noFill/>
+          <a:ln/>
+        </p:spPr>
+        <p:txBody>
+          <a:bodyPr wrap="square" anchor="t" lIns="25400" rIns="25400" tIns="25400" bIns="25400">
+            <a:spAutoFit/>
+          </a:bodyPr>
+          <a:lstStyle/>
+          <a:p>
+            <a:pPr algn="l">
+              <a:lnSpc>
+                <a:spcPct val="100000"/>
+              </a:lnSpc>
+              <a:spcBef>
+                <a:spcPts val="0"/>
+              </a:spcBef>
+              <a:spcAft>
+                <a:spcPts val="0"/>
+              </a:spcAft>
+            </a:pPr>
+            <a:r>
+              <a:rPr sz="1450" b="1" i="0">
+                <a:solidFill>
+                  <a:srgbClr val="16213E"/>
+                </a:solidFill>
+                <a:latin typeface="Arial"/>
+              </a:rPr>
+              <a:t>The metro average hides a split market</a:t>
+            </a:r>
+          </a:p>
+        </p:txBody>
+      </p:sp>
+      <p:sp>
+        <p:nvSpPr>
+          <p:cNvPr id="26" name="TextBox 25"/>
+          <p:cNvSpPr txBox="1"/>
+          <p:nvPr/>
+        </p:nvSpPr>
+        <p:spPr>
+          <a:xfrm>
+            <a:off x="1051560" y="4270248"/>
+            <a:ext cx="7589520" cy="548640"/>
+          </a:xfrm>
+          <a:prstGeom prst="rect">
+            <a:avLst/>
+          </a:prstGeom>
+          <a:noFill/>
+          <a:ln/>
+        </p:spPr>
+        <p:txBody>
+          <a:bodyPr wrap="square" anchor="t" lIns="25400" rIns="25400" tIns="25400" bIns="25400">
+            <a:spAutoFit/>
+          </a:bodyPr>
+          <a:lstStyle/>
+          <a:p>
+            <a:pPr algn="l">
+              <a:lnSpc>
+                <a:spcPct val="102000"/>
+              </a:lnSpc>
+              <a:spcBef>
+                <a:spcPts val="0"/>
+              </a:spcBef>
+              <a:spcAft>
+                <a:spcPts val="0"/>
+              </a:spcAft>
+            </a:pPr>
+            <a:r>
+              <a:rPr sz="1150" b="0" i="0">
+                <a:solidFill>
+                  <a:srgbClr val="3D4A5C"/>
+                </a:solidFill>
+                <a:latin typeface="Arial"/>
+              </a:rPr>
+              <a:t>Separate models per neighborhood beat one shared factor (2.8% vs 4.1% error).</a:t>
             </a:r>
           </a:p>
         </p:txBody>
@@ -6768,7 +6595,7 @@
                 </a:solidFill>
                 <a:latin typeface="Arial"/>
               </a:rPr>
-              <a:t>We tested 11 models two ways, so no model could win by luck</a:t>
+              <a:t>We tested 13 models two ways, so no model could win by luck</a:t>
             </a:r>
           </a:p>
         </p:txBody>
@@ -7188,7 +7015,7 @@
         </p:nvSpPr>
         <p:spPr>
           <a:xfrm>
-            <a:off x="365760" y="2520696"/>
+            <a:off x="365760" y="2465832"/>
             <a:ext cx="2560319" cy="170688"/>
           </a:xfrm>
           <a:prstGeom prst="rect">
@@ -7234,7 +7061,7 @@
         </p:nvSpPr>
         <p:spPr>
           <a:xfrm>
-            <a:off x="365760" y="2691384"/>
+            <a:off x="365760" y="2636520"/>
             <a:ext cx="2560319" cy="149352"/>
           </a:xfrm>
           <a:prstGeom prst="rect">
@@ -7280,7 +7107,7 @@
         </p:nvSpPr>
         <p:spPr>
           <a:xfrm>
-            <a:off x="365760" y="2968752"/>
+            <a:off x="365760" y="2859024"/>
             <a:ext cx="2560319" cy="170688"/>
           </a:xfrm>
           <a:prstGeom prst="rect">
@@ -7326,7 +7153,7 @@
         </p:nvSpPr>
         <p:spPr>
           <a:xfrm>
-            <a:off x="365760" y="3139440"/>
+            <a:off x="365760" y="3029712"/>
             <a:ext cx="2560319" cy="149352"/>
           </a:xfrm>
           <a:prstGeom prst="rect">
@@ -7405,7 +7232,7 @@
                 </a:solidFill>
                 <a:latin typeface="Arial"/>
               </a:rPr>
-              <a:t>11 MODELS</a:t>
+              <a:t>13 MODELS</a:t>
             </a:r>
           </a:p>
         </p:txBody>
@@ -7540,7 +7367,7 @@
         </p:nvSpPr>
         <p:spPr>
           <a:xfrm>
-            <a:off x="3291839" y="2520696"/>
+            <a:off x="3291839" y="2465832"/>
             <a:ext cx="2560319" cy="170688"/>
           </a:xfrm>
           <a:prstGeom prst="rect">
@@ -7586,7 +7413,7 @@
         </p:nvSpPr>
         <p:spPr>
           <a:xfrm>
-            <a:off x="3291839" y="2691384"/>
+            <a:off x="3291839" y="2636520"/>
             <a:ext cx="2560319" cy="149352"/>
           </a:xfrm>
           <a:prstGeom prst="rect">
@@ -7619,7 +7446,7 @@
                 </a:solidFill>
                 <a:latin typeface="Arial"/>
               </a:rPr>
-              <a:t>ARIMA · Holt · Prophet</a:t>
+              <a:t>ARIMA · Holt · Prophet ×2</a:t>
             </a:r>
           </a:p>
         </p:txBody>
@@ -7632,7 +7459,7 @@
         </p:nvSpPr>
         <p:spPr>
           <a:xfrm>
-            <a:off x="3291839" y="2968752"/>
+            <a:off x="3291839" y="2859024"/>
             <a:ext cx="2560319" cy="170688"/>
           </a:xfrm>
           <a:prstGeom prst="rect">
@@ -7665,7 +7492,7 @@
                 </a:solidFill>
                 <a:latin typeface="Arial"/>
               </a:rPr>
-              <a:t>Machine / deep learning</a:t>
+              <a:t>ML, deep learning, AI</a:t>
             </a:r>
           </a:p>
         </p:txBody>
@@ -7678,8 +7505,8 @@
         </p:nvSpPr>
         <p:spPr>
           <a:xfrm>
-            <a:off x="3291839" y="3139440"/>
-            <a:ext cx="2560319" cy="149352"/>
+            <a:off x="3291839" y="3029712"/>
+            <a:ext cx="2560319" cy="298704"/>
           </a:xfrm>
           <a:prstGeom prst="rect">
             <a:avLst/>
@@ -7711,7 +7538,7 @@
                 </a:solidFill>
                 <a:latin typeface="Arial"/>
               </a:rPr>
-              <a:t>XGBoost · LightGBM · LSTM · GRU</a:t>
+              <a:t>XGBoost · LightGBM · LSTM · GRU · Chronos</a:t>
             </a:r>
           </a:p>
         </p:txBody>
@@ -7724,7 +7551,7 @@
         </p:nvSpPr>
         <p:spPr>
           <a:xfrm>
-            <a:off x="3291839" y="3416808"/>
+            <a:off x="3291839" y="3401568"/>
             <a:ext cx="2560319" cy="170688"/>
           </a:xfrm>
           <a:prstGeom prst="rect">
@@ -7770,7 +7597,7 @@
         </p:nvSpPr>
         <p:spPr>
           <a:xfrm>
-            <a:off x="3291839" y="3587496"/>
+            <a:off x="3291839" y="3572256"/>
             <a:ext cx="2560319" cy="149352"/>
           </a:xfrm>
           <a:prstGeom prst="rect">
@@ -7984,7 +7811,7 @@
         </p:nvSpPr>
         <p:spPr>
           <a:xfrm>
-            <a:off x="6217919" y="2670048"/>
+            <a:off x="6217919" y="2615184"/>
             <a:ext cx="2560319" cy="170688"/>
           </a:xfrm>
           <a:prstGeom prst="rect">
@@ -8030,7 +7857,7 @@
         </p:nvSpPr>
         <p:spPr>
           <a:xfrm>
-            <a:off x="6217919" y="2840736"/>
+            <a:off x="6217919" y="2785872"/>
             <a:ext cx="2560319" cy="298704"/>
           </a:xfrm>
           <a:prstGeom prst="rect">
@@ -8577,7 +8404,7 @@
                 </a:solidFill>
                 <a:latin typeface="Arial"/>
               </a:rPr>
-              <a:t>One test window crowned LightGBM; 18 windows ranked it eighth</a:t>
+              <a:t>One test window crowned LightGBM; 18 windows ranked it ninth</a:t>
             </a:r>
           </a:p>
         </p:txBody>
@@ -8720,8 +8547,8 @@
         </p:blipFill>
         <p:spPr>
           <a:xfrm>
-            <a:off x="855016" y="1542288"/>
-            <a:ext cx="4599327" cy="3052571"/>
+            <a:off x="1427162" y="1542288"/>
+            <a:ext cx="3455035" cy="3052571"/>
           </a:xfrm>
           <a:prstGeom prst="rect">
             <a:avLst/>
@@ -8815,7 +8642,7 @@
                 </a:solidFill>
                 <a:latin typeface="Arial"/>
               </a:rPr>
-              <a:t>1st → 8th</a:t>
+              <a:t>1st → 9th</a:t>
             </a:r>
           </a:p>
         </p:txBody>
@@ -8861,7 +8688,7 @@
                 </a:solidFill>
                 <a:latin typeface="Arial"/>
               </a:rPr>
-              <a:t>LightGBM won the single 64-month test (2.2% error) but ranked 8th across 18 rolling tests: it got lucky in the one window that counted.</a:t>
+              <a:t>LightGBM won the single 64-month test (2.2% error) but ranked 9th across 18 rolling tests: it got lucky in the one window that counted.</a:t>
             </a:r>
           </a:p>
         </p:txBody>
@@ -8979,7 +8806,7 @@
                 </a:solidFill>
                 <a:latin typeface="Arial"/>
               </a:rPr>
-              <a:t>Mortgage rates help at 12 months, but nothing beats naive drift a year out</a:t>
+              <a:t>A 1-point rate rise means LA values about 9% lower two years later</a:t>
             </a:r>
           </a:p>
         </p:txBody>
@@ -9106,24 +8933,30 @@
           </a:p>
         </p:txBody>
       </p:sp>
-      <p:graphicFrame>
-        <p:nvGraphicFramePr>
-          <p:cNvPr id="7" name="Chart 6"/>
-          <p:cNvGraphicFramePr>
-            <a:graphicFrameLocks noGrp="1"/>
-          </p:cNvGraphicFramePr>
-          <p:nvPr/>
-        </p:nvGraphicFramePr>
-        <p:xfrm>
-          <a:off x="457200" y="1569720"/>
-          <a:ext cx="5394960" cy="2979419"/>
-        </p:xfrm>
-        <a:graphic>
-          <a:graphicData uri="http://schemas.openxmlformats.org/drawingml/2006/chart">
-            <c:chart xmlns:c="http://schemas.openxmlformats.org/drawingml/2006/chart" r:id="rId2"/>
-          </a:graphicData>
-        </a:graphic>
-      </p:graphicFrame>
+      <p:pic>
+        <p:nvPicPr>
+          <p:cNvPr id="7" name="Picture 6" descr="Impulse response of LA home values to a 1-point mortgage rate rise over 36 months, with 90% band" title="Impulse response of LA home values to a 1-point mortgage rate rise over 36 months, with 90% band"/>
+          <p:cNvPicPr>
+            <a:picLocks noChangeAspect="1"/>
+          </p:cNvPicPr>
+          <p:nvPr/>
+        </p:nvPicPr>
+        <p:blipFill>
+          <a:blip r:embed="rId2"/>
+          <a:stretch>
+            <a:fillRect/>
+          </a:stretch>
+        </p:blipFill>
+        <p:spPr>
+          <a:xfrm>
+            <a:off x="411480" y="1919258"/>
+            <a:ext cx="5486400" cy="2280342"/>
+          </a:xfrm>
+          <a:prstGeom prst="rect">
+            <a:avLst/>
+          </a:prstGeom>
+        </p:spPr>
+      </p:pic>
       <p:sp>
         <p:nvSpPr>
           <p:cNvPr id="8" name="TextBox 7"/>
@@ -9132,8 +8965,8 @@
         </p:nvSpPr>
         <p:spPr>
           <a:xfrm>
-            <a:off x="6126480" y="1661160"/>
-            <a:ext cx="2606040" cy="274320"/>
+            <a:off x="6172200" y="1661160"/>
+            <a:ext cx="2560320" cy="274320"/>
           </a:xfrm>
           <a:prstGeom prst="rect">
             <a:avLst/>
@@ -9178,8 +9011,8 @@
         </p:nvSpPr>
         <p:spPr>
           <a:xfrm>
-            <a:off x="6126480" y="1972056"/>
-            <a:ext cx="2606040" cy="822960"/>
+            <a:off x="6172200" y="1972056"/>
+            <a:ext cx="2560320" cy="822960"/>
           </a:xfrm>
           <a:prstGeom prst="rect">
             <a:avLst/>
@@ -9211,7 +9044,7 @@
                 </a:solidFill>
                 <a:latin typeface="Arial"/>
               </a:rPr>
-              <a:t>24 months</a:t>
+              <a:t>−9.2%</a:t>
             </a:r>
           </a:p>
         </p:txBody>
@@ -9224,8 +9057,8 @@
         </p:nvSpPr>
         <p:spPr>
           <a:xfrm>
-            <a:off x="6126480" y="2849880"/>
-            <a:ext cx="2606040" cy="1536191"/>
+            <a:off x="6172200" y="2849880"/>
+            <a:ext cx="2560320" cy="1024127"/>
           </a:xfrm>
           <a:prstGeom prst="rect">
             <a:avLst/>
@@ -9257,7 +9090,7 @@
                 </a:solidFill>
                 <a:latin typeface="Arial"/>
               </a:rPr>
-              <a:t>Rate rises hit LA values about two years later (coefficient -0.063, p = 0.16: real but weak). At 12 months ARIMAX is 4.98% off vs 5.37% for ARIMA, but naive drift scores 4.92%.</a:t>
+              <a:t>after 24 months (−4.5% after 12). Rates help predict prices, not the reverse (Granger p = 0.05 vs 0.51).</a:t>
             </a:r>
           </a:p>
         </p:txBody>
@@ -9627,7 +9460,7 @@
         <p:spPr>
           <a:xfrm>
             <a:off x="6172200" y="2849880"/>
-            <a:ext cx="2560320" cy="1024127"/>
+            <a:ext cx="2560320" cy="1536191"/>
           </a:xfrm>
           <a:prstGeom prst="rect">
             <a:avLst/>
@@ -9659,7 +9492,7 @@
                 </a:solidFill>
                 <a:latin typeface="Arial"/>
               </a:rPr>
-              <a:t>neighborhoods are still below their 2022 peak. Median today vs that peak: LA County +1.2%, Orange County +15.3%.</a:t>
+              <a:t>neighborhoods are still below their 2022 peak. In LA County, doubling the price meant a 1.2-point deeper drop (t = -7.7); in Orange County the effect reverses.</a:t>
             </a:r>
           </a:p>
         </p:txBody>

</xml_diff>

<commit_message>
Add LLM forecast test, payroll jobs, and AI-tools section
- Claude Opus 5.5, GPT-5.5 and Gemini 3.1 Pro forecast at the 18 rolling
  origins with named, blind and masked prompts; masked scores match ARIMAX
  at best, showing the unmasked wins come from memorized history
- LA and Orange County payroll jobs (BLS): ARIMAX + jobs model, jobs in the
  VAR with impulse response and a pre-2020 robustness check, county view
- Report (20 pages), slides (new AI-forecast slide, live map demo) and
  README updated; LLM prompts, raw answers and scripts included

Co-Authored-By: Claude Opus 5.5 <noreply@anthropic.com>
Claude-Session: https://claude.ai/code/session_01MGxrqNkCGgpin2owaUrbi7
</commit_message>
<xml_diff>
--- a/slides/LA_home_values_slides.pptx
+++ b/slides/LA_home_values_slides.pptx
@@ -249,15 +249,23 @@
             <c:idx val="12"/>
             <c:spPr>
               <a:solidFill>
+                <a:srgbClr val="B8BECC"/>
+              </a:solidFill>
+            </c:spPr>
+          </c:dPt>
+          <c:dPt>
+            <c:idx val="13"/>
+            <c:spPr>
+              <a:solidFill>
                 <a:srgbClr val="1F6F8B"/>
               </a:solidFill>
             </c:spPr>
           </c:dPt>
           <c:cat>
             <c:strRef>
-              <c:f>Sheet1!$A$2:$A$14</c:f>
+              <c:f>Sheet1!$A$2:$A$15</c:f>
               <c:strCache>
-                <c:ptCount val="13"/>
+                <c:ptCount val="14"/>
                 <c:pt idx="0">
                   <c:v>Prophet</c:v>
                 </c:pt>
@@ -292,9 +300,12 @@
                   <c:v>VAR (growth + rate)</c:v>
                 </c:pt>
                 <c:pt idx="11">
+                  <c:v>ARIMAX + jobs</c:v>
+                </c:pt>
+                <c:pt idx="12">
                   <c:v>ARIMA</c:v>
                 </c:pt>
-                <c:pt idx="12">
+                <c:pt idx="13">
                   <c:v>ARIMAX</c:v>
                 </c:pt>
               </c:strCache>
@@ -302,10 +313,10 @@
           </c:cat>
           <c:val>
             <c:numRef>
-              <c:f>Sheet1!$B$2:$B$14</c:f>
+              <c:f>Sheet1!$B$2:$B$15</c:f>
               <c:numCache>
                 <c:formatCode>General</c:formatCode>
-                <c:ptCount val="13"/>
+                <c:ptCount val="14"/>
                 <c:pt idx="0">
                   <c:v>6.89</c:v>
                 </c:pt>
@@ -340,9 +351,12 @@
                   <c:v>2.93</c:v>
                 </c:pt>
                 <c:pt idx="11">
+                  <c:v>2.81</c:v>
+                </c:pt>
+                <c:pt idx="12">
                   <c:v>2.77</c:v>
                 </c:pt>
-                <c:pt idx="12">
+                <c:pt idx="13">
                   <c:v>2.67</c:v>
                 </c:pt>
               </c:numCache>
@@ -926,7 +940,7 @@
           <a:lstStyle/>
           <a:p>
             <a:r>
-              <a:t>Five takeaways. First, for a smooth monthly housing index, simple models beat complex ones, including the Chronos foundation model. Second, how you test decides who wins: one blind window would have picked the wrong model. Third, mortgage rates matter, but slowly: a one-point rise lowers values about nine percent over two years. Fourth, use the long history: training on all data since 2000 forecast better than starting in 2008, 2012 or 2016, even with the breaks in between. And fifth, the metro average hides a split market. One common factor drives most of the movement across neighborhoods, but each neighborhood's own trend is what you need to forecast it. If you are buying or lending in LA, look at the neighborhood, not the metro number. Thank you.</a:t>
+              <a:t>Five takeaways. First, for a smooth monthly housing index, simple models beat complex ones, including the Chronos foundation model. Second, how you test decides who wins: one blind window would have picked the wrong model. Third, and the same lesson for AI: you cannot backtest a chat LLM on years it has already read about. Fourth, mortgage rates matter, but slowly: a one-point rise lowers values about nine percent over two years, and local jobs add nothing on top. And fifth, the metro average hides a split market. One common factor drives most of the movement across neighborhoods, but each neighborhood's own trend is what you need to forecast it. If you are buying or lending in LA, look at the neighborhood, not the metro number. Thank you.</a:t>
             </a:r>
           </a:p>
         </p:txBody>
@@ -1066,7 +1080,7 @@
           <a:lstStyle/>
           <a:p>
             <a:r>
-              <a:t>Here is the setup. Three data sources: the Zillow index for the metro, 499 neighborhoods from Zillow's neighborhood file, and the 30-year mortgage rate from FRED. We compared thirteen models in four families, from a naive drift baseline to LSTM and GRU networks and Amazon's Chronos foundation model, plus three models that use outside information. And we scored them two ways. A blind 80/20 split, like most projects use, and a rolling-origin test where we refit every three months and forecast twelve months ahead, eighteen times. One warning: Zillow smooths this index, so next month is almost the same as this month and every decent model is about 0.1 percent off one month ahead. That tells us nothing, so we judge models at six to twelve months.</a:t>
+              <a:t>Here is the setup. Our data: the Zillow index for the metro, 499 neighborhoods from Zillow's neighborhood file, the 30-year mortgage rate, and payroll jobs for LA and Orange County. We compared fourteen models in four families, from a naive drift baseline to LSTM and GRU networks and Amazon's Chronos foundation model, plus four models that use outside information. On top of those we asked three chat LLMs, Claude, GPT and Gemini, for forecasts at the same dates. And we scored them two ways. A blind 80/20 split, like most projects use, and a rolling-origin test where we refit every three months and forecast twelve months ahead, eighteen times. One warning: Zillow smooths this index, so next month is almost the same as this month and every decent model is about 0.1 percent off one month ahead. That tells us nothing, so we judge models at six to twelve months.</a:t>
             </a:r>
           </a:p>
         </p:txBody>
@@ -1136,7 +1150,7 @@
           <a:lstStyle/>
           <a:p>
             <a:r>
-              <a:t>This is the main result, the rolling test. ARIMAX, which is ARIMA plus mortgage rates, had the lowest average error at 2.67 percent, with plain ARIMA right behind at 2.77. The neural networks landed in the middle, the tree models near the bottom, and Prophet last at almost 7 percent, mostly because it fits a smooth trend and does not start from the latest value. Our read: with about 250 monthly observations of a smooth index, there just is not much nonlinear structure for machine learning to find.</a:t>
+              <a:t>This is the main result, the rolling test. ARIMAX, which is ARIMA plus mortgage rates, had the lowest average error at 2.67 percent, with plain ARIMA right behind at 2.77. Adding payroll jobs did not help: ARIMAX with jobs came third at 2.81. The neural networks landed in the middle, the tree models near the bottom, and Prophet last at almost 7 percent, mostly because it fits a smooth trend and does not start from the latest value. Our read: with about 250 monthly observations of a smooth index, there just is not much nonlinear structure for machine learning to find.</a:t>
             </a:r>
           </a:p>
         </p:txBody>
@@ -1206,7 +1220,7 @@
           <a:lstStyle/>
           <a:p>
             <a:r>
-              <a:t>Here is why the test design matters. In the single blind test, LightGBM won with a 2.2 percent error. It was the only model whose forecast bent, and it happened to bend in the right years. Across eighteen rolling tests it ranked ninth. Meanwhile VAR, LSTM and XGBoost took the 2021 boom and kept going, ending 25 to 35 percent too high. The lesson for us: one test window can crown the wrong model, so we trust the rolling test.</a:t>
+              <a:t>Here is why the test design matters. In the single blind test, LightGBM won with a 2.2 percent error. It was the only model whose forecast bent, and it happened to bend in the right years. Across eighteen rolling tests it ranked tenth. Meanwhile VAR, LSTM and XGBoost took the 2021 boom and kept going, ending 25 to 35 percent too high. The lesson for us: one test window can crown the wrong model, so we trust the rolling test.</a:t>
             </a:r>
           </a:p>
         </p:txBody>
@@ -1276,7 +1290,7 @@
           <a:lstStyle/>
           <a:p>
             <a:r>
-              <a:t>How much do mortgage rates matter? We used the VAR from class and traced an impulse response: what happens to LA home values after a one-point rise in the mortgage rate. Values barely move for the first few months, then fall steadily: about 4.5 percent lower after a year and about 9 percent lower after two, and the 90 percent band stays below zero from about a year on. A Granger causality test agrees on the direction: past rates help predict home values, but past home values do not help predict rates. The effect is slow, which is why it only helps our forecasts at the 12-month horizon, and even there a simple naive drift is about as good.</a:t>
+              <a:t>We also asked three chat LLMs, Claude, GPT and Gemini, to forecast at the same eighteen dates, with only the data up to each date and no code. At first they looked brilliant: Claude and GPT averaged about 1.6 percent error, far better than ARIMAX. But every one of these dates is before the models' training cutoff, so they may simply remember what LA prices did next. So we hid the clues: no place, no dates, no mortgage rate, only the last ten years of a rescaled index. Claude's error went from 1.6 to 2.7 percent, GPT's to 2.7, and Gemini's to 3.0. At twelve months ahead the drop is even bigger. Once they cannot recognize the period, the best LLMs forecast about as well as ARIMAX, not better. The lesson: you cannot backtest an LLM on years it has already read about.</a:t>
             </a:r>
           </a:p>
         </p:txBody>
@@ -1346,7 +1360,7 @@
           <a:lstStyle/>
           <a:p>
             <a:r>
-              <a:t>Now below the metro level. Each dot is a neighborhood. Across the bottom is its home value before the shock, and up the side is how far it fell from the 2022 peak to the 2023 low. In LA County the expensive neighborhoods fell the most, which makes sense: a buyer of a two-million-dollar home feels a jump from 3 to 7 percent much more in dollars. Orange County, in orange, held up better. Four years later many neighborhoods are still below their 2022 peak, mostly in LA County.</a:t>
+              <a:t>How much do mortgage rates matter? We used the VAR from class and traced an impulse response: what happens to LA home values after a one-point rise in the mortgage rate. Values barely move for the first few months, then fall steadily: about 4.5 percent lower after a year and about 9 percent lower after two, and the 90 percent band stays below zero from about a year on. A Granger causality test agrees on the direction: past rates help predict home values, but past home values do not help predict rates. The effect is slow, which is why it only helps our forecasts at the 12-month horizon, and even there a simple naive drift is about as good. We also added local payroll jobs. They looked like a leading signal too, but only because of the 2020 job crash and rebound; using data before 2020, jobs predict nothing.</a:t>
             </a:r>
           </a:p>
         </p:txBody>
@@ -1416,7 +1430,7 @@
           <a:lstStyle/>
           <a:p>
             <a:r>
-              <a:t>Which neighborhoods are going up and down right now? Over the last twelve months, 220 LA-metro neighborhoods rose more than 2 percent, 216 were flat, and 60 fell more than 2 percent. Blue on the map is rising and red is falling. The pattern is a reversal of 2023: the coastal, high-end areas that fell hardest are now leading. The weakest areas are central LA, places like MacArthur Park, Koreatown, Downtown and Westlake. Pacific Palisades also fell, but that reflects the January 2025 fire rather than the market.</a:t>
+              <a:t>Now below the metro level. Over the last twelve months, 220 LA-metro neighborhoods rose more than 2 percent, 216 were flat, and 60 fell. Let me show you on our live map. [Switch to the browser.] Each dot is a neighborhood; blue is rising, red is falling. Expensive coastal pockets like North of Montana in Santa Monica, Point Dume in Malibu and Corona del Mar are blue: the high-end areas that fell hardest in 2023 are leading now. Central LA, Koreatown, Westlake and Downtown, is red. [Click one neighborhood.] Each one shows its value, its change, and our 12-month forecast. Pacific Palisades is down because of the January 2025 fire, not the market. [Back to the slides.] After the 2022 rate jump, pricier LA County neighborhoods fell the most, and 152 of 496 are still below their 2022 peak.</a:t>
             </a:r>
           </a:p>
         </p:txBody>
@@ -5041,7 +5055,7 @@
                 </a:solidFill>
                 <a:latin typeface="Arial"/>
               </a:rPr>
-              <a:t>MGMTMSA 437 · Forecasting LA Home Values · Data: Zillow ZHVI, FRED MORTGAGE30US</a:t>
+              <a:t>MGMTMSA 437 · Forecasting LA Home Values · Data: Zillow ZHVI, FRED, BLS</a:t>
             </a:r>
           </a:p>
         </p:txBody>
@@ -5427,7 +5441,7 @@
                 </a:solidFill>
                 <a:latin typeface="Arial"/>
               </a:rPr>
-              <a:t>One blind window ranked LightGBM 1st; 18 rolling windows, 9th.</a:t>
+              <a:t>One blind window ranked LightGBM 1st; 18 rolling windows, 10th.</a:t>
             </a:r>
           </a:p>
         </p:txBody>
@@ -5551,7 +5565,7 @@
                 </a:solidFill>
                 <a:latin typeface="Arial"/>
               </a:rPr>
-              <a:t>Mortgage rates matter, slowly</a:t>
+              <a:t>An LLM can't be backtested on years it has read about</a:t>
             </a:r>
           </a:p>
         </p:txBody>
@@ -5597,7 +5611,7 @@
                 </a:solidFill>
                 <a:latin typeface="Arial"/>
               </a:rPr>
-              <a:t>A 1-point rise lowers values about 9% over two years.</a:t>
+              <a:t>Claude, GPT and Gemini beat every model until we hid the dates; then they matched ARIMAX at best.</a:t>
             </a:r>
           </a:p>
         </p:txBody>
@@ -5721,7 +5735,7 @@
                 </a:solidFill>
                 <a:latin typeface="Arial"/>
               </a:rPr>
-              <a:t>Use the long history</a:t>
+              <a:t>Mortgage rates matter, slowly; local jobs don't add</a:t>
             </a:r>
           </a:p>
         </p:txBody>
@@ -5767,7 +5781,7 @@
                 </a:solidFill>
                 <a:latin typeface="Arial"/>
               </a:rPr>
-              <a:t>Training from 2000 beat starting in 2008, 2012 or 2016.</a:t>
+              <a:t>A 1-point rise lowers values about 9% over two years.</a:t>
             </a:r>
           </a:p>
         </p:txBody>
@@ -6131,7 +6145,7 @@
                 </a:solidFill>
                 <a:latin typeface="Arial"/>
               </a:rPr>
-              <a:t>MGMTMSA 437 · Forecasting LA Home Values · Data: Zillow ZHVI, FRED MORTGAGE30US</a:t>
+              <a:t>MGMTMSA 437 · Forecasting LA Home Values · Data: Zillow ZHVI, FRED, BLS</a:t>
             </a:r>
           </a:p>
         </p:txBody>
@@ -6595,7 +6609,7 @@
                 </a:solidFill>
                 <a:latin typeface="Arial"/>
               </a:rPr>
-              <a:t>We tested 13 models two ways, so no model could win by luck</a:t>
+              <a:t>We tested 14 models two ways, so no model could win by luck</a:t>
             </a:r>
           </a:p>
         </p:txBody>
@@ -6671,7 +6685,7 @@
                 </a:solidFill>
                 <a:latin typeface="Arial"/>
               </a:rPr>
-              <a:t>MGMTMSA 437 · Forecasting LA Home Values · Data: Zillow ZHVI, FRED MORTGAGE30US</a:t>
+              <a:t>MGMTMSA 437 · Forecasting LA Home Values · Data: Zillow ZHVI, FRED, BLS</a:t>
             </a:r>
           </a:p>
         </p:txBody>
@@ -7140,7 +7154,7 @@
                 </a:solidFill>
                 <a:latin typeface="Arial"/>
               </a:rPr>
-              <a:t>30-year mortgage rate</a:t>
+              <a:t>Mortgage rate and payroll jobs</a:t>
             </a:r>
           </a:p>
         </p:txBody>
@@ -7186,7 +7200,7 @@
                 </a:solidFill>
                 <a:latin typeface="Arial"/>
               </a:rPr>
-              <a:t>FRED, monthly</a:t>
+              <a:t>FRED and BLS, LA and Orange County</a:t>
             </a:r>
           </a:p>
         </p:txBody>
@@ -7232,7 +7246,7 @@
                 </a:solidFill>
                 <a:latin typeface="Arial"/>
               </a:rPr>
-              <a:t>13 MODELS</a:t>
+              <a:t>14 MODELS + 3 LLMS</a:t>
             </a:r>
           </a:p>
         </p:txBody>
@@ -7308,7 +7322,7 @@
                 </a:solidFill>
                 <a:latin typeface="Arial"/>
               </a:rPr>
-              <a:t>Baselines</a:t>
+              <a:t>Baseline and classical</a:t>
             </a:r>
           </a:p>
         </p:txBody>
@@ -7354,7 +7368,7 @@
                 </a:solidFill>
                 <a:latin typeface="Arial"/>
               </a:rPr>
-              <a:t>Naive drift</a:t>
+              <a:t>Naive drift · ARIMA · Holt · Prophet ×2</a:t>
             </a:r>
           </a:p>
         </p:txBody>
@@ -7400,7 +7414,7 @@
                 </a:solidFill>
                 <a:latin typeface="Arial"/>
               </a:rPr>
-              <a:t>Classical</a:t>
+              <a:t>ML, deep learning, AI</a:t>
             </a:r>
           </a:p>
         </p:txBody>
@@ -7414,7 +7428,7 @@
         <p:spPr>
           <a:xfrm>
             <a:off x="3291839" y="2636520"/>
-            <a:ext cx="2560319" cy="149352"/>
+            <a:ext cx="2560319" cy="298704"/>
           </a:xfrm>
           <a:prstGeom prst="rect">
             <a:avLst/>
@@ -7446,7 +7460,7 @@
                 </a:solidFill>
                 <a:latin typeface="Arial"/>
               </a:rPr>
-              <a:t>ARIMA · Holt · Prophet ×2</a:t>
+              <a:t>XGBoost · LightGBM · LSTM · GRU · Chronos</a:t>
             </a:r>
           </a:p>
         </p:txBody>
@@ -7459,7 +7473,7 @@
         </p:nvSpPr>
         <p:spPr>
           <a:xfrm>
-            <a:off x="3291839" y="2859024"/>
+            <a:off x="3291839" y="3008376"/>
             <a:ext cx="2560319" cy="170688"/>
           </a:xfrm>
           <a:prstGeom prst="rect">
@@ -7492,7 +7506,7 @@
                 </a:solidFill>
                 <a:latin typeface="Arial"/>
               </a:rPr>
-              <a:t>ML, deep learning, AI</a:t>
+              <a:t>Outside information</a:t>
             </a:r>
           </a:p>
         </p:txBody>
@@ -7505,8 +7519,8 @@
         </p:nvSpPr>
         <p:spPr>
           <a:xfrm>
-            <a:off x="3291839" y="3029712"/>
-            <a:ext cx="2560319" cy="298704"/>
+            <a:off x="3291839" y="3179064"/>
+            <a:ext cx="2560319" cy="149352"/>
           </a:xfrm>
           <a:prstGeom prst="rect">
             <a:avLst/>
@@ -7538,7 +7552,7 @@
                 </a:solidFill>
                 <a:latin typeface="Arial"/>
               </a:rPr>
-              <a:t>XGBoost · LightGBM · LSTM · GRU · Chronos</a:t>
+              <a:t>ARIMAX ×2 · VAR · factor VAR</a:t>
             </a:r>
           </a:p>
         </p:txBody>
@@ -7584,7 +7598,7 @@
                 </a:solidFill>
                 <a:latin typeface="Arial"/>
               </a:rPr>
-              <a:t>Outside information</a:t>
+              <a:t>Plus 3 chat LLMs</a:t>
             </a:r>
           </a:p>
         </p:txBody>
@@ -7630,7 +7644,7 @@
                 </a:solidFill>
                 <a:latin typeface="Arial"/>
               </a:rPr>
-              <a:t>ARIMAX (rates) · VAR · factor VAR</a:t>
+              <a:t>Claude · GPT · Gemini</a:t>
             </a:r>
           </a:p>
         </p:txBody>
@@ -8084,7 +8098,7 @@
                 </a:solidFill>
                 <a:latin typeface="Arial"/>
               </a:rPr>
-              <a:t>MGMTMSA 437 · Forecasting LA Home Values · Data: Zillow ZHVI, FRED MORTGAGE30US</a:t>
+              <a:t>MGMTMSA 437 · Forecasting LA Home Values · Data: Zillow ZHVI, FRED, BLS</a:t>
             </a:r>
           </a:p>
         </p:txBody>
@@ -8404,7 +8418,7 @@
                 </a:solidFill>
                 <a:latin typeface="Arial"/>
               </a:rPr>
-              <a:t>One test window crowned LightGBM; 18 windows ranked it ninth</a:t>
+              <a:t>One test window crowned LightGBM; 18 windows ranked it tenth</a:t>
             </a:r>
           </a:p>
         </p:txBody>
@@ -8480,7 +8494,7 @@
                 </a:solidFill>
                 <a:latin typeface="Arial"/>
               </a:rPr>
-              <a:t>MGMTMSA 437 · Forecasting LA Home Values · Data: Zillow ZHVI, FRED MORTGAGE30US</a:t>
+              <a:t>MGMTMSA 437 · Forecasting LA Home Values · Data: Zillow ZHVI, FRED, BLS</a:t>
             </a:r>
           </a:p>
         </p:txBody>
@@ -8642,7 +8656,7 @@
                 </a:solidFill>
                 <a:latin typeface="Arial"/>
               </a:rPr>
-              <a:t>1st → 9th</a:t>
+              <a:t>1st → 10th</a:t>
             </a:r>
           </a:p>
         </p:txBody>
@@ -8688,7 +8702,7 @@
                 </a:solidFill>
                 <a:latin typeface="Arial"/>
               </a:rPr>
-              <a:t>LightGBM won the single 64-month test (2.2% error) but ranked 9th across 18 rolling tests: it got lucky in the one window that counted.</a:t>
+              <a:t>LightGBM won the single 64-month test (2.2% error) but ranked 10th across 18 rolling tests: it got lucky in the one window that counted.</a:t>
             </a:r>
           </a:p>
         </p:txBody>
@@ -8760,7 +8774,7 @@
                 </a:solidFill>
                 <a:latin typeface="Arial"/>
               </a:rPr>
-              <a:t>RESULT 3 · MORTGAGE RATES</a:t>
+              <a:t>RESULT 3 · AI FORECASTS</a:t>
             </a:r>
           </a:p>
         </p:txBody>
@@ -8806,7 +8820,7 @@
                 </a:solidFill>
                 <a:latin typeface="Arial"/>
               </a:rPr>
-              <a:t>A 1-point rate rise means LA values about 9% lower two years later</a:t>
+              <a:t>Chat LLMs beat every model, until we hid which years they were forecasting</a:t>
             </a:r>
           </a:p>
         </p:txBody>
@@ -8882,7 +8896,7 @@
                 </a:solidFill>
                 <a:latin typeface="Arial"/>
               </a:rPr>
-              <a:t>MGMTMSA 437 · Forecasting LA Home Values · Data: Zillow ZHVI, FRED MORTGAGE30US</a:t>
+              <a:t>MGMTMSA 437 · Forecasting LA Home Values · Data: Zillow ZHVI, FRED, BLS</a:t>
             </a:r>
           </a:p>
         </p:txBody>
@@ -8935,7 +8949,7 @@
       </p:sp>
       <p:pic>
         <p:nvPicPr>
-          <p:cNvPr id="7" name="Picture 6" descr="Impulse response of LA home values to a 1-point mortgage rate rise over 36 months, with 90% band" title="Impulse response of LA home values to a 1-point mortgage rate rise over 36 months, with 90% band"/>
+          <p:cNvPr id="7" name="Picture 6" descr="Average and 12-month error of Claude, GPT and Gemini under named, blind and masked prompts, against ARIMAX and naive drift" title="Average and 12-month error of Claude, GPT and Gemini under named, blind and masked prompts, against ARIMAX and naive dri"/>
           <p:cNvPicPr>
             <a:picLocks noChangeAspect="1"/>
           </p:cNvPicPr>
@@ -8949,8 +8963,8 @@
         </p:blipFill>
         <p:spPr>
           <a:xfrm>
-            <a:off x="411480" y="1919258"/>
-            <a:ext cx="5486400" cy="2280342"/>
+            <a:off x="411480" y="2011185"/>
+            <a:ext cx="5577840" cy="2096489"/>
           </a:xfrm>
           <a:prstGeom prst="rect">
             <a:avLst/>
@@ -8965,8 +8979,8 @@
         </p:nvSpPr>
         <p:spPr>
           <a:xfrm>
-            <a:off x="6172200" y="1661160"/>
-            <a:ext cx="2560320" cy="274320"/>
+            <a:off x="6217920" y="1661160"/>
+            <a:ext cx="2514600" cy="274320"/>
           </a:xfrm>
           <a:prstGeom prst="rect">
             <a:avLst/>
@@ -8998,7 +9012,7 @@
                 </a:solidFill>
                 <a:latin typeface="Arial"/>
               </a:rPr>
-              <a:t>RATES WORK SLOWLY</a:t>
+              <a:t>SAME MODEL, DATES HIDDEN</a:t>
             </a:r>
           </a:p>
         </p:txBody>
@@ -9011,8 +9025,8 @@
         </p:nvSpPr>
         <p:spPr>
           <a:xfrm>
-            <a:off x="6172200" y="1972056"/>
-            <a:ext cx="2560320" cy="822960"/>
+            <a:off x="6217920" y="1972056"/>
+            <a:ext cx="2514600" cy="822960"/>
           </a:xfrm>
           <a:prstGeom prst="rect">
             <a:avLst/>
@@ -9044,7 +9058,7 @@
                 </a:solidFill>
                 <a:latin typeface="Arial"/>
               </a:rPr>
-              <a:t>−9.2%</a:t>
+              <a:t>1.6 → 2.7%</a:t>
             </a:r>
           </a:p>
         </p:txBody>
@@ -9057,8 +9071,8 @@
         </p:nvSpPr>
         <p:spPr>
           <a:xfrm>
-            <a:off x="6172200" y="2849880"/>
-            <a:ext cx="2560320" cy="1024127"/>
+            <a:off x="6217920" y="2849880"/>
+            <a:ext cx="2514600" cy="1024127"/>
           </a:xfrm>
           <a:prstGeom prst="rect">
             <a:avLst/>
@@ -9090,7 +9104,7 @@
                 </a:solidFill>
                 <a:latin typeface="Arial"/>
               </a:rPr>
-              <a:t>after 24 months (−4.5% after 12). Rates help predict prices, not the reverse (Granger p = 0.05 vs 0.51).</a:t>
+              <a:t>Claude's error once it could not tell the years (ARIMAX 2.67%). All test dates are inside the LLMs' training data.</a:t>
             </a:r>
           </a:p>
         </p:txBody>
@@ -9162,7 +9176,7 @@
                 </a:solidFill>
                 <a:latin typeface="Arial"/>
               </a:rPr>
-              <a:t>NEIGHBORHOODS · 2022 SHOCK</a:t>
+              <a:t>RESULT 4 · MORTGAGE RATES</a:t>
             </a:r>
           </a:p>
         </p:txBody>
@@ -9208,7 +9222,7 @@
                 </a:solidFill>
                 <a:latin typeface="Arial"/>
               </a:rPr>
-              <a:t>In LA County, pricier neighborhoods fell hardest after rates jumped</a:t>
+              <a:t>A 1-point rate rise means LA values about 9% lower two years later</a:t>
             </a:r>
           </a:p>
         </p:txBody>
@@ -9284,7 +9298,7 @@
                 </a:solidFill>
                 <a:latin typeface="Arial"/>
               </a:rPr>
-              <a:t>MGMTMSA 437 · Forecasting LA Home Values · Data: Zillow ZHVI, FRED MORTGAGE30US</a:t>
+              <a:t>MGMTMSA 437 · Forecasting LA Home Values · Data: Zillow ZHVI, FRED, BLS</a:t>
             </a:r>
           </a:p>
         </p:txBody>
@@ -9337,7 +9351,7 @@
       </p:sp>
       <p:pic>
         <p:nvPicPr>
-          <p:cNvPr id="7" name="Picture 6" descr="Scatter of neighborhood drop after 2022 against home value, LA and Orange County" title="Scatter of neighborhood drop after 2022 against home value, LA and Orange County"/>
+          <p:cNvPr id="7" name="Picture 6" descr="Impulse response of LA home values to a 1-point mortgage rate rise over 36 months, with 90% band" title="Impulse response of LA home values to a 1-point mortgage rate rise over 36 months, with 90% band"/>
           <p:cNvPicPr>
             <a:picLocks noChangeAspect="1"/>
           </p:cNvPicPr>
@@ -9351,8 +9365,8 @@
         </p:blipFill>
         <p:spPr>
           <a:xfrm>
-            <a:off x="411480" y="1702384"/>
-            <a:ext cx="5486400" cy="2714090"/>
+            <a:off x="411480" y="1919258"/>
+            <a:ext cx="5486400" cy="2280342"/>
           </a:xfrm>
           <a:prstGeom prst="rect">
             <a:avLst/>
@@ -9400,7 +9414,7 @@
                 </a:solidFill>
                 <a:latin typeface="Arial"/>
               </a:rPr>
-              <a:t>STILL BELOW 2022 PEAK</a:t>
+              <a:t>RATES WORK SLOWLY</a:t>
             </a:r>
           </a:p>
         </p:txBody>
@@ -9446,7 +9460,7 @@
                 </a:solidFill>
                 <a:latin typeface="Arial"/>
               </a:rPr>
-              <a:t>152 of 496</a:t>
+              <a:t>−9.2%</a:t>
             </a:r>
           </a:p>
         </p:txBody>
@@ -9492,7 +9506,7 @@
                 </a:solidFill>
                 <a:latin typeface="Arial"/>
               </a:rPr>
-              <a:t>neighborhoods are still below their 2022 peak. In LA County, doubling the price meant a 1.2-point deeper drop (t = -7.7); in Orange County the effect reverses.</a:t>
+              <a:t>after 24 months (−4.5% after 12). Rates help predict prices, not the reverse (Granger p = 0.05 vs 0.51). Local jobs add nothing once 2020–21 is set aside.</a:t>
             </a:r>
           </a:p>
         </p:txBody>
@@ -9564,7 +9578,7 @@
                 </a:solidFill>
                 <a:latin typeface="Arial"/>
               </a:rPr>
-              <a:t>NEIGHBORHOODS · LAST 12 MONTHS</a:t>
+              <a:t>NEIGHBORHOODS · LIVE MAP</a:t>
             </a:r>
           </a:p>
         </p:txBody>
@@ -9610,7 +9624,7 @@
                 </a:solidFill>
                 <a:latin typeface="Arial"/>
               </a:rPr>
-              <a:t>Right now coastal neighborhoods are rising while central LA falls</a:t>
+              <a:t>The metro average hides a split market, neighborhood by neighborhood</a:t>
             </a:r>
           </a:p>
         </p:txBody>
@@ -9686,7 +9700,7 @@
                 </a:solidFill>
                 <a:latin typeface="Arial"/>
               </a:rPr>
-              <a:t>MGMTMSA 437 · Forecasting LA Home Values · Data: Zillow ZHVI, FRED MORTGAGE30US</a:t>
+              <a:t>MGMTMSA 437 · Forecasting LA Home Values · Data: Zillow ZHVI, FRED, BLS</a:t>
             </a:r>
           </a:p>
         </p:txBody>
@@ -9753,7 +9767,7 @@
         </p:blipFill>
         <p:spPr>
           <a:xfrm>
-            <a:off x="1024569" y="1569720"/>
+            <a:off x="1436049" y="1569720"/>
             <a:ext cx="2797180" cy="3025140"/>
           </a:xfrm>
           <a:prstGeom prst="rect">
@@ -9761,30 +9775,328 @@
           </a:prstGeom>
         </p:spPr>
       </p:pic>
-      <p:pic>
-        <p:nvPicPr>
-          <p:cNvPr id="8" name="Picture 7" descr="Ten fastest-rising and ten fastest-falling neighborhoods, Aug 2025 to Aug 2026" title="Ten fastest-rising and ten fastest-falling neighborhoods, Aug 2025 to Aug 2026"/>
-          <p:cNvPicPr>
-            <a:picLocks noChangeAspect="1"/>
-          </p:cNvPicPr>
-          <p:nvPr/>
-        </p:nvPicPr>
-        <p:blipFill>
-          <a:blip r:embed="rId3"/>
-          <a:stretch>
-            <a:fillRect/>
-          </a:stretch>
-        </p:blipFill>
-        <p:spPr>
-          <a:xfrm>
-            <a:off x="4572000" y="1630629"/>
-            <a:ext cx="4206240" cy="2903320"/>
-          </a:xfrm>
-          <a:prstGeom prst="rect">
-            <a:avLst/>
-          </a:prstGeom>
-        </p:spPr>
-      </p:pic>
+      <p:sp>
+        <p:nvSpPr>
+          <p:cNvPr id="8" name="TextBox 7"/>
+          <p:cNvSpPr txBox="1"/>
+          <p:nvPr/>
+        </p:nvSpPr>
+        <p:spPr>
+          <a:xfrm>
+            <a:off x="5669280" y="1661160"/>
+            <a:ext cx="3108960" cy="406400"/>
+          </a:xfrm>
+          <a:prstGeom prst="rect">
+            <a:avLst/>
+          </a:prstGeom>
+          <a:noFill/>
+          <a:ln/>
+        </p:spPr>
+        <p:txBody>
+          <a:bodyPr wrap="none" anchor="t" lIns="25400" rIns="25400" tIns="25400" bIns="25400">
+            <a:spAutoFit/>
+          </a:bodyPr>
+          <a:lstStyle/>
+          <a:p>
+            <a:pPr algn="l">
+              <a:lnSpc>
+                <a:spcPct val="100000"/>
+              </a:lnSpc>
+              <a:spcBef>
+                <a:spcPts val="0"/>
+              </a:spcBef>
+              <a:spcAft>
+                <a:spcPts val="600"/>
+              </a:spcAft>
+            </a:pPr>
+            <a:r>
+              <a:rPr sz="2600" b="1" i="0">
+                <a:solidFill>
+                  <a:srgbClr val="16213E"/>
+                </a:solidFill>
+                <a:latin typeface="Arial"/>
+              </a:rPr>
+              <a:t>220 / 216 / 60</a:t>
+            </a:r>
+          </a:p>
+        </p:txBody>
+      </p:sp>
+      <p:sp>
+        <p:nvSpPr>
+          <p:cNvPr id="9" name="TextBox 8"/>
+          <p:cNvSpPr txBox="1"/>
+          <p:nvPr/>
+        </p:nvSpPr>
+        <p:spPr>
+          <a:xfrm>
+            <a:off x="5669280" y="2067560"/>
+            <a:ext cx="3108960" cy="298704"/>
+          </a:xfrm>
+          <a:prstGeom prst="rect">
+            <a:avLst/>
+          </a:prstGeom>
+          <a:noFill/>
+          <a:ln/>
+        </p:spPr>
+        <p:txBody>
+          <a:bodyPr wrap="square" anchor="t" lIns="25400" rIns="25400" tIns="25400" bIns="25400">
+            <a:spAutoFit/>
+          </a:bodyPr>
+          <a:lstStyle/>
+          <a:p>
+            <a:pPr algn="l">
+              <a:lnSpc>
+                <a:spcPct val="100000"/>
+              </a:lnSpc>
+              <a:spcBef>
+                <a:spcPts val="0"/>
+              </a:spcBef>
+              <a:spcAft>
+                <a:spcPts val="600"/>
+              </a:spcAft>
+            </a:pPr>
+            <a:r>
+              <a:rPr sz="1050" b="0" i="0">
+                <a:solidFill>
+                  <a:srgbClr val="6B6F76"/>
+                </a:solidFill>
+                <a:latin typeface="Arial"/>
+              </a:rPr>
+              <a:t>neighborhoods rising / flat / falling more than 2%, last 12 months</a:t>
+            </a:r>
+          </a:p>
+        </p:txBody>
+      </p:sp>
+      <p:sp>
+        <p:nvSpPr>
+          <p:cNvPr id="10" name="TextBox 9"/>
+          <p:cNvSpPr txBox="1"/>
+          <p:nvPr/>
+        </p:nvSpPr>
+        <p:spPr>
+          <a:xfrm>
+            <a:off x="5669280" y="2530856"/>
+            <a:ext cx="3108960" cy="406400"/>
+          </a:xfrm>
+          <a:prstGeom prst="rect">
+            <a:avLst/>
+          </a:prstGeom>
+          <a:noFill/>
+          <a:ln/>
+        </p:spPr>
+        <p:txBody>
+          <a:bodyPr wrap="none" anchor="t" lIns="25400" rIns="25400" tIns="25400" bIns="25400">
+            <a:spAutoFit/>
+          </a:bodyPr>
+          <a:lstStyle/>
+          <a:p>
+            <a:pPr algn="l">
+              <a:lnSpc>
+                <a:spcPct val="100000"/>
+              </a:lnSpc>
+              <a:spcBef>
+                <a:spcPts val="0"/>
+              </a:spcBef>
+              <a:spcAft>
+                <a:spcPts val="600"/>
+              </a:spcAft>
+            </a:pPr>
+            <a:r>
+              <a:rPr sz="2600" b="1" i="0">
+                <a:solidFill>
+                  <a:srgbClr val="B4400B"/>
+                </a:solidFill>
+                <a:latin typeface="Arial"/>
+              </a:rPr>
+              <a:t>152 of 496</a:t>
+            </a:r>
+          </a:p>
+        </p:txBody>
+      </p:sp>
+      <p:sp>
+        <p:nvSpPr>
+          <p:cNvPr id="11" name="TextBox 10"/>
+          <p:cNvSpPr txBox="1"/>
+          <p:nvPr/>
+        </p:nvSpPr>
+        <p:spPr>
+          <a:xfrm>
+            <a:off x="5669280" y="2937256"/>
+            <a:ext cx="3108960" cy="149352"/>
+          </a:xfrm>
+          <a:prstGeom prst="rect">
+            <a:avLst/>
+          </a:prstGeom>
+          <a:noFill/>
+          <a:ln/>
+        </p:spPr>
+        <p:txBody>
+          <a:bodyPr wrap="square" anchor="t" lIns="25400" rIns="25400" tIns="25400" bIns="25400">
+            <a:spAutoFit/>
+          </a:bodyPr>
+          <a:lstStyle/>
+          <a:p>
+            <a:pPr algn="l">
+              <a:lnSpc>
+                <a:spcPct val="100000"/>
+              </a:lnSpc>
+              <a:spcBef>
+                <a:spcPts val="0"/>
+              </a:spcBef>
+              <a:spcAft>
+                <a:spcPts val="600"/>
+              </a:spcAft>
+            </a:pPr>
+            <a:r>
+              <a:rPr sz="1050" b="0" i="0">
+                <a:solidFill>
+                  <a:srgbClr val="6B6F76"/>
+                </a:solidFill>
+                <a:latin typeface="Arial"/>
+              </a:rPr>
+              <a:t>still below their 2022 peak, mostly in LA County</a:t>
+            </a:r>
+          </a:p>
+        </p:txBody>
+      </p:sp>
+      <p:sp>
+        <p:nvSpPr>
+          <p:cNvPr id="12" name="TextBox 11"/>
+          <p:cNvSpPr txBox="1"/>
+          <p:nvPr/>
+        </p:nvSpPr>
+        <p:spPr>
+          <a:xfrm>
+            <a:off x="5669280" y="3251200"/>
+            <a:ext cx="3108960" cy="406400"/>
+          </a:xfrm>
+          <a:prstGeom prst="rect">
+            <a:avLst/>
+          </a:prstGeom>
+          <a:noFill/>
+          <a:ln/>
+        </p:spPr>
+        <p:txBody>
+          <a:bodyPr wrap="none" anchor="t" lIns="25400" rIns="25400" tIns="25400" bIns="25400">
+            <a:spAutoFit/>
+          </a:bodyPr>
+          <a:lstStyle/>
+          <a:p>
+            <a:pPr algn="l">
+              <a:lnSpc>
+                <a:spcPct val="100000"/>
+              </a:lnSpc>
+              <a:spcBef>
+                <a:spcPts val="0"/>
+              </a:spcBef>
+              <a:spcAft>
+                <a:spcPts val="600"/>
+              </a:spcAft>
+            </a:pPr>
+            <a:r>
+              <a:rPr sz="2600" b="1" i="0">
+                <a:solidFill>
+                  <a:srgbClr val="B4400B"/>
+                </a:solidFill>
+                <a:latin typeface="Arial"/>
+              </a:rPr>
+              <a:t>−1.2 pts</a:t>
+            </a:r>
+          </a:p>
+        </p:txBody>
+      </p:sp>
+      <p:sp>
+        <p:nvSpPr>
+          <p:cNvPr id="13" name="TextBox 12"/>
+          <p:cNvSpPr txBox="1"/>
+          <p:nvPr/>
+        </p:nvSpPr>
+        <p:spPr>
+          <a:xfrm>
+            <a:off x="5669280" y="3657600"/>
+            <a:ext cx="3108960" cy="298704"/>
+          </a:xfrm>
+          <a:prstGeom prst="rect">
+            <a:avLst/>
+          </a:prstGeom>
+          <a:noFill/>
+          <a:ln/>
+        </p:spPr>
+        <p:txBody>
+          <a:bodyPr wrap="square" anchor="t" lIns="25400" rIns="25400" tIns="25400" bIns="25400">
+            <a:spAutoFit/>
+          </a:bodyPr>
+          <a:lstStyle/>
+          <a:p>
+            <a:pPr algn="l">
+              <a:lnSpc>
+                <a:spcPct val="100000"/>
+              </a:lnSpc>
+              <a:spcBef>
+                <a:spcPts val="0"/>
+              </a:spcBef>
+              <a:spcAft>
+                <a:spcPts val="600"/>
+              </a:spcAft>
+            </a:pPr>
+            <a:r>
+              <a:rPr sz="1050" b="0" i="0">
+                <a:solidFill>
+                  <a:srgbClr val="6B6F76"/>
+                </a:solidFill>
+                <a:latin typeface="Arial"/>
+              </a:rPr>
+              <a:t>deeper 2022 drop per doubling of price in LA County (reverses in Orange County)</a:t>
+            </a:r>
+          </a:p>
+        </p:txBody>
+      </p:sp>
+      <p:sp>
+        <p:nvSpPr>
+          <p:cNvPr id="14" name="TextBox 13"/>
+          <p:cNvSpPr txBox="1"/>
+          <p:nvPr/>
+        </p:nvSpPr>
+        <p:spPr>
+          <a:xfrm>
+            <a:off x="5669280" y="4139184"/>
+            <a:ext cx="3108960" cy="457200"/>
+          </a:xfrm>
+          <a:prstGeom prst="rect">
+            <a:avLst/>
+          </a:prstGeom>
+          <a:noFill/>
+          <a:ln/>
+        </p:spPr>
+        <p:txBody>
+          <a:bodyPr wrap="square" anchor="t" lIns="25400" rIns="25400" tIns="25400" bIns="25400">
+            <a:spAutoFit/>
+          </a:bodyPr>
+          <a:lstStyle/>
+          <a:p>
+            <a:pPr algn="l">
+              <a:lnSpc>
+                <a:spcPct val="100000"/>
+              </a:lnSpc>
+              <a:spcBef>
+                <a:spcPts val="0"/>
+              </a:spcBef>
+              <a:spcAft>
+                <a:spcPts val="600"/>
+              </a:spcAft>
+            </a:pPr>
+            <a:r>
+              <a:rPr sz="1050" b="1" i="0">
+                <a:solidFill>
+                  <a:srgbClr val="1F6F8B"/>
+                </a:solidFill>
+                <a:latin typeface="Arial"/>
+              </a:rPr>
+              <a:t>Live map: neiltd.github.io/la-housing-forecast</a:t>
+            </a:r>
+          </a:p>
+        </p:txBody>
+      </p:sp>
     </p:spTree>
   </p:cSld>
   <p:clrMapOvr>
@@ -9974,7 +10286,7 @@
                 </a:solidFill>
                 <a:latin typeface="Arial"/>
               </a:rPr>
-              <a:t>MGMTMSA 437 · Forecasting LA Home Values · Data: Zillow ZHVI, FRED MORTGAGE30US</a:t>
+              <a:t>MGMTMSA 437 · Forecasting LA Home Values · Data: Zillow ZHVI, FRED, BLS</a:t>
             </a:r>
           </a:p>
         </p:txBody>

</xml_diff>

<commit_message>
Add trend, misprediction and lecture checks; RMSE; deck update
- Log-linear trend line (nominal 4.5%/yr, real 2.1%/yr) and fit-window robustness
- Section 5c: where and why forecasts miss (turning points, metro-wide)
- Rolling test now reports RMSE; automatic no-look-ahead check for ARIMAX
- Section 9d: unit roots (ADF/KPSS), spurious-regression check, gap
  mean reversion, 10-year rate-shock response, Zillow vs Case-Shiller
- Neighborhood crime/schools/parks script and table
- Slides: new numbers in rails and speaker notes

Co-Authored-By: Claude Opus 5.5 <noreply@anthropic.com>
Claude-Session: https://claude.ai/code/session_01MGxrqNkCGgpin2owaUrbi7
</commit_message>
<xml_diff>
--- a/slides/LA_home_values_slides.pptx
+++ b/slides/LA_home_values_slides.pptx
@@ -1010,7 +1010,7 @@
           <a:lstStyle/>
           <a:p>
             <a:r>
-              <a:t>From 2000 to 2026, LA home values grew about 5.6 percent a year, with a 37 percent crash between 2006 and 2012 along the way. Today the typical home is worth about 952 thousand dollars, which is 1.3 percent below the January 2025 peak. The bottom panel shows why this period is interesting: the 30-year mortgage rate went from 2.7 percent in 2021 to 7.6 percent in 2023. The shaded area is our test window, so every model has to forecast through that rate shock.</a:t>
+              <a:t>From 2000 to 2026, LA home values grew about 5.6 percent a year, with a 37 percent crash between 2006 and 2012 along the way. Today the typical home is worth about 952 thousand dollars, which is 1.3 percent below the January 2025 peak. The dashed line is a log-linear trend from lecture 3, about 4.5 percent a year. Prices were 54 percent above it in 2006 and 25 percent below it in 2012, and today they sit only about 3 percent above it, so the stall looks like prices returning to trend. After inflation the picture is the same: prices are about 3 percent below a 2.1 percent a year real trend, which matches the chart Professor Yu showed in class. The bottom panel shows why this period is interesting: the 30-year mortgage rate went from 2.7 percent in 2021 to 7.6 percent in 2023. The shaded area is our test window, so every model has to forecast through that rate shock.</a:t>
             </a:r>
           </a:p>
         </p:txBody>
@@ -1150,7 +1150,7 @@
           <a:lstStyle/>
           <a:p>
             <a:r>
-              <a:t>This is the main result, the rolling test. ARIMAX, which is ARIMA plus mortgage rates, had the lowest average error at 2.67 percent, with plain ARIMA right behind at 2.77. Adding payroll jobs did not help: ARIMAX with jobs came third at 2.81. The neural networks landed in the middle, the tree models near the bottom, and Prophet last at almost 7 percent, mostly because it fits a smooth trend and does not start from the latest value. Our read: with about 250 monthly observations of a smooth index, there just is not much nonlinear structure for machine learning to find.</a:t>
+              <a:t>This is the main result, the rolling test. ARIMAX, which is ARIMA plus mortgage rates, had the lowest average error at 2.67 percent, with plain ARIMA right behind at 2.77. Adding payroll jobs did not help: ARIMAX with jobs came third at 2.81. The neural networks landed in the middle, the tree models near the bottom, and Prophet last at almost 7 percent, mostly because it fits a smooth trend and does not start from the latest value. The ranking holds if we score in dollars with RMSE instead: ARIMAX is still first at about 36 thousand dollars. Our read: with about 250 monthly observations of a smooth index, there just is not much nonlinear structure for machine learning to find.</a:t>
             </a:r>
           </a:p>
         </p:txBody>
@@ -1360,7 +1360,7 @@
           <a:lstStyle/>
           <a:p>
             <a:r>
-              <a:t>How much do mortgage rates matter? We used the VAR from class and traced an impulse response: what happens to LA home values after a one-point rise in the mortgage rate. Values barely move for the first few months, then fall steadily: about 4.5 percent lower after a year and about 9 percent lower after two, and the 90 percent band stays below zero from about a year on. A Granger causality test agrees on the direction: past rates help predict home values, but past home values do not help predict rates. The effect is slow, which is why it only helps our forecasts at the 12-month horizon, and even there a simple naive drift is about as good. We also added local payroll jobs. They looked like a leading signal too, but only because of the 2020 job crash and rebound; using data before 2020, jobs predict nothing.</a:t>
+              <a:t>How much do mortgage rates matter? We used the VAR from class and traced an impulse response: what happens to LA home values after a one-point rise in the mortgage rate. Values barely move for the first few months, then fall steadily: about 4.5 percent lower after a year and about 9 percent lower after two, and the 90 percent band stays below zero from about a year on. A Granger causality test agrees on the direction: past rates help predict home values, but past home values do not help predict rates. The effect is slow, which is why it only helps our forecasts at the 12-month horizon, and even there a simple naive drift is about as good. We also added local payroll jobs. They looked like a leading signal too, but only because of the 2020 job crash and rebound; using data before 2020, jobs predict nothing. Two checks. There is no look-ahead: ARIMAX uses rates from 24 months back, so a 12-month forecast only uses rates we already knew. And the effect is permanent while rates stay high: run out ten years, values settle about 12 percent lower.</a:t>
             </a:r>
           </a:p>
         </p:txBody>
@@ -1500,7 +1500,7 @@
           <a:lstStyle/>
           <a:p>
             <a:r>
-              <a:t>So what happens next? Our best model forecasts the typical LA home at about 998 thousand dollars in August 2027, up 4.8 percent. ARIMA and naive drift agree closely. The honest headline is the range: the 80 percent interval runs from a 6 percent fall to a 17 percent rise. Neighborhood forecasts are a bit stronger in Orange County than in LA County. Because rates act with a two-year lag, today's rates mostly affect 2028, not this forecast.</a:t>
+              <a:t>So what happens next? Our best model forecasts the typical LA home at about 998 thousand dollars in August 2027, up 4.8 percent. ARIMA and naive drift agree closely. The honest headline is the range: the 80 percent interval runs from a 6 percent fall to a 17 percent rise. Neighborhood forecasts are a bit stronger in Orange County than in LA County. Because rates act with a two-year lag, today's rates mostly affect 2028, not this forecast. One caution from our misprediction check: like any ARIMA-type model, ours misses turning points. In early 2022 it forecast the boom to continue, 10 to 15 percent too high, and in January 2023 it forecast a further fall when prices rebounded. So treat this as the trend path, not a call on the next turn.</a:t>
             </a:r>
           </a:p>
         </p:txBody>
@@ -5781,7 +5781,7 @@
                 </a:solidFill>
                 <a:latin typeface="Arial"/>
               </a:rPr>
-              <a:t>A 1-point rise lowers values about 9% over two years.</a:t>
+              <a:t>A 1-point rise lowers values about 9% over two years. Turning points stay hard to call.</a:t>
             </a:r>
           </a:p>
         </p:txBody>
@@ -8268,7 +8268,7 @@
         <p:spPr>
           <a:xfrm>
             <a:off x="6126480" y="2849880"/>
-            <a:ext cx="2606040" cy="1024127"/>
+            <a:ext cx="2606040" cy="1280160"/>
           </a:xfrm>
           <a:prstGeom prst="rect">
             <a:avLst/>
@@ -8300,7 +8300,7 @@
                 </a:solidFill>
                 <a:latin typeface="Arial"/>
               </a:rPr>
-              <a:t>ARIMAX, average error 1 to 12 months ahead. ARIMA 2.77%. LSTM 3.02%, XGBoost 3.65%, Prophet 6.89%.</a:t>
+              <a:t>ARIMAX, average error 1 to 12 months ahead. ARIMA 2.77%. LSTM 3.02%, XGBoost 3.65%, Prophet 6.89%. Also 1st on RMSE ($35.8K).</a:t>
             </a:r>
           </a:p>
         </p:txBody>

</xml_diff>

<commit_message>
Run Claude through the API like GPT and Gemini; add Diebold-Mariano test
All three chatbots now use llm_run_api.py: one fresh request per prompt, no system
prompt, no tools, default settings. Claude named 1.31%, masked 2.77% (was 1.58/2.67
via the Claude Code CLI, kept as a robustness check). DM test at 12 months: masked vs
ARIMAX p = 0.84-0.99, named p = 0.004-0.03. Deck slide 6 and README updated.

Co-Authored-By: Claude Opus 5.5 <noreply@anthropic.com>
Claude-Session: https://claude.ai/code/session_01MGxrqNkCGgpin2owaUrbi7
</commit_message>
<xml_diff>
--- a/slides/LA_home_values_slides.pptx
+++ b/slides/LA_home_values_slides.pptx
@@ -1290,7 +1290,7 @@
           <a:lstStyle/>
           <a:p>
             <a:r>
-              <a:t>We also asked three chat LLMs, Claude, GPT and Gemini, to forecast at the same eighteen dates, with only the data up to each date and no code. At first they looked brilliant: Claude and GPT averaged about 1.6 percent error, far better than ARIMAX. But every one of these dates is before the models' training cutoff, so they may simply remember what LA prices did next. So we hid the clues: no place, no dates, no mortgage rate, only the last ten years of a rescaled index. Claude's error went from 1.6 to 2.7 percent, GPT's to 2.7, and Gemini's to 3.0. At twelve months ahead the drop is even bigger. Once they cannot recognize the period, the best LLMs forecast about as well as ARIMAX, not better. The lesson: you cannot backtest an LLM on years it has already read about.</a:t>
+              <a:t>We also asked three chat LLMs, Claude, GPT and Gemini, to forecast at the same eighteen dates, through their APIs, one fresh request per prompt, with only the data up to each date and no code. At first they looked brilliant: between 1.3 and 1.6 percent error, far better than ARIMAX. But every one of these dates is before the models' training cutoff, so they may simply remember what LA prices did next. So we hid the clues: no place, no dates, no mortgage rate, only the last ten years of a rescaled index. Claude's error went from 1.3 to 2.8 percent, GPT's to 2.7, and Gemini's to 3.0. At twelve months ahead the drop is even bigger. Once they cannot recognize the period, the best LLMs forecast about as well as ARIMAX, not better. The lesson: you cannot backtest an LLM on years it has already read about.</a:t>
             </a:r>
           </a:p>
         </p:txBody>
@@ -9058,7 +9058,7 @@
                 </a:solidFill>
                 <a:latin typeface="Arial"/>
               </a:rPr>
-              <a:t>1.6 → 2.7%</a:t>
+              <a:t>1.3 → 2.8%</a:t>
             </a:r>
           </a:p>
         </p:txBody>
@@ -9072,7 +9072,7 @@
         <p:spPr>
           <a:xfrm>
             <a:off x="6217920" y="2849880"/>
-            <a:ext cx="2514600" cy="1024127"/>
+            <a:ext cx="2514600" cy="1280160"/>
           </a:xfrm>
           <a:prstGeom prst="rect">
             <a:avLst/>
@@ -9104,7 +9104,7 @@
                 </a:solidFill>
                 <a:latin typeface="Arial"/>
               </a:rPr>
-              <a:t>Claude's error once it could not tell the years (ARIMAX 2.67%). All test dates are inside the LLMs' training data.</a:t>
+              <a:t>Claude's error once it could not tell the place, dates or mortgage rate (ARIMAX 2.67%). All test dates are inside the LLMs' training data.</a:t>
             </a:r>
           </a:p>
         </p:txBody>

</xml_diff>

<commit_message>
Claude memory checks (quiz, full-history masked) and ARIMAX regressor table
- 'Name this series' quiz: Claude never names LA (0/18) but dates the masked series
  within a month at the median.
- Masked prompt with all history since 2000: error 2.47%, corr with actual 0.56, and an
  April 2022 forecast of -4.7% (actual -3.7%): longer history gives the dates away.
- ARIMAX regressors: rate p = 0.16 (train) / 0.15 (full), jobs p = 0.29 / 0.36.
- Slide 7: Granger p = 0.052 (borderline) plus the regressor note.

Co-Authored-By: Claude Opus 5.5 <noreply@anthropic.com>
Claude-Session: https://claude.ai/code/session_01MGxrqNkCGgpin2owaUrbi7
</commit_message>
<xml_diff>
--- a/slides/LA_home_values_slides.pptx
+++ b/slides/LA_home_values_slides.pptx
@@ -1360,7 +1360,7 @@
           <a:lstStyle/>
           <a:p>
             <a:r>
-              <a:t>How much do mortgage rates matter? We used the VAR from class and traced an impulse response: what happens to LA home values after a one-point rise in the mortgage rate. Values barely move for the first few months, then fall steadily: about 4.5 percent lower after a year and about 9 percent lower after two, and the 90 percent band stays below zero from about a year on. A Granger causality test agrees on the direction: past rates help predict home values, but past home values do not help predict rates. The effect is slow, which is why it only helps our forecasts at the 12-month horizon, and even there a simple naive drift is about as good. We also added local payroll jobs. They looked like a leading signal too, but only because of the 2020 job crash and rebound; using data before 2020, jobs predict nothing. Two checks. There is no look-ahead: ARIMAX uses rates from 24 months back, so a 12-month forecast only uses rates we already knew. And the effect is permanent while rates stay high: run out ten years, values settle about 12 percent lower.</a:t>
+              <a:t>How much do mortgage rates matter? We used the VAR from class and traced an impulse response: what happens to LA home values after a one-point rise in the mortgage rate. Values barely move for the first few months, then fall steadily: about 4.5 percent lower after a year and about 9 percent lower after two, and the 90 percent band stays below zero from about a year on. A Granger causality test agrees on the direction, though only borderline: past rates help predict home values, p equals 0.052, but past home values do not help predict rates. Inside ARIMAX itself, neither outside variable is significant on its own: the rate term has the expected negative sign but p is 0.16, and payroll jobs have p 0.29. The rate's value shows up out of sample, where ARIMAX ranks first. The effect is slow, which is why it only helps our forecasts at the 12-month horizon, and even there a simple naive drift is about as good. We also added local payroll jobs. They looked like a leading signal too, but only because of the 2020 job crash and rebound; using data before 2020, jobs predict nothing. Two checks. There is no look-ahead: ARIMAX uses rates from 24 months back, so a 12-month forecast only uses rates we already knew. And the effect is permanent while rates stay high: run out ten years, values settle about 12 percent lower.</a:t>
             </a:r>
           </a:p>
         </p:txBody>
@@ -9506,7 +9506,7 @@
                 </a:solidFill>
                 <a:latin typeface="Arial"/>
               </a:rPr>
-              <a:t>after 24 months (−4.5% after 12). Rates help predict prices, not the reverse (Granger p = 0.05 vs 0.51). Local jobs add nothing once 2020–21 is set aside.</a:t>
+              <a:t>after 24 months (−4.5% after 12). Rates help predict prices, not the reverse (Granger p = 0.052, borderline, vs 0.51). Local jobs add nothing once 2020–21 is set aside.</a:t>
             </a:r>
           </a:p>
         </p:txBody>

</xml_diff>

<commit_message>
Deck: charts drawn at slide size with bigger titles; slide 3 test order and error definition
- Slide 7 chart at 5x3; slides 2, 5, 6, 8, 9 charts redrawn closer to slide size, shorter titles.
- Slide 3: rolling test listed first (matches slides 4-5); 'How we score' box defines the error (MAPE).
- Slide 10 notes: how the neighborhood test was run (5 yearly origins, ~400 neighborhoods).
- Notes trimmed to about 8 minutes.

Co-Authored-By: Claude Opus 5.5 <noreply@anthropic.com>
Claude-Session: https://claude.ai/code/session_01MGxrqNkCGgpin2owaUrbi7
</commit_message>
<xml_diff>
--- a/slides/LA_home_values_slides.pptx
+++ b/slides/LA_home_values_slides.pptx
@@ -940,7 +940,7 @@
           <a:lstStyle/>
           <a:p>
             <a:r>
-              <a:t>Four takeaways. First, for a smooth monthly housing index, simple time-series models beat complex ones, including the Chronos foundation model, as long as you test over many windows, not one. Second, AI chatbots are a real alternative, about as good as our best model, but only once you hide what they can remember: you cannot backtest them on years they have already read about. Third, mortgage rates matter, but slowly: a one-point rise lowers values about nine percent over two years, and local jobs add nothing on top. And fourth, the metro average hides a split market: look at the neighborhood, not the metro number. With more time, we would test other cities, score the AI live on months after its training cutoff, and try made-up series it cannot have seen. Thank you.</a:t>
+              <a:t>Four takeaways. First, for a smooth monthly housing index, simple time-series models beat complex ones, including the Chronos foundation model, as long as you test over many windows, not one. Second, AI chatbots are a real alternative, about as good as our best model, but only once you hide what they can remember: you cannot backtest them on years they have already read about. Third, mortgage rates matter, but slowly: a one-point rise lowers values about nine percent over two years, and local jobs add nothing on top. And fourth, the metro average hides a split market: look at the neighborhood, not the metro number. We tested this the same rolling way: five yearly start dates, about 400 neighborhoods, twelve months ahead. ARIMA for each neighborhood had 2.8 percent error, the naive benchmark 3.5, and the shared factor model 4.1. With more time, we would test other cities, score the AI live on months after its training cutoff, and try made-up series it cannot have seen. Thank you.</a:t>
             </a:r>
           </a:p>
         </p:txBody>
@@ -1080,7 +1080,7 @@
           <a:lstStyle/>
           <a:p>
             <a:r>
-              <a:t>Here is the setup. Our data: the Zillow index for the metro, 499 neighborhoods from Zillow's neighborhood file, the 30-year mortgage rate, and payroll jobs for LA and Orange County. We compared fourteen models in four families, from a naive drift baseline to LSTM and GRU networks and Amazon's Chronos foundation model, plus three AI chatbots: Claude, GPT and Gemini. We scored them two ways: a single blind 80/20 split, and a rolling test where we refit every three months and forecast twelve months ahead, eighteen times. Zillow smooths this index, so every model is nearly perfect one month ahead; we judge them at six to twelve months.</a:t>
+              <a:t>Here is the setup. Our data: the Zillow index for the metro, 499 neighborhoods from Zillow's neighborhood file, the 30-year mortgage rate, and payroll jobs for LA and Orange County. We compared fourteen models in four families, from a naive drift baseline to LSTM and GRU networks and Amazon's Chronos foundation model, plus three AI chatbots: Claude, GPT and Gemini. We scored them two ways. The main one is a rolling test: we refit every three months and forecast twelve months ahead, eighteen times. The second is a single blind 80/20 split, like most projects use. Our error measure is simple: for each forecast month, how far off were we in percent, averaged over months one to twelve and over all eighteen start dates.</a:t>
             </a:r>
           </a:p>
         </p:txBody>
@@ -1150,7 +1150,7 @@
           <a:lstStyle/>
           <a:p>
             <a:r>
-              <a:t>This is the main result, the rolling test. ARIMAX, which is ARIMA plus mortgage rates, had the lowest average error at 2.67 percent, with plain ARIMA right behind at 2.77. Adding payroll jobs did not help: ARIMAX with jobs came third at 2.81. The neural networks landed in the middle, the tree models near the bottom, and Prophet last at almost 7 percent, mostly because it fits a smooth trend and does not start from the latest value. The ranking holds if we score in dollars with RMSE instead: ARIMAX is still first at about 36 thousand dollars. Our read: with about 250 monthly observations of a smooth index, there just is not much nonlinear structure for machine learning to find.</a:t>
+              <a:t>This is the main result, the rolling test. ARIMAX, which is ARIMA plus mortgage rates, had the lowest average error at 2.67 percent, with plain ARIMA right behind at 2.77. Adding payroll jobs did not help: ARIMAX with jobs came third at 2.81. The neural networks landed in the middle, the tree models near the bottom, and Prophet last at almost 7 percent, mostly because it fits a smooth trend and does not start from the latest value. The ranking holds if we score in dollars with RMSE instead: ARIMAX is still first at about 36 thousand dollars.</a:t>
             </a:r>
           </a:p>
         </p:txBody>
@@ -1290,7 +1290,7 @@
           <a:lstStyle/>
           <a:p>
             <a:r>
-              <a:t>Now the alternative tool. We asked three AI chatbots, Claude, GPT and Gemini, to forecast at the same eighteen dates, through their APIs, one fresh request per prompt, with only the data up to each date and no code. At first they looked brilliant: between 1.3 and 1.6 percent error, far better than ARIMAX. But every one of these dates is before the models' training cutoff, so they may simply remember what LA prices did next. So we hid the clues: no place, no dates, no mortgage rate, only the last ten years of a rescaled index. Claude's error went from 1.3 to 2.8 percent, GPT's to 2.7, and Gemini's to 3.0. At twelve months ahead the drop is even bigger. Once they cannot recognize the period, the best LLMs forecast about as well as ARIMAX, not better. The lesson: you cannot backtest an LLM on years it has already read about.</a:t>
+              <a:t>Now the alternative tool. We asked three AI chatbots, Claude, GPT and Gemini, to forecast at the same eighteen dates, through their APIs, one fresh request per prompt, with only the data up to each date and no code. At first they looked brilliant: between 1.3 and 1.6 percent error, far better than ARIMAX. But every one of these dates is before the models' training cutoff, so they may simply remember what LA prices did next. So we hid the clues: no place, no dates, no mortgage rate, only the last ten years of a rescaled index. Claude's error went from 1.3 to 2.8 percent, GPT's to 2.7, and Gemini's to 3.0. Once they cannot recognize the period, the best LLMs forecast about as well as ARIMAX, not better. The lesson: you cannot backtest an LLM on years it has already read about.</a:t>
             </a:r>
           </a:p>
         </p:txBody>
@@ -1430,7 +1430,7 @@
           <a:lstStyle/>
           <a:p>
             <a:r>
-              <a:t>Top: using a VAR, we traced what happens to LA home values after a one-point rise in the mortgage rate. Values barely move for a few months, then fall: about 4.5 percent lower after a year and 9 percent after two, and the level stays lower while rates stay high. A Granger test agrees on the direction, though only borderline, p equals 0.052. Inside ARIMAX neither outside variable is significant on its own: the rate term has the expected negative sign but p is 0.16, and payroll jobs have p 0.29. Income and crime don't help either, so the simple model wins. Bottom: our best model forecasts about 998 thousand dollars in August 2027, up 4.8 percent, but the honest headline is the range, from a 6 percent fall to a 17 percent rise. Like every model here, it extends the trend and will miss the next turning point.</a:t>
+              <a:t>Top: using a VAR, we traced what happens to LA home values after a one-point rise in the mortgage rate. Values barely move for a few months, then fall: about 4.5 percent lower after a year and 9 percent after two, and the level stays lower while rates stay high. A Granger test agrees on the direction, though only borderline, p equals 0.052. Inside ARIMAX neither outside variable is significant on its own: the rate term has the expected negative sign but p is 0.16, and payroll jobs have p 0.29. Income and crime don't help either, so the simple model wins. Bottom: our best model forecasts about 998 thousand dollars in August 2027, up 4.8 percent, but the honest headline is the range, from a 6 percent fall to a 17 percent rise.</a:t>
             </a:r>
           </a:p>
         </p:txBody>
@@ -1500,7 +1500,7 @@
           <a:lstStyle/>
           <a:p>
             <a:r>
-              <a:t>Now below the metro level. Over the last twelve months, 220 LA-metro neighborhoods rose more than 2 percent, 216 were flat, and 60 fell. Let me show you on our live map. [Switch to the browser.] Each dot is a neighborhood; blue is rising, red is falling. Expensive coastal pockets like North of Montana in Santa Monica, Point Dume in Malibu and Corona del Mar are blue: the high-end areas that fell hardest in 2023 are leading now. Central LA, Koreatown, Westlake and Downtown, is red. [Click one neighborhood.] Each one shows its value, its change, and our 12-month forecast. Pacific Palisades is down because of the January 2025 fire, not the market. [Back to the slides.] After the 2022 rate jump, pricier LA County neighborhoods fell the most, and 152 of 496 are still below their 2022 peak.</a:t>
+              <a:t>Now below the metro level. Over the last twelve months, 220 LA-metro neighborhoods rose more than 2 percent, 216 were flat, and 60 fell. Let me show you on our live map. [Switch to the browser.] Each dot is a neighborhood; blue is rising, red is falling. Expensive coastal pockets like North of Montana in Santa Monica, Point Dume in Malibu and Corona del Mar are blue: the high-end areas that fell hardest in 2023 are leading now. Central LA, Koreatown, Westlake and Downtown, is red. [Click one neighborhood.] Each one shows its value, its change, and our 12-month forecast. [Back to the slides.] After the 2022 rate jump, pricier LA County neighborhoods fell the most, and 152 of 496 are still below their 2022 peak.</a:t>
             </a:r>
           </a:p>
         </p:txBody>
@@ -6159,8 +6159,8 @@
         </p:blipFill>
         <p:spPr>
           <a:xfrm>
-            <a:off x="794726" y="1569720"/>
-            <a:ext cx="4537027" cy="2933699"/>
+            <a:off x="1000669" y="1569720"/>
+            <a:ext cx="4125141" cy="2933699"/>
           </a:xfrm>
           <a:prstGeom prst="rect">
             <a:avLst/>
@@ -6786,7 +6786,7 @@
                 </a:solidFill>
                 <a:latin typeface="Arial"/>
               </a:rPr>
-              <a:t>WHY NOT 1-MONTH ERRORS  </a:t>
+              <a:t>HOW WE SCORE  </a:t>
             </a:r>
             <a:r>
               <a:rPr sz="1250" b="0" i="0">
@@ -6795,7 +6795,7 @@
                 </a:solidFill>
                 <a:latin typeface="Arial"/>
               </a:rPr>
-              <a:t>Zillow smooths this index, so every decent model is about 0.1% off one month ahead. We judge models at 6 to 12 months instead.</a:t>
+              <a:t>Error = average % gap between the forecast and Zillow's actual value (MAPE), over 1 to 12 months ahead and all 18 start dates. Lower is better; RMSE in dollars agrees.</a:t>
             </a:r>
           </a:p>
         </p:txBody>
@@ -7713,7 +7713,7 @@
                 </a:solidFill>
                 <a:latin typeface="Arial"/>
               </a:rPr>
-              <a:t>Blind 80/20</a:t>
+              <a:t>1. Rolling origin (main)</a:t>
             </a:r>
           </a:p>
         </p:txBody>
@@ -7759,7 +7759,7 @@
                 </a:solidFill>
                 <a:latin typeface="Arial"/>
               </a:rPr>
-              <a:t>Train to Apr 2021, forecast 64 months in one shot</a:t>
+              <a:t>Refit every 3 months, forecast 12 months ahead, 18 times</a:t>
             </a:r>
           </a:p>
         </p:txBody>
@@ -7805,7 +7805,7 @@
                 </a:solidFill>
                 <a:latin typeface="Arial"/>
               </a:rPr>
-              <a:t>Rolling origin</a:t>
+              <a:t>2. Single blind 80/20</a:t>
             </a:r>
           </a:p>
         </p:txBody>
@@ -7851,7 +7851,7 @@
                 </a:solidFill>
                 <a:latin typeface="Arial"/>
               </a:rPr>
-              <a:t>Refit every 3 months, forecast 12 months ahead, 18 times</a:t>
+              <a:t>Train to Apr 2021, forecast 64 months in one shot</a:t>
             </a:r>
           </a:p>
         </p:txBody>
@@ -8508,8 +8508,8 @@
         </p:blipFill>
         <p:spPr>
           <a:xfrm>
-            <a:off x="1427162" y="1542288"/>
-            <a:ext cx="3455035" cy="3052571"/>
+            <a:off x="1652987" y="1542288"/>
+            <a:ext cx="3003385" cy="3052571"/>
           </a:xfrm>
           <a:prstGeom prst="rect">
             <a:avLst/>
@@ -8910,8 +8910,8 @@
         </p:blipFill>
         <p:spPr>
           <a:xfrm>
-            <a:off x="411480" y="2011185"/>
-            <a:ext cx="5577840" cy="2096489"/>
+            <a:off x="411480" y="1712810"/>
+            <a:ext cx="5577840" cy="2693239"/>
           </a:xfrm>
           <a:prstGeom prst="rect">
             <a:avLst/>
@@ -9939,8 +9939,8 @@
         </p:blipFill>
         <p:spPr>
           <a:xfrm>
-            <a:off x="3474720" y="1455932"/>
-            <a:ext cx="5257800" cy="2067042"/>
+            <a:off x="4077069" y="1289304"/>
+            <a:ext cx="4053101" cy="2400299"/>
           </a:xfrm>
           <a:prstGeom prst="rect">
             <a:avLst/>
@@ -10203,8 +10203,8 @@
         </p:blipFill>
         <p:spPr>
           <a:xfrm>
-            <a:off x="1283646" y="1261872"/>
-            <a:ext cx="3833507" cy="1593341"/>
+            <a:off x="1003181" y="1261872"/>
+            <a:ext cx="4394437" cy="1593341"/>
           </a:xfrm>
           <a:prstGeom prst="rect">
             <a:avLst/>
@@ -10227,8 +10227,8 @@
         </p:blipFill>
         <p:spPr>
           <a:xfrm>
-            <a:off x="1449318" y="2928366"/>
-            <a:ext cx="3502162" cy="1593341"/>
+            <a:off x="1168888" y="2928366"/>
+            <a:ext cx="4063022" cy="1593341"/>
           </a:xfrm>
           <a:prstGeom prst="rect">
             <a:avLst/>
@@ -10859,8 +10859,8 @@
         </p:blipFill>
         <p:spPr>
           <a:xfrm>
-            <a:off x="1436049" y="1569720"/>
-            <a:ext cx="2797180" cy="3025140"/>
+            <a:off x="1297760" y="1569720"/>
+            <a:ext cx="3073758" cy="3025140"/>
           </a:xfrm>
           <a:prstGeom prst="rect">
             <a:avLst/>

</xml_diff>

<commit_message>
Deck: Yang's revisions and review fixes before the design pass
- Slide 5: 5x3 grid, LightGBM boxed red, ARIMAX green; 'its lead did not hold'.
- Slide 6: 'An alternative tool: AI won by memory, not forecasting'.
- Slide 7: masked = fewest clues (period still guessable); LA identified 16/18 blind, 0/18 masked.
- Slide 8: sub-headers, separator, same-width charts; ARIMA 80% interval labeled as context.
- Slide 9: clickable live-map link; 496 with recent data. Slide 10: new next steps.
- Slides 1-4: 'up to a year ahead', 18 forecast dates, absolute % error, 12-month numbers.
- Speaker notes rewritten (about 6.5 minutes); no causal claim for the rate response.

Co-Authored-By: Claude Opus 5.5 <noreply@anthropic.com>
Claude-Session: https://claude.ai/code/session_01MGxrqNkCGgpin2owaUrbi7
</commit_message>
<xml_diff>
--- a/slides/LA_home_values_slides.pptx
+++ b/slides/LA_home_values_slides.pptx
@@ -870,7 +870,7 @@
           <a:lstStyle/>
           <a:p>
             <a:r>
-              <a:t>Hi everyone. Our project forecasts home values in the Los Angeles metro using Zillow's Home Value Index from January 2000 to August 2026. The line on the right is the whole story in one picture: a boom and bust in the 2000s, a long recovery, a pandemic surge, and then a stall. That stall lines up with mortgage rates more than doubling. Our question: how well can we forecast LA home values a year ahead, and which approach works best? We compare traditional time-series models with an alternative many people now reach for first: asking an AI chatbot. And we go below the metro level to 499 neighborhoods, because the average hides a lot.</a:t>
+              <a:t>Hi everyone. We forecast home values in the Los Angeles metro, using Zillow's monthly index from 2000 to August 2026. The line shows the whole story: a boom and bust in the 2000s, a long recovery, a pandemic surge, then a stall. Our question: how well can we forecast LA home values up to a year ahead, and what works best? We compare traditional time-series models with an alternative many people now try first: asking an AI chatbot.</a:t>
             </a:r>
           </a:p>
         </p:txBody>
@@ -940,7 +940,7 @@
           <a:lstStyle/>
           <a:p>
             <a:r>
-              <a:t>Four takeaways. First, for a smooth monthly housing index, simple time-series models beat complex ones, including the Chronos foundation model, as long as you test over many windows, not one. Second, AI chatbots are a real alternative, about as good as our best model, but only once you hide what they can remember: you cannot backtest them on years they have already read about. Third, mortgage rates matter, but slowly: a one-point rise lowers values about nine percent over two years, and local jobs add nothing on top. And fourth, the metro average hides a split market: look at the neighborhood, not the metro number. We tested this the same rolling way: five yearly start dates, about 400 neighborhoods, twelve months ahead. ARIMA for each neighborhood had 2.8 percent error, the naive benchmark 3.5, and the shared factor model 4.1. With more time, we would test other cities, score the AI live on months after its training cutoff, and try made-up series it cannot have seen. Thank you.</a:t>
+              <a:t>Our answer: a simple ARIMAX had the lowest average error, about 2.7 percent; a full year out, the naive benchmark was just as good; and masked AI showed no clear advantage. Four takeaways. Simple time-series models beat complex ones, if you test over many windows. AI is a real alternative only when tested fairly, on data it can't remember. Mortgage rates matter, but slowly; jobs did not improve our model. And the metro average hides a split market. Next, we would test more cities, score the AI live after its training cutoff, and feed it altered histories to see whether it forecasts or recalls. Thank you.</a:t>
             </a:r>
           </a:p>
         </p:txBody>
@@ -1010,7 +1010,7 @@
           <a:lstStyle/>
           <a:p>
             <a:r>
-              <a:t>From 2000 to 2026, LA home values grew about 5.6 percent a year, with a 37 percent crash between 2006 and 2012 along the way. Today the typical home is worth about 952 thousand dollars, which is 1.3 percent below the January 2025 peak, and close to its long-run trend. The bottom panel shows why this period is interesting: the 30-year mortgage rate went from 2.7 percent in 2021 to 7.6 percent in 2023. The shaded area is our test window, so every model has to forecast through that rate shock.</a:t>
+              <a:t>From 2000 to 2026, LA home values grew about 5.6 percent a year on average, with a 37 percent crash from 2006 to 2012. The dashed line is a fitted trend, about 4.5 percent a year, and prices today sit close to it. The typical home is worth about 952 thousand dollars, 1.3 percent below the January 2025 peak. The bottom panel shows why this is a hard test: the 30-year mortgage rate went from 2.7 percent in 2021 to 7.6 percent in 2023, and the shaded test window runs right through that shock.</a:t>
             </a:r>
           </a:p>
         </p:txBody>
@@ -1080,7 +1080,7 @@
           <a:lstStyle/>
           <a:p>
             <a:r>
-              <a:t>Here is the setup. Our data: the Zillow index for the metro, 499 neighborhoods from Zillow's neighborhood file, the 30-year mortgage rate, and payroll jobs for LA and Orange County. We compared fourteen models in four families, from a naive drift baseline to LSTM and GRU networks and Amazon's Chronos foundation model, plus three AI chatbots: Claude, GPT and Gemini. We scored them two ways. The main one is a rolling test: we refit every three months and forecast twelve months ahead, eighteen times. The second is a single blind 80/20 split, like most projects use. Our error measure is simple: for each forecast month, how far off were we in percent, averaged over months one to twelve and over all eighteen start dates.</a:t>
+              <a:t>Our data: the Zillow index, about 500 neighborhoods, the mortgage rate, and payroll jobs for LA and Orange County. We compared fourteen models, from a simple naive-drift benchmark to neural networks and Amazon's Chronos foundation model, plus three AI chatbots. Every model setting, including the mortgage-rate lag, was chosen on training data only. Our main test is rolling: at eighteen start dates, every three months, each model forecasts the next twelve months. The score is the average absolute percentage error across those months and dates. Lower is better.</a:t>
             </a:r>
           </a:p>
         </p:txBody>
@@ -1150,7 +1150,7 @@
           <a:lstStyle/>
           <a:p>
             <a:r>
-              <a:t>This is the main result, the rolling test. ARIMAX, which is ARIMA plus mortgage rates, had the lowest average error at 2.67 percent, with plain ARIMA right behind at 2.77. Adding payroll jobs did not help: ARIMAX with jobs came third at 2.81. The neural networks landed in the middle, the tree models near the bottom, and Prophet last at almost 7 percent, mostly because it fits a smooth trend and does not start from the latest value. The ranking holds if we score in dollars with RMSE instead: ARIMAX is still first at about 36 thousand dollars.</a:t>
+              <a:t>ARIMAX, which is ARIMA plus the mortgage rate, had the lowest average error, 2.67 percent, just ahead of plain ARIMA at 2.77. The gap is small. Neural networks landed in the middle, tree models lower, and Prophet last, because it doesn't start from the latest value. The ranking holds in dollars too. One honest point: at exactly twelve months ahead every model is about five percent off, and the naive benchmark, 4.9 percent, is as good as ARIMAX, 5.0. The models help most in the first months.</a:t>
             </a:r>
           </a:p>
         </p:txBody>
@@ -1220,7 +1220,7 @@
           <a:lstStyle/>
           <a:p>
             <a:r>
-              <a:t>Here is why the test design matters. In the single blind test, LightGBM won with a 2.2 percent error. It was the only model whose forecast bent, and it happened to bend in the right years. Across eighteen rolling tests it ranked tenth. Meanwhile VAR, LSTM and XGBoost took the 2021 boom and kept going, ending 25 to 35 percent too high. The lesson for us: one test window can crown the wrong model, so we trust the rolling test.</a:t>
+              <a:t>Why test at eighteen dates instead of one? In a single 80/20 split, LightGBM, circled in red, won with 2.2 percent error. Across our rolling tests it ranked tenth, and ARIMAX, in green, was first. The single test forecasts 64 months at once, so it is a different task, but the lesson holds: one window can crown the wrong model.</a:t>
             </a:r>
           </a:p>
         </p:txBody>
@@ -1290,7 +1290,7 @@
           <a:lstStyle/>
           <a:p>
             <a:r>
-              <a:t>Now the alternative tool. We asked three AI chatbots, Claude, GPT and Gemini, to forecast at the same eighteen dates, through their APIs, one fresh request per prompt, with only the data up to each date and no code. At first they looked brilliant: between 1.3 and 1.6 percent error, far better than ARIMAX. But every one of these dates is before the models' training cutoff, so they may simply remember what LA prices did next. So we hid the clues: no place, no dates, no mortgage rate, only the last ten years of a rescaled index. Claude's error went from 1.3 to 2.8 percent, GPT's to 2.7, and Gemini's to 3.0. Once they cannot recognize the period, the best LLMs forecast about as well as ARIMAX, not better. The lesson: you cannot backtest an LLM on years it has already read about.</a:t>
+              <a:t>Remember that lesson, because AI has the same trap. We asked Claude, GPT and Gemini to forecast the same eighteen dates, each as a fresh API request with only the data up to that date. At first they looked brilliant: 1.3 to 1.6 percent error, better than every model. But all eighteen dates are before their training cutoff, so they may remember what happened. When we hid the place, the dates and the mortgage rate, Claude's error rose to 2.8 percent, GPT's to 2.7 and Gemini's to 3.0. That is no better than ARIMAX; the difference is not statistically significant.</a:t>
             </a:r>
           </a:p>
         </p:txBody>
@@ -1360,7 +1360,7 @@
           <a:lstStyle/>
           <a:p>
             <a:r>
-              <a:t>How did we test that? Each AI got the same question three ways, each as a fresh API request. Named tells it this is LA, with real dates. Blind hides the place and dates but keeps the real mortgage rate, and that is enough to give the years away: when we asked Claude to name the blind series, it said Los Angeles 16 times out of 18 and got the dates exactly right. Masked shows only the last ten years of a rescaled index, so there is nothing to recognize: Claude never named LA. The chart shows what that means at the 2022 peak. In April 2022, prices had risen 17 percent in a year. With the named and blind prompts, Claude forecast a fall, close to what happened. With the masked prompt it forecast another 12 percent rise, just like our ARIMAX. Without its memory, the AI does what a time-series model does: it extends the momentum.</a:t>
+              <a:t>Here is how we gave the AI fewer clues. Named says Los Angeles, with real dates. Blind hides the place and dates but keeps the real mortgage rate, and that is enough: asked to identify the blind series, Claude named Los Angeles 16 times out of 18 and got the dates exactly right. Masked shows only the last ten years, rescaled, with no rate. Claude never named LA, though it could still guess the period from the shape, so masking reduces the clues rather than removing them. The chart shows April 2022, the peak. With the clues, Claude forecast a fall, close to what happened. Masked, it forecast another 12 percent rise, just like our ARIMAX. No model saw that turn coming.</a:t>
             </a:r>
           </a:p>
         </p:txBody>
@@ -1430,7 +1430,7 @@
           <a:lstStyle/>
           <a:p>
             <a:r>
-              <a:t>Top: using a VAR, we traced what happens to LA home values after a one-point rise in the mortgage rate. Values barely move for a few months, then fall: about 4.5 percent lower after a year and 9 percent after two, and the level stays lower while rates stay high. A Granger test agrees on the direction, though only borderline, p equals 0.052. Inside ARIMAX neither outside variable is significant on its own: the rate term has the expected negative sign but p is 0.16, and payroll jobs have p 0.29. Income and crime don't help either, so the simple model wins. Bottom: our best model forecasts about 998 thousand dollars in August 2027, up 4.8 percent, but the honest headline is the range, from a 6 percent fall to a 17 percent rise.</a:t>
+              <a:t>Back to our best model. Top: our VAR estimates how LA values respond after a one-point rise in the mortgage rate: little at first, about 4.5 percent lower after a year and 9 after two. That is a predictive relationship, not a proven causal effect, and the Granger test is borderline, p equals 0.052. Inside ARIMAX neither the rate nor jobs is significant on its own, but the rate still helps out of sample. It enters with a two-year lag, so a twelve-month forecast never needs future rates. Bottom: ARIMAX forecasts about 998 thousand dollars by August 2027, up 4.8 percent. The band is the ARIMA 80 percent interval, for context: from minus 6 to plus 17 percent.</a:t>
             </a:r>
           </a:p>
         </p:txBody>
@@ -1500,7 +1500,7 @@
           <a:lstStyle/>
           <a:p>
             <a:r>
-              <a:t>Now below the metro level. Over the last twelve months, 220 LA-metro neighborhoods rose more than 2 percent, 216 were flat, and 60 fell. Let me show you on our live map. [Switch to the browser.] Each dot is a neighborhood; blue is rising, red is falling. Expensive coastal pockets like North of Montana in Santa Monica, Point Dume in Malibu and Corona del Mar are blue: the high-end areas that fell hardest in 2023 are leading now. Central LA, Koreatown, Westlake and Downtown, is red. [Click one neighborhood.] Each one shows its value, its change, and our 12-month forecast. [Back to the slides.] After the 2022 rate jump, pricier LA County neighborhoods fell the most, and 152 of 496 are still below their 2022 peak.</a:t>
+              <a:t>Now the neighborhoods. Of 496 neighborhoods with recent data, 220 rose more than 2 percent in the last year, 216 stayed within 2 percent, and 60 fell. [Switch to the browser.] Blue is rising, red is falling. Expensive coastal areas like Santa Monica, Malibu and Corona del Mar are rising; central LA, Koreatown and Downtown are falling. [Click one neighborhood.] Each shows its value, its change and our 12-month forecast. [Back to the slides.] After 2022, pricier LA County neighborhoods fell more: each doubling of price meant a 1.2-point deeper drop. We tested neighborhood forecasts the same rolling way, at five yearly dates for about 400 neighborhoods: ARIMA for each neighborhood had 2.8 percent error, the naive benchmark 3.5.</a:t>
             </a:r>
           </a:p>
         </p:txBody>
@@ -4677,7 +4677,7 @@
                 </a:solidFill>
                 <a:latin typeface="Arial"/>
               </a:rPr>
-              <a:t>How well can we forecast LA home values a year ahead, and which works best: time-series models or AI?</a:t>
+              <a:t>How well can we forecast LA home values up to a year ahead, and which works best: time-series models or AI?</a:t>
             </a:r>
           </a:p>
         </p:txBody>
@@ -5218,7 +5218,7 @@
                 </a:solidFill>
                 <a:latin typeface="Arial"/>
               </a:rPr>
-              <a:t>Test more cities; score the AI live on months after its training cutoff; try made-up look-alike series the AI cannot have seen.</a:t>
+              <a:t>Test more cities; score the AI live on months after its training cutoff; feed AI altered histories to check whether it forecasts the data or recalls the past.</a:t>
             </a:r>
           </a:p>
         </p:txBody>
@@ -5558,7 +5558,7 @@
                 </a:solidFill>
                 <a:latin typeface="Arial"/>
               </a:rPr>
-              <a:t>Chatbots beat every model until we hid the place, dates and rate; then they only tied ARIMAX.</a:t>
+              <a:t>Chatbots beat every model until we hid the place, dates and rate; then no clear edge over ARIMAX.</a:t>
             </a:r>
           </a:p>
         </p:txBody>
@@ -5682,7 +5682,7 @@
                 </a:solidFill>
                 <a:latin typeface="Arial"/>
               </a:rPr>
-              <a:t>Mortgage rates matter, slowly; local jobs don't add</a:t>
+              <a:t>Mortgage rates matter, slowly; jobs didn't improve our model</a:t>
             </a:r>
           </a:p>
         </p:txBody>
@@ -5970,7 +5970,7 @@
                 </a:solidFill>
                 <a:latin typeface="Arial"/>
               </a:rPr>
-              <a:t>THE QUESTION</a:t>
+              <a:t>WHY LA, WHY NOW</a:t>
             </a:r>
           </a:p>
         </p:txBody>
@@ -6524,7 +6524,7 @@
         <p:spPr>
           <a:xfrm>
             <a:off x="502920" y="493776"/>
-            <a:ext cx="8138160" cy="792479"/>
+            <a:ext cx="8138160" cy="640080"/>
           </a:xfrm>
           <a:prstGeom prst="rect">
             <a:avLst/>
@@ -6556,7 +6556,7 @@
                 </a:solidFill>
                 <a:latin typeface="Arial"/>
               </a:rPr>
-              <a:t>We tested 14 models two ways, so no model could win by luck</a:t>
+              <a:t>We compared 14 models across 18 forecast dates</a:t>
             </a:r>
           </a:p>
         </p:txBody>
@@ -6569,7 +6569,7 @@
         </p:nvSpPr>
         <p:spPr>
           <a:xfrm>
-            <a:off x="521207" y="1341120"/>
+            <a:off x="521207" y="1060704"/>
             <a:ext cx="1005840" cy="41148"/>
           </a:xfrm>
           <a:prstGeom prst="rect">
@@ -6795,7 +6795,7 @@
                 </a:solidFill>
                 <a:latin typeface="Arial"/>
               </a:rPr>
-              <a:t>Error = average % gap between the forecast and Zillow's actual value (MAPE), over 1 to 12 months ahead and all 18 start dates. Lower is better; RMSE in dollars agrees.</a:t>
+              <a:t>Error = average absolute % gap between the forecast and Zillow's actual value (MAPE), over 1 to 12 months ahead and all 18 start dates. Lower is better; RMSE in dollars agrees.</a:t>
             </a:r>
           </a:p>
         </p:txBody>
@@ -6808,7 +6808,7 @@
         </p:nvSpPr>
         <p:spPr>
           <a:xfrm>
-            <a:off x="365760" y="1615440"/>
+            <a:off x="365760" y="1335024"/>
             <a:ext cx="2560319" cy="320040"/>
           </a:xfrm>
           <a:prstGeom prst="rect">
@@ -6854,7 +6854,7 @@
         </p:nvSpPr>
         <p:spPr>
           <a:xfrm>
-            <a:off x="365760" y="1944624"/>
+            <a:off x="365760" y="1664208"/>
             <a:ext cx="2560319" cy="9144"/>
           </a:xfrm>
           <a:prstGeom prst="rect">
@@ -6884,7 +6884,7 @@
         </p:nvSpPr>
         <p:spPr>
           <a:xfrm>
-            <a:off x="365760" y="2072640"/>
+            <a:off x="365760" y="1792224"/>
             <a:ext cx="2560319" cy="170688"/>
           </a:xfrm>
           <a:prstGeom prst="rect">
@@ -6930,7 +6930,7 @@
         </p:nvSpPr>
         <p:spPr>
           <a:xfrm>
-            <a:off x="365760" y="2243328"/>
+            <a:off x="365760" y="1962912"/>
             <a:ext cx="2560319" cy="149352"/>
           </a:xfrm>
           <a:prstGeom prst="rect">
@@ -6976,7 +6976,7 @@
         </p:nvSpPr>
         <p:spPr>
           <a:xfrm>
-            <a:off x="365760" y="2465832"/>
+            <a:off x="365760" y="2185416"/>
             <a:ext cx="2560319" cy="170688"/>
           </a:xfrm>
           <a:prstGeom prst="rect">
@@ -7022,7 +7022,7 @@
         </p:nvSpPr>
         <p:spPr>
           <a:xfrm>
-            <a:off x="365760" y="2636520"/>
+            <a:off x="365760" y="2356104"/>
             <a:ext cx="2560319" cy="149352"/>
           </a:xfrm>
           <a:prstGeom prst="rect">
@@ -7068,7 +7068,7 @@
         </p:nvSpPr>
         <p:spPr>
           <a:xfrm>
-            <a:off x="365760" y="2859024"/>
+            <a:off x="365760" y="2578608"/>
             <a:ext cx="2560319" cy="170688"/>
           </a:xfrm>
           <a:prstGeom prst="rect">
@@ -7114,7 +7114,7 @@
         </p:nvSpPr>
         <p:spPr>
           <a:xfrm>
-            <a:off x="365760" y="3029712"/>
+            <a:off x="365760" y="2749296"/>
             <a:ext cx="2560319" cy="149352"/>
           </a:xfrm>
           <a:prstGeom prst="rect">
@@ -7160,7 +7160,7 @@
         </p:nvSpPr>
         <p:spPr>
           <a:xfrm>
-            <a:off x="3291839" y="1615440"/>
+            <a:off x="3291839" y="1335024"/>
             <a:ext cx="2560319" cy="320040"/>
           </a:xfrm>
           <a:prstGeom prst="rect">
@@ -7206,7 +7206,7 @@
         </p:nvSpPr>
         <p:spPr>
           <a:xfrm>
-            <a:off x="3291839" y="1944624"/>
+            <a:off x="3291839" y="1664208"/>
             <a:ext cx="2560319" cy="9144"/>
           </a:xfrm>
           <a:prstGeom prst="rect">
@@ -7236,7 +7236,7 @@
         </p:nvSpPr>
         <p:spPr>
           <a:xfrm>
-            <a:off x="3291839" y="2072640"/>
+            <a:off x="3291839" y="1792224"/>
             <a:ext cx="2560319" cy="170688"/>
           </a:xfrm>
           <a:prstGeom prst="rect">
@@ -7282,7 +7282,7 @@
         </p:nvSpPr>
         <p:spPr>
           <a:xfrm>
-            <a:off x="3291839" y="2243328"/>
+            <a:off x="3291839" y="1962912"/>
             <a:ext cx="2560319" cy="149352"/>
           </a:xfrm>
           <a:prstGeom prst="rect">
@@ -7328,7 +7328,7 @@
         </p:nvSpPr>
         <p:spPr>
           <a:xfrm>
-            <a:off x="3291839" y="2465832"/>
+            <a:off x="3291839" y="2185416"/>
             <a:ext cx="2560319" cy="170688"/>
           </a:xfrm>
           <a:prstGeom prst="rect">
@@ -7374,7 +7374,7 @@
         </p:nvSpPr>
         <p:spPr>
           <a:xfrm>
-            <a:off x="3291839" y="2636520"/>
+            <a:off x="3291839" y="2356104"/>
             <a:ext cx="2560319" cy="298704"/>
           </a:xfrm>
           <a:prstGeom prst="rect">
@@ -7420,7 +7420,7 @@
         </p:nvSpPr>
         <p:spPr>
           <a:xfrm>
-            <a:off x="3291839" y="3008376"/>
+            <a:off x="3291839" y="2727960"/>
             <a:ext cx="2560319" cy="170688"/>
           </a:xfrm>
           <a:prstGeom prst="rect">
@@ -7466,7 +7466,7 @@
         </p:nvSpPr>
         <p:spPr>
           <a:xfrm>
-            <a:off x="3291839" y="3179064"/>
+            <a:off x="3291839" y="2898648"/>
             <a:ext cx="2560319" cy="149352"/>
           </a:xfrm>
           <a:prstGeom prst="rect">
@@ -7512,7 +7512,7 @@
         </p:nvSpPr>
         <p:spPr>
           <a:xfrm>
-            <a:off x="3291839" y="3401568"/>
+            <a:off x="3291839" y="3121152"/>
             <a:ext cx="2560319" cy="170688"/>
           </a:xfrm>
           <a:prstGeom prst="rect">
@@ -7558,7 +7558,7 @@
         </p:nvSpPr>
         <p:spPr>
           <a:xfrm>
-            <a:off x="3291839" y="3572256"/>
+            <a:off x="3291839" y="3291840"/>
             <a:ext cx="2560319" cy="149352"/>
           </a:xfrm>
           <a:prstGeom prst="rect">
@@ -7604,7 +7604,7 @@
         </p:nvSpPr>
         <p:spPr>
           <a:xfrm>
-            <a:off x="6217919" y="1615440"/>
+            <a:off x="6217919" y="1335024"/>
             <a:ext cx="2560319" cy="320040"/>
           </a:xfrm>
           <a:prstGeom prst="rect">
@@ -7650,7 +7650,7 @@
         </p:nvSpPr>
         <p:spPr>
           <a:xfrm>
-            <a:off x="6217919" y="1944624"/>
+            <a:off x="6217919" y="1664208"/>
             <a:ext cx="2560319" cy="9144"/>
           </a:xfrm>
           <a:prstGeom prst="rect">
@@ -7680,7 +7680,7 @@
         </p:nvSpPr>
         <p:spPr>
           <a:xfrm>
-            <a:off x="6217919" y="2072640"/>
+            <a:off x="6217919" y="1792224"/>
             <a:ext cx="2560319" cy="170688"/>
           </a:xfrm>
           <a:prstGeom prst="rect">
@@ -7726,7 +7726,7 @@
         </p:nvSpPr>
         <p:spPr>
           <a:xfrm>
-            <a:off x="6217919" y="2243328"/>
+            <a:off x="6217919" y="1962912"/>
             <a:ext cx="2560319" cy="298704"/>
           </a:xfrm>
           <a:prstGeom prst="rect">
@@ -7772,7 +7772,7 @@
         </p:nvSpPr>
         <p:spPr>
           <a:xfrm>
-            <a:off x="6217919" y="2615184"/>
+            <a:off x="6217919" y="2334768"/>
             <a:ext cx="2560319" cy="170688"/>
           </a:xfrm>
           <a:prstGeom prst="rect">
@@ -7818,7 +7818,7 @@
         </p:nvSpPr>
         <p:spPr>
           <a:xfrm>
-            <a:off x="6217919" y="2785872"/>
+            <a:off x="6217919" y="2505456"/>
             <a:ext cx="2560319" cy="298704"/>
           </a:xfrm>
           <a:prstGeom prst="rect">
@@ -8247,7 +8247,7 @@
                 </a:solidFill>
                 <a:latin typeface="Arial"/>
               </a:rPr>
-              <a:t>ARIMAX, average error 1 to 12 months ahead. ARIMA 2.77%. LSTM 3.02%, XGBoost 3.65%, Prophet 6.89%. Also 1st on RMSE ($35.8K).</a:t>
+              <a:t>ARIMAX (ARIMA + mortgage rate), average error 1 to 12 months ahead; ARIMA 2.77%. At 12 months: ARIMAX 5.0%, naive drift 4.9%.</a:t>
             </a:r>
           </a:p>
         </p:txBody>
@@ -8494,7 +8494,7 @@
       </p:sp>
       <p:pic>
         <p:nvPicPr>
-          <p:cNvPr id="7" name="Picture 6" descr="Grid of 11 model forecasts from April 2021 against actual LA values" title="Grid of 11 model forecasts from April 2021 against actual LA values"/>
+          <p:cNvPr id="7" name="Picture 6" descr="5 by 3 grid of 15 model forecasts from May 2021 against actual LA values; LightGBM circled in red, ARIMAX in green" title="5 by 3 grid of 15 model forecasts from May 2021 against actual LA values; LightGBM circled in red, ARIMAX in green"/>
           <p:cNvPicPr>
             <a:picLocks noChangeAspect="1"/>
           </p:cNvPicPr>
@@ -8508,8 +8508,8 @@
         </p:blipFill>
         <p:spPr>
           <a:xfrm>
-            <a:off x="1652987" y="1542288"/>
-            <a:ext cx="3003385" cy="3052571"/>
+            <a:off x="558447" y="1542288"/>
+            <a:ext cx="5329625" cy="3052571"/>
           </a:xfrm>
           <a:prstGeom prst="rect">
             <a:avLst/>
@@ -8524,8 +8524,8 @@
         </p:nvSpPr>
         <p:spPr>
           <a:xfrm>
-            <a:off x="6172200" y="1661160"/>
-            <a:ext cx="2560320" cy="274320"/>
+            <a:off x="6309360" y="1661160"/>
+            <a:ext cx="2514600" cy="274320"/>
           </a:xfrm>
           <a:prstGeom prst="rect">
             <a:avLst/>
@@ -8570,8 +8570,8 @@
         </p:nvSpPr>
         <p:spPr>
           <a:xfrm>
-            <a:off x="6172200" y="1972056"/>
-            <a:ext cx="2560320" cy="822960"/>
+            <a:off x="6309360" y="1972056"/>
+            <a:ext cx="2514600" cy="822960"/>
           </a:xfrm>
           <a:prstGeom prst="rect">
             <a:avLst/>
@@ -8616,8 +8616,8 @@
         </p:nvSpPr>
         <p:spPr>
           <a:xfrm>
-            <a:off x="6172200" y="2849880"/>
-            <a:ext cx="2560320" cy="1280160"/>
+            <a:off x="6309360" y="2849880"/>
+            <a:ext cx="2514600" cy="1280160"/>
           </a:xfrm>
           <a:prstGeom prst="rect">
             <a:avLst/>
@@ -8649,7 +8649,7 @@
                 </a:solidFill>
                 <a:latin typeface="Arial"/>
               </a:rPr>
-              <a:t>LightGBM won the single 64-month test (2.2% error) but ranked 10th across 18 rolling tests: it got lucky in the one window that counted.</a:t>
+              <a:t>LightGBM won the single 64-month test (2.2% error) but ranked 10th across 18 rolling 12-month tests: its lead did not hold.</a:t>
             </a:r>
           </a:p>
         </p:txBody>
@@ -8767,7 +8767,7 @@
                 </a:solidFill>
                 <a:latin typeface="Arial"/>
               </a:rPr>
-              <a:t>An alternative tool: AI chatbots won by memory, not forecasting</a:t>
+              <a:t>An alternative tool: AI won by memory, not forecasting</a:t>
             </a:r>
           </a:p>
         </p:txBody>
@@ -9408,7 +9408,7 @@
                 </a:solidFill>
                 <a:latin typeface="Arial"/>
               </a:rPr>
-              <a:t>Given the blind data, Claude named Los Angeles 16 of 18 times and got the dates exactly right. Masked: 0 of 18.</a:t>
+              <a:t>LA identified: blind 16 of 18 (dates exactly right); masked 0 of 18. The period can still be guessed from the shape.</a:t>
             </a:r>
           </a:p>
         </p:txBody>
@@ -9872,7 +9872,7 @@
                 </a:solidFill>
                 <a:latin typeface="Arial"/>
               </a:rPr>
-              <a:t>Last 10 years only; no place, dates or rate</a:t>
+              <a:t>Last 10 years, rescaled; no place or rate</a:t>
             </a:r>
           </a:p>
         </p:txBody>
@@ -9918,7 +9918,7 @@
                 </a:solidFill>
                 <a:latin typeface="Arial"/>
               </a:rPr>
-              <a:t>The fair test</a:t>
+              <a:t>Fewest clues; period still guessable</a:t>
             </a:r>
           </a:p>
         </p:txBody>
@@ -10187,9 +10187,55 @@
           </a:p>
         </p:txBody>
       </p:sp>
+      <p:sp>
+        <p:nvSpPr>
+          <p:cNvPr id="7" name="TextBox 6"/>
+          <p:cNvSpPr txBox="1"/>
+          <p:nvPr/>
+        </p:nvSpPr>
+        <p:spPr>
+          <a:xfrm>
+            <a:off x="457200" y="1261872"/>
+            <a:ext cx="8229600" cy="274320"/>
+          </a:xfrm>
+          <a:prstGeom prst="rect">
+            <a:avLst/>
+          </a:prstGeom>
+          <a:noFill/>
+          <a:ln/>
+        </p:spPr>
+        <p:txBody>
+          <a:bodyPr wrap="square" anchor="t" lIns="25400" rIns="25400" tIns="25400" bIns="25400">
+            <a:spAutoFit/>
+          </a:bodyPr>
+          <a:lstStyle/>
+          <a:p>
+            <a:pPr algn="l">
+              <a:lnSpc>
+                <a:spcPct val="100000"/>
+              </a:lnSpc>
+              <a:spcBef>
+                <a:spcPts val="0"/>
+              </a:spcBef>
+              <a:spcAft>
+                <a:spcPts val="600"/>
+              </a:spcAft>
+            </a:pPr>
+            <a:r>
+              <a:rPr sz="1050" b="1" i="0">
+                <a:solidFill>
+                  <a:srgbClr val="1F6F8B"/>
+                </a:solidFill>
+                <a:latin typeface="Arial"/>
+              </a:rPr>
+              <a:t>LA HOUSING VALUE VS MORTGAGE RATES</a:t>
+            </a:r>
+          </a:p>
+        </p:txBody>
+      </p:sp>
       <p:pic>
         <p:nvPicPr>
-          <p:cNvPr id="7" name="Picture 6" descr="Impulse response of LA home values to a 1-point mortgage rate rise over 36 months, with 90% band" title="Impulse response of LA home values to a 1-point mortgage rate rise over 36 months, with 90% band"/>
+          <p:cNvPr id="8" name="Picture 7" descr="Impulse response of LA home values to a 1-point mortgage rate rise over 36 months, with 90% band" title="Impulse response of LA home values to a 1-point mortgage rate rise over 36 months, with 90% band"/>
           <p:cNvPicPr>
             <a:picLocks noChangeAspect="1"/>
           </p:cNvPicPr>
@@ -10203,17 +10249,277 @@
         </p:blipFill>
         <p:spPr>
           <a:xfrm>
-            <a:off x="1003181" y="1261872"/>
-            <a:ext cx="4394437" cy="1593341"/>
+            <a:off x="1106683" y="1536192"/>
+            <a:ext cx="4278872" cy="1300733"/>
           </a:xfrm>
           <a:prstGeom prst="rect">
             <a:avLst/>
           </a:prstGeom>
         </p:spPr>
       </p:pic>
+      <p:sp>
+        <p:nvSpPr>
+          <p:cNvPr id="9" name="TextBox 8"/>
+          <p:cNvSpPr txBox="1"/>
+          <p:nvPr/>
+        </p:nvSpPr>
+        <p:spPr>
+          <a:xfrm>
+            <a:off x="6263640" y="1554480"/>
+            <a:ext cx="2514600" cy="302768"/>
+          </a:xfrm>
+          <a:prstGeom prst="rect">
+            <a:avLst/>
+          </a:prstGeom>
+          <a:noFill/>
+          <a:ln/>
+        </p:spPr>
+        <p:txBody>
+          <a:bodyPr wrap="none" anchor="t" lIns="25400" rIns="25400" tIns="25400" bIns="25400">
+            <a:spAutoFit/>
+          </a:bodyPr>
+          <a:lstStyle/>
+          <a:p>
+            <a:pPr algn="l">
+              <a:lnSpc>
+                <a:spcPct val="100000"/>
+              </a:lnSpc>
+              <a:spcBef>
+                <a:spcPts val="0"/>
+              </a:spcBef>
+              <a:spcAft>
+                <a:spcPts val="600"/>
+              </a:spcAft>
+            </a:pPr>
+            <a:r>
+              <a:rPr sz="2000" b="1" i="0">
+                <a:solidFill>
+                  <a:srgbClr val="B4400B"/>
+                </a:solidFill>
+                <a:latin typeface="Arial"/>
+              </a:rPr>
+              <a:t>−9.2%</a:t>
+            </a:r>
+          </a:p>
+        </p:txBody>
+      </p:sp>
+      <p:sp>
+        <p:nvSpPr>
+          <p:cNvPr id="10" name="TextBox 9"/>
+          <p:cNvSpPr txBox="1"/>
+          <p:nvPr/>
+        </p:nvSpPr>
+        <p:spPr>
+          <a:xfrm>
+            <a:off x="6263640" y="1857248"/>
+            <a:ext cx="2514600" cy="270256"/>
+          </a:xfrm>
+          <a:prstGeom prst="rect">
+            <a:avLst/>
+          </a:prstGeom>
+          <a:noFill/>
+          <a:ln/>
+        </p:spPr>
+        <p:txBody>
+          <a:bodyPr wrap="square" anchor="t" lIns="25400" rIns="25400" tIns="25400" bIns="25400">
+            <a:spAutoFit/>
+          </a:bodyPr>
+          <a:lstStyle/>
+          <a:p>
+            <a:pPr algn="l">
+              <a:lnSpc>
+                <a:spcPct val="100000"/>
+              </a:lnSpc>
+              <a:spcBef>
+                <a:spcPts val="0"/>
+              </a:spcBef>
+              <a:spcAft>
+                <a:spcPts val="600"/>
+              </a:spcAft>
+            </a:pPr>
+            <a:r>
+              <a:rPr sz="950" b="0" i="0">
+                <a:solidFill>
+                  <a:srgbClr val="6B6F76"/>
+                </a:solidFill>
+                <a:latin typeface="Arial"/>
+              </a:rPr>
+              <a:t>two years after a 1-point rate rise (−4.5% after one)</a:t>
+            </a:r>
+          </a:p>
+        </p:txBody>
+      </p:sp>
+      <p:sp>
+        <p:nvSpPr>
+          <p:cNvPr id="11" name="TextBox 10"/>
+          <p:cNvSpPr txBox="1"/>
+          <p:nvPr/>
+        </p:nvSpPr>
+        <p:spPr>
+          <a:xfrm>
+            <a:off x="6263640" y="2182368"/>
+            <a:ext cx="2514600" cy="302768"/>
+          </a:xfrm>
+          <a:prstGeom prst="rect">
+            <a:avLst/>
+          </a:prstGeom>
+          <a:noFill/>
+          <a:ln/>
+        </p:spPr>
+        <p:txBody>
+          <a:bodyPr wrap="none" anchor="t" lIns="25400" rIns="25400" tIns="25400" bIns="25400">
+            <a:spAutoFit/>
+          </a:bodyPr>
+          <a:lstStyle/>
+          <a:p>
+            <a:pPr algn="l">
+              <a:lnSpc>
+                <a:spcPct val="100000"/>
+              </a:lnSpc>
+              <a:spcBef>
+                <a:spcPts val="0"/>
+              </a:spcBef>
+              <a:spcAft>
+                <a:spcPts val="600"/>
+              </a:spcAft>
+            </a:pPr>
+            <a:r>
+              <a:rPr sz="2000" b="1" i="0">
+                <a:solidFill>
+                  <a:srgbClr val="16213E"/>
+                </a:solidFill>
+                <a:latin typeface="Arial"/>
+              </a:rPr>
+              <a:t>p = 0.052</a:t>
+            </a:r>
+          </a:p>
+        </p:txBody>
+      </p:sp>
+      <p:sp>
+        <p:nvSpPr>
+          <p:cNvPr id="12" name="TextBox 11"/>
+          <p:cNvSpPr txBox="1"/>
+          <p:nvPr/>
+        </p:nvSpPr>
+        <p:spPr>
+          <a:xfrm>
+            <a:off x="6263640" y="2485136"/>
+            <a:ext cx="2514600" cy="270256"/>
+          </a:xfrm>
+          <a:prstGeom prst="rect">
+            <a:avLst/>
+          </a:prstGeom>
+          <a:noFill/>
+          <a:ln/>
+        </p:spPr>
+        <p:txBody>
+          <a:bodyPr wrap="square" anchor="t" lIns="25400" rIns="25400" tIns="25400" bIns="25400">
+            <a:spAutoFit/>
+          </a:bodyPr>
+          <a:lstStyle/>
+          <a:p>
+            <a:pPr algn="l">
+              <a:lnSpc>
+                <a:spcPct val="100000"/>
+              </a:lnSpc>
+              <a:spcBef>
+                <a:spcPts val="0"/>
+              </a:spcBef>
+              <a:spcAft>
+                <a:spcPts val="600"/>
+              </a:spcAft>
+            </a:pPr>
+            <a:r>
+              <a:rPr sz="950" b="0" i="0">
+                <a:solidFill>
+                  <a:srgbClr val="6B6F76"/>
+                </a:solidFill>
+                <a:latin typeface="Arial"/>
+              </a:rPr>
+              <a:t>rates lead prices (Granger, borderline). ARIMAX: rate p = 0.16, jobs p = 0.29</a:t>
+            </a:r>
+          </a:p>
+        </p:txBody>
+      </p:sp>
+      <p:sp>
+        <p:nvSpPr>
+          <p:cNvPr id="13" name="Rectangle 12"/>
+          <p:cNvSpPr/>
+          <p:nvPr/>
+        </p:nvSpPr>
+        <p:spPr>
+          <a:xfrm>
+            <a:off x="457200" y="2873501"/>
+            <a:ext cx="8229600" cy="10972"/>
+          </a:xfrm>
+          <a:prstGeom prst="rect">
+            <a:avLst/>
+          </a:prstGeom>
+          <a:solidFill>
+            <a:srgbClr val="6B6F76"/>
+          </a:solidFill>
+          <a:ln>
+            <a:noFill/>
+          </a:ln>
+          <a:effectLst/>
+        </p:spPr>
+        <p:txBody>
+          <a:bodyPr rtlCol="0" anchor="ctr"/>
+          <a:lstStyle/>
+          <a:p>
+            <a:pPr algn="ctr"/>
+          </a:p>
+        </p:txBody>
+      </p:sp>
+      <p:sp>
+        <p:nvSpPr>
+          <p:cNvPr id="14" name="TextBox 13"/>
+          <p:cNvSpPr txBox="1"/>
+          <p:nvPr/>
+        </p:nvSpPr>
+        <p:spPr>
+          <a:xfrm>
+            <a:off x="457200" y="2928365"/>
+            <a:ext cx="8229600" cy="274320"/>
+          </a:xfrm>
+          <a:prstGeom prst="rect">
+            <a:avLst/>
+          </a:prstGeom>
+          <a:noFill/>
+          <a:ln/>
+        </p:spPr>
+        <p:txBody>
+          <a:bodyPr wrap="square" anchor="t" lIns="25400" rIns="25400" tIns="25400" bIns="25400">
+            <a:spAutoFit/>
+          </a:bodyPr>
+          <a:lstStyle/>
+          <a:p>
+            <a:pPr algn="l">
+              <a:lnSpc>
+                <a:spcPct val="100000"/>
+              </a:lnSpc>
+              <a:spcBef>
+                <a:spcPts val="0"/>
+              </a:spcBef>
+              <a:spcAft>
+                <a:spcPts val="600"/>
+              </a:spcAft>
+            </a:pPr>
+            <a:r>
+              <a:rPr sz="1050" b="1" i="0">
+                <a:solidFill>
+                  <a:srgbClr val="1F6F8B"/>
+                </a:solidFill>
+                <a:latin typeface="Arial"/>
+              </a:rPr>
+              <a:t>OUR FORECAST: ABOUT 5% HIGHER BY AUGUST 2027, WITH A WIDE RANGE</a:t>
+            </a:r>
+          </a:p>
+        </p:txBody>
+      </p:sp>
       <p:pic>
         <p:nvPicPr>
-          <p:cNvPr id="8" name="Picture 7" descr="LA metro forecast to August 2027: ARIMAX, ARIMA with 80% band, naive drift" title="LA metro forecast to August 2027: ARIMAX, ARIMA with 80% band, naive drift"/>
+          <p:cNvPr id="15" name="Picture 14" descr="LA metro forecast to August 2027: ARIMAX, ARIMA with 80% band, naive drift" title="LA metro forecast to August 2027: ARIMAX, ARIMA with 80% band, naive drift"/>
           <p:cNvPicPr>
             <a:picLocks noChangeAspect="1"/>
           </p:cNvPicPr>
@@ -10227,8 +10533,8 @@
         </p:blipFill>
         <p:spPr>
           <a:xfrm>
-            <a:off x="1168888" y="2928366"/>
-            <a:ext cx="4063022" cy="1593341"/>
+            <a:off x="1109393" y="3202685"/>
+            <a:ext cx="4273453" cy="1300733"/>
           </a:xfrm>
           <a:prstGeom prst="rect">
             <a:avLst/>
@@ -10237,14 +10543,14 @@
       </p:pic>
       <p:sp>
         <p:nvSpPr>
-          <p:cNvPr id="9" name="TextBox 8"/>
+          <p:cNvPr id="16" name="TextBox 15"/>
           <p:cNvSpPr txBox="1"/>
           <p:nvPr/>
         </p:nvSpPr>
         <p:spPr>
           <a:xfrm>
-            <a:off x="6217920" y="1335024"/>
-            <a:ext cx="2514600" cy="406400"/>
+            <a:off x="6263640" y="3220973"/>
+            <a:ext cx="2514600" cy="302768"/>
           </a:xfrm>
           <a:prstGeom prst="rect">
             <a:avLst/>
@@ -10270,27 +10576,27 @@
               </a:spcAft>
             </a:pPr>
             <a:r>
-              <a:rPr sz="2600" b="1" i="0">
-                <a:solidFill>
-                  <a:srgbClr val="B4400B"/>
-                </a:solidFill>
-                <a:latin typeface="Arial"/>
-              </a:rPr>
-              <a:t>−9.2%</a:t>
-            </a:r>
-          </a:p>
-        </p:txBody>
-      </p:sp>
-      <p:sp>
-        <p:nvSpPr>
-          <p:cNvPr id="10" name="TextBox 9"/>
+              <a:rPr sz="2000" b="1" i="0">
+                <a:solidFill>
+                  <a:srgbClr val="1F6F8B"/>
+                </a:solidFill>
+                <a:latin typeface="Arial"/>
+              </a:rPr>
+              <a:t>$998K (+4.8%)</a:t>
+            </a:r>
+          </a:p>
+        </p:txBody>
+      </p:sp>
+      <p:sp>
+        <p:nvSpPr>
+          <p:cNvPr id="17" name="TextBox 16"/>
           <p:cNvSpPr txBox="1"/>
           <p:nvPr/>
         </p:nvSpPr>
         <p:spPr>
           <a:xfrm>
-            <a:off x="6217920" y="1741424"/>
-            <a:ext cx="2514600" cy="298704"/>
+            <a:off x="6263640" y="3523742"/>
+            <a:ext cx="2514600" cy="135128"/>
           </a:xfrm>
           <a:prstGeom prst="rect">
             <a:avLst/>
@@ -10316,27 +10622,27 @@
               </a:spcAft>
             </a:pPr>
             <a:r>
-              <a:rPr sz="1050" b="0" i="0">
+              <a:rPr sz="950" b="0" i="0">
                 <a:solidFill>
                   <a:srgbClr val="6B6F76"/>
                 </a:solidFill>
                 <a:latin typeface="Arial"/>
               </a:rPr>
-              <a:t>two years after a 1-point rate rise (−4.5% after one)</a:t>
-            </a:r>
-          </a:p>
-        </p:txBody>
-      </p:sp>
-      <p:sp>
-        <p:nvSpPr>
-          <p:cNvPr id="11" name="TextBox 10"/>
+              <a:t>ARIMAX forecast, August 2027</a:t>
+            </a:r>
+          </a:p>
+        </p:txBody>
+      </p:sp>
+      <p:sp>
+        <p:nvSpPr>
+          <p:cNvPr id="18" name="TextBox 17"/>
           <p:cNvSpPr txBox="1"/>
           <p:nvPr/>
         </p:nvSpPr>
         <p:spPr>
           <a:xfrm>
-            <a:off x="6217920" y="2149856"/>
-            <a:ext cx="2514600" cy="406400"/>
+            <a:off x="6263640" y="3713734"/>
+            <a:ext cx="2514600" cy="302768"/>
           </a:xfrm>
           <a:prstGeom prst="rect">
             <a:avLst/>
@@ -10362,27 +10668,27 @@
               </a:spcAft>
             </a:pPr>
             <a:r>
-              <a:rPr sz="2600" b="1" i="0">
+              <a:rPr sz="2000" b="1" i="0">
                 <a:solidFill>
                   <a:srgbClr val="16213E"/>
                 </a:solidFill>
                 <a:latin typeface="Arial"/>
               </a:rPr>
-              <a:t>p = 0.052</a:t>
-            </a:r>
-          </a:p>
-        </p:txBody>
-      </p:sp>
-      <p:sp>
-        <p:nvSpPr>
-          <p:cNvPr id="12" name="TextBox 11"/>
+              <a:t>-6% to +17%</a:t>
+            </a:r>
+          </a:p>
+        </p:txBody>
+      </p:sp>
+      <p:sp>
+        <p:nvSpPr>
+          <p:cNvPr id="19" name="TextBox 18"/>
           <p:cNvSpPr txBox="1"/>
           <p:nvPr/>
         </p:nvSpPr>
         <p:spPr>
           <a:xfrm>
-            <a:off x="6217920" y="2556256"/>
-            <a:ext cx="2514600" cy="298704"/>
+            <a:off x="6263640" y="4016502"/>
+            <a:ext cx="2514600" cy="135128"/>
           </a:xfrm>
           <a:prstGeom prst="rect">
             <a:avLst/>
@@ -10408,197 +10714,13 @@
               </a:spcAft>
             </a:pPr>
             <a:r>
-              <a:rPr sz="1050" b="0" i="0">
+              <a:rPr sz="950" b="0" i="0">
                 <a:solidFill>
                   <a:srgbClr val="6B6F76"/>
                 </a:solidFill>
                 <a:latin typeface="Arial"/>
               </a:rPr>
-              <a:t>rates lead prices (Granger, borderline). In ARIMAX: rate p = 0.16, jobs p = 0.29</a:t>
-            </a:r>
-          </a:p>
-        </p:txBody>
-      </p:sp>
-      <p:sp>
-        <p:nvSpPr>
-          <p:cNvPr id="13" name="TextBox 12"/>
-          <p:cNvSpPr txBox="1"/>
-          <p:nvPr/>
-        </p:nvSpPr>
-        <p:spPr>
-          <a:xfrm>
-            <a:off x="6217920" y="2964688"/>
-            <a:ext cx="2514600" cy="406400"/>
-          </a:xfrm>
-          <a:prstGeom prst="rect">
-            <a:avLst/>
-          </a:prstGeom>
-          <a:noFill/>
-          <a:ln/>
-        </p:spPr>
-        <p:txBody>
-          <a:bodyPr wrap="none" anchor="t" lIns="25400" rIns="25400" tIns="25400" bIns="25400">
-            <a:spAutoFit/>
-          </a:bodyPr>
-          <a:lstStyle/>
-          <a:p>
-            <a:pPr algn="l">
-              <a:lnSpc>
-                <a:spcPct val="100000"/>
-              </a:lnSpc>
-              <a:spcBef>
-                <a:spcPts val="0"/>
-              </a:spcBef>
-              <a:spcAft>
-                <a:spcPts val="600"/>
-              </a:spcAft>
-            </a:pPr>
-            <a:r>
-              <a:rPr sz="2600" b="1" i="0">
-                <a:solidFill>
-                  <a:srgbClr val="1F6F8B"/>
-                </a:solidFill>
-                <a:latin typeface="Arial"/>
-              </a:rPr>
-              <a:t>$998K (+4.8%)</a:t>
-            </a:r>
-          </a:p>
-        </p:txBody>
-      </p:sp>
-      <p:sp>
-        <p:nvSpPr>
-          <p:cNvPr id="14" name="TextBox 13"/>
-          <p:cNvSpPr txBox="1"/>
-          <p:nvPr/>
-        </p:nvSpPr>
-        <p:spPr>
-          <a:xfrm>
-            <a:off x="6217920" y="3371088"/>
-            <a:ext cx="2514600" cy="149352"/>
-          </a:xfrm>
-          <a:prstGeom prst="rect">
-            <a:avLst/>
-          </a:prstGeom>
-          <a:noFill/>
-          <a:ln/>
-        </p:spPr>
-        <p:txBody>
-          <a:bodyPr wrap="square" anchor="t" lIns="25400" rIns="25400" tIns="25400" bIns="25400">
-            <a:spAutoFit/>
-          </a:bodyPr>
-          <a:lstStyle/>
-          <a:p>
-            <a:pPr algn="l">
-              <a:lnSpc>
-                <a:spcPct val="100000"/>
-              </a:lnSpc>
-              <a:spcBef>
-                <a:spcPts val="0"/>
-              </a:spcBef>
-              <a:spcAft>
-                <a:spcPts val="600"/>
-              </a:spcAft>
-            </a:pPr>
-            <a:r>
-              <a:rPr sz="1050" b="0" i="0">
-                <a:solidFill>
-                  <a:srgbClr val="6B6F76"/>
-                </a:solidFill>
-                <a:latin typeface="Arial"/>
-              </a:rPr>
-              <a:t>ARIMAX forecast, August 2027</a:t>
-            </a:r>
-          </a:p>
-        </p:txBody>
-      </p:sp>
-      <p:sp>
-        <p:nvSpPr>
-          <p:cNvPr id="15" name="TextBox 14"/>
-          <p:cNvSpPr txBox="1"/>
-          <p:nvPr/>
-        </p:nvSpPr>
-        <p:spPr>
-          <a:xfrm>
-            <a:off x="6217920" y="3630168"/>
-            <a:ext cx="2514600" cy="406400"/>
-          </a:xfrm>
-          <a:prstGeom prst="rect">
-            <a:avLst/>
-          </a:prstGeom>
-          <a:noFill/>
-          <a:ln/>
-        </p:spPr>
-        <p:txBody>
-          <a:bodyPr wrap="none" anchor="t" lIns="25400" rIns="25400" tIns="25400" bIns="25400">
-            <a:spAutoFit/>
-          </a:bodyPr>
-          <a:lstStyle/>
-          <a:p>
-            <a:pPr algn="l">
-              <a:lnSpc>
-                <a:spcPct val="100000"/>
-              </a:lnSpc>
-              <a:spcBef>
-                <a:spcPts val="0"/>
-              </a:spcBef>
-              <a:spcAft>
-                <a:spcPts val="600"/>
-              </a:spcAft>
-            </a:pPr>
-            <a:r>
-              <a:rPr sz="2600" b="1" i="0">
-                <a:solidFill>
-                  <a:srgbClr val="16213E"/>
-                </a:solidFill>
-                <a:latin typeface="Arial"/>
-              </a:rPr>
-              <a:t>-6% to +17%</a:t>
-            </a:r>
-          </a:p>
-        </p:txBody>
-      </p:sp>
-      <p:sp>
-        <p:nvSpPr>
-          <p:cNvPr id="16" name="TextBox 15"/>
-          <p:cNvSpPr txBox="1"/>
-          <p:nvPr/>
-        </p:nvSpPr>
-        <p:spPr>
-          <a:xfrm>
-            <a:off x="6217920" y="4036568"/>
-            <a:ext cx="2514600" cy="149352"/>
-          </a:xfrm>
-          <a:prstGeom prst="rect">
-            <a:avLst/>
-          </a:prstGeom>
-          <a:noFill/>
-          <a:ln/>
-        </p:spPr>
-        <p:txBody>
-          <a:bodyPr wrap="square" anchor="t" lIns="25400" rIns="25400" tIns="25400" bIns="25400">
-            <a:spAutoFit/>
-          </a:bodyPr>
-          <a:lstStyle/>
-          <a:p>
-            <a:pPr algn="l">
-              <a:lnSpc>
-                <a:spcPct val="100000"/>
-              </a:lnSpc>
-              <a:spcBef>
-                <a:spcPts val="0"/>
-              </a:spcBef>
-              <a:spcAft>
-                <a:spcPts val="600"/>
-              </a:spcAft>
-            </a:pPr>
-            <a:r>
-              <a:rPr sz="1050" b="0" i="0">
-                <a:solidFill>
-                  <a:srgbClr val="6B6F76"/>
-                </a:solidFill>
-                <a:latin typeface="Arial"/>
-              </a:rPr>
-              <a:t>80% range for the next 12 months</a:t>
+              <a:t>ARIMA 80% interval for Aug 2027, for context</a:t>
             </a:r>
           </a:p>
         </p:txBody>
@@ -10954,7 +11076,7 @@
                 </a:solidFill>
                 <a:latin typeface="Arial"/>
               </a:rPr>
-              <a:t>neighborhoods rising / flat / falling more than 2%, last 12 months</a:t>
+              <a:t>neighborhoods rising &gt;2% / within ±2% / falling &gt;2%, last 12 months (496 with recent data)</a:t>
             </a:r>
           </a:p>
         </p:txBody>
@@ -11183,6 +11305,7 @@
                   <a:srgbClr val="1F6F8B"/>
                 </a:solidFill>
                 <a:latin typeface="Arial"/>
+                <a:hlinkClick r:id="rId3"/>
               </a:rPr>
               <a:t>Live map: neiltd.github.io/la-housing-forecast</a:t>
             </a:r>

</xml_diff>

<commit_message>
Deck: second review - careful wording, plain-English tests, no causal claims
- Titles: 'ARIMAX had the lowest average forecast error', 'AI's edge faded once we removed the
  clues', 'Masking cut recognition, but didn't remove it', 'Our answer: simple models held up best'.
- Slide 3 tests in plain English; MAPE explained; slide 8 labels say VAR-estimated / for context.
- Rate-response chart retitled 'Estimated response to a 1-point rate shock'.
- Notes: transitions between presenters; month-12 test wording; no 'no model saw it'.

Co-Authored-By: Claude Opus 5.5 <noreply@anthropic.com>
Claude-Session: https://claude.ai/code/session_01MGxrqNkCGgpin2owaUrbi7
</commit_message>
<xml_diff>
--- a/slides/LA_home_values_slides.pptx
+++ b/slides/LA_home_values_slides.pptx
@@ -940,7 +940,7 @@
           <a:lstStyle/>
           <a:p>
             <a:r>
-              <a:t>Our answer: a simple ARIMAX had the lowest average error, about 2.7 percent; a full year out, the naive benchmark was just as good; and masked AI showed no clear advantage. Four takeaways. Simple time-series models beat complex ones, if you test over many windows. AI is a real alternative only when tested fairly, on data it can't remember. Mortgage rates matter, but slowly; jobs did not improve our model. And the metro average hides a split market. Next, we would test more cities, score the AI live after its training cutoff, and feed it altered histories to see whether it forecasts or recalls. Thank you.</a:t>
+              <a:t>Our answer: a simple ARIMAX had the lowest average error, about 2.7 percent; a full year out, the naive benchmark was just as good; and masked AI showed no clear advantage. Four takeaways. Simple models were competitive. Chatbots need tests on new outcomes before we can judge their forecasting value; the recognition checks suggest historical familiarity contributed to their apparent advantage. Rates showed a delayed relationship, and jobs did not improve our forecast. And the metro average is only part of the picture. Next, we would test more cities, score the AI live after its training cutoff, and feed it altered histories to see whether it forecasts or recalls. Thank you.</a:t>
             </a:r>
           </a:p>
         </p:txBody>
@@ -1080,7 +1080,7 @@
           <a:lstStyle/>
           <a:p>
             <a:r>
-              <a:t>Our data: the Zillow index, about 500 neighborhoods, the mortgage rate, and payroll jobs for LA and Orange County. We compared fourteen models, from a simple naive-drift benchmark to neural networks and Amazon's Chronos foundation model, plus three AI chatbots. Every model setting, including the mortgage-rate lag, was chosen on training data only. Our main test is rolling: at eighteen start dates, every three months, each model forecasts the next twelve months. The score is the average absolute percentage error across those months and dates. Lower is better.</a:t>
+              <a:t>That history gives us a difficult forecasting test. Our data: the Zillow index, about 500 neighborhoods, the mortgage rate, and payroll jobs for LA and Orange County. We compared fourteen models, from a simple naive-drift benchmark to neural networks and Amazon's Chronos foundation model, plus three AI chatbots. Every model setting, including the mortgage-rate lag, was chosen on training data only. Our main test repeats a twelve-month forecast at eighteen start dates, every three months. The score is the average absolute percentage error across those months and dates. Lower is better.</a:t>
             </a:r>
           </a:p>
         </p:txBody>
@@ -1150,7 +1150,7 @@
           <a:lstStyle/>
           <a:p>
             <a:r>
-              <a:t>ARIMAX, which is ARIMA plus the mortgage rate, had the lowest average error, 2.67 percent, just ahead of plain ARIMA at 2.77. The gap is small. Neural networks landed in the middle, tree models lower, and Prophet last, because it doesn't start from the latest value. The ranking holds in dollars too. One honest point: at exactly twelve months ahead every model is about five percent off, and the naive benchmark, 4.9 percent, is as good as ARIMAX, 5.0. The models help most in the first months.</a:t>
+              <a:t>ARIMAX, which is ARIMA plus the mortgage rate, had the lowest average error, 2.67 percent, just ahead of plain ARIMA at 2.77. The gap is small. Neural networks landed in the middle, tree models lower, and Prophet had the highest error in our test. The ranking holds in dollars too. One honest point: at twelve months ahead, ARIMAX and naive drift, which just extends the historical average growth, both have errors of about five percent: 5.0 and 4.9.</a:t>
             </a:r>
           </a:p>
         </p:txBody>
@@ -1220,7 +1220,7 @@
           <a:lstStyle/>
           <a:p>
             <a:r>
-              <a:t>Why test at eighteen dates instead of one? In a single 80/20 split, LightGBM, circled in red, won with 2.2 percent error. Across our rolling tests it ranked tenth, and ARIMAX, in green, was first. The single test forecasts 64 months at once, so it is a different task, but the lesson holds: one window can crown the wrong model.</a:t>
+              <a:t>Why test at eighteen dates instead of one? In a single 80/20 split, LightGBM, circled in red, won with 2.2 percent error. Across our rolling tests it ranked tenth, and ARIMAX, in green, was first. The long test forecasts 64 months at once, so it is a different task. The ranking depends on the forecast period and horizon, so we put more weight on repeated tests.</a:t>
             </a:r>
           </a:p>
         </p:txBody>
@@ -1290,7 +1290,7 @@
           <a:lstStyle/>
           <a:p>
             <a:r>
-              <a:t>Remember that lesson, because AI has the same trap. We asked Claude, GPT and Gemini to forecast the same eighteen dates, each as a fresh API request with only the data up to that date. At first they looked brilliant: 1.3 to 1.6 percent error, better than every model. But all eighteen dates are before their training cutoff, so they may remember what happened. When we hid the place, the dates and the mortgage rate, Claude's error rose to 2.8 percent, GPT's to 2.7 and Gemini's to 3.0. That is no better than ARIMAX; the difference is not statistically significant.</a:t>
+              <a:t>We then asked whether chatbots could improve on these results. Chatbots introduce another testing problem: they may recognize the historical period. We asked Claude, GPT and Gemini to forecast the same eighteen dates, each as a fresh API request with only the data up to that date. At first they looked brilliant: 1.3 to 1.6 percent error, better than every model. But all eighteen dates are before their training cutoff, so these periods may already be familiar to them. When we hid the place, the dates and the mortgage rate, Claude's error rose to 2.8 percent, GPT's to 2.7 and Gemini's to 3.0. Their average errors were close to ARIMAX's, and at month 12 our statistical test did not detect a difference.</a:t>
             </a:r>
           </a:p>
         </p:txBody>
@@ -1360,7 +1360,7 @@
           <a:lstStyle/>
           <a:p>
             <a:r>
-              <a:t>Here is how we gave the AI fewer clues. Named says Los Angeles, with real dates. Blind hides the place and dates but keeps the real mortgage rate, and that is enough: asked to identify the blind series, Claude named Los Angeles 16 times out of 18 and got the dates exactly right. Masked shows only the last ten years, rescaled, with no rate. Claude never named LA, though it could still guess the period from the shape, so masking reduces the clues rather than removing them. The chart shows April 2022, the peak. With the clues, Claude forecast a fall, close to what happened. Masked, it forecast another 12 percent rise, just like our ARIMAX. No model saw that turn coming.</a:t>
+              <a:t>Here is how we gave the AI fewer clues. Named says Los Angeles, with real dates. Blind hides the place and dates but keeps the real mortgage rate, and that is enough: asked to identify the blind series, Claude named Los Angeles 16 times out of 18 and got the dates exactly right. Masked shows only the last ten years, rescaled, with no rate. Claude never named LA, though it could still guess the period from the shape, so masking reduces the clues rather than removing them. The chart shows a forecast made in April 2022, just before the downturn. With the clues, Claude forecast a fall, close to what happened. With the masked prompt, Claude predicted continued growth, as ARIMAX did. The masked forecast and ARIMAX both missed the downturn.</a:t>
             </a:r>
           </a:p>
         </p:txBody>
@@ -1430,7 +1430,7 @@
           <a:lstStyle/>
           <a:p>
             <a:r>
-              <a:t>Back to our best model. Top: our VAR estimates how LA values respond after a one-point rise in the mortgage rate: little at first, about 4.5 percent lower after a year and 9 after two. That is a predictive relationship, not a proven causal effect, and the Granger test is borderline, p equals 0.052. Inside ARIMAX neither the rate nor jobs is significant on its own, but the rate still helps out of sample. It enters with a two-year lag, so a twelve-month forecast never needs future rates. Bottom: ARIMAX forecasts about 998 thousand dollars by August 2027, up 4.8 percent. The band is the ARIMA 80 percent interval, for context: from minus 6 to plus 17 percent.</a:t>
+              <a:t>We also examined the relationship with rates and produced a forecast for August 2027. Top: our VAR estimates how LA values respond after a one-point rise in the mortgage rate: little at first, about 4.5 percent lower after a year and 9 after two. That is a predictive relationship, not a proven causal effect, and the Granger test is borderline, p equals 0.052. Inside ARIMAX neither the rate nor jobs is significant on its own, but the rate still helps out of sample. It enters with a two-year lag, so a twelve-month forecast never needs future rates. Bottom: ARIMAX forecasts about 998 thousand dollars by August 2027, up 4.8 percent. The band is the ARIMA 80 percent interval, for context: from minus 6 to plus 17 percent.</a:t>
             </a:r>
           </a:p>
         </p:txBody>
@@ -1500,7 +1500,7 @@
           <a:lstStyle/>
           <a:p>
             <a:r>
-              <a:t>Now the neighborhoods. Of 496 neighborhoods with recent data, 220 rose more than 2 percent in the last year, 216 stayed within 2 percent, and 60 fell. [Switch to the browser.] Blue is rising, red is falling. Expensive coastal areas like Santa Monica, Malibu and Corona del Mar are rising; central LA, Koreatown and Downtown are falling. [Click one neighborhood.] Each shows its value, its change and our 12-month forecast. [Back to the slides.] After 2022, pricier LA County neighborhoods fell more: each doubling of price meant a 1.2-point deeper drop. We tested neighborhood forecasts the same rolling way, at five yearly dates for about 400 neighborhoods: ARIMA for each neighborhood had 2.8 percent error, the naive benchmark 3.5.</a:t>
+              <a:t>That forecast describes the metro average. Individual neighborhoods look very different. Of 496 neighborhoods with recent data, 220 rose more than 2 percent in the last year, 216 stayed within 2 percent, and 60 fell. [Switch to the browser.] Blue is rising, red is falling. The map shows gains in selected coastal neighborhoods, including North of Montana, Point Dume and Corona del Mar, and declines in parts of central LA such as Koreatown. [Click one neighborhood.] Each shows its value, its change and our 12-month forecast. [Back to the slides.] Higher starting prices were associated with larger declines in LA County after 2022. We tested neighborhood forecasts the same rolling way, at five yearly dates for about 400 neighborhoods: ARIMA for each neighborhood had 2.8 percent error, the naive benchmark 3.5.</a:t>
             </a:r>
           </a:p>
         </p:txBody>
@@ -4791,7 +4791,7 @@
                 </a:solidFill>
                 <a:latin typeface="Arial"/>
               </a:rPr>
-              <a:t>Zillow Home Value Index, LA metro, Jan 2000 to Aug 2026, plus 499 neighborhoods and the 30-year mortgage rate</a:t>
+              <a:t>Monthly Zillow home values for the LA metro, January 2000 to August 2026, with mortgage rates and neighborhood data</a:t>
             </a:r>
           </a:p>
         </p:txBody>
@@ -4979,7 +4979,7 @@
                 </a:solidFill>
                 <a:latin typeface="Arial"/>
               </a:rPr>
-              <a:t>What we learned, and what we would do next</a:t>
+              <a:t>Our answer: simple models held up best</a:t>
             </a:r>
           </a:p>
         </p:txBody>
@@ -5342,7 +5342,7 @@
                 </a:solidFill>
                 <a:latin typeface="Arial"/>
               </a:rPr>
-              <a:t>Simple beats complex, if you test fairly</a:t>
+              <a:t>Simple models were competitive</a:t>
             </a:r>
           </a:p>
         </p:txBody>
@@ -5388,7 +5388,7 @@
                 </a:solidFill>
                 <a:latin typeface="Arial"/>
               </a:rPr>
-              <a:t>ARIMA models beat ML and Chronos; one blind window would have crowned LightGBM (10th overall).</a:t>
+              <a:t>ARIMAX had the lowest average error; naive drift was equally competitive at month 12.</a:t>
             </a:r>
           </a:p>
         </p:txBody>
@@ -5512,7 +5512,7 @@
                 </a:solidFill>
                 <a:latin typeface="Arial"/>
               </a:rPr>
-              <a:t>AI is an alternative only if you test it fairly</a:t>
+              <a:t>Test chatbots on outcomes they cannot know</a:t>
             </a:r>
           </a:p>
         </p:txBody>
@@ -5558,7 +5558,7 @@
                 </a:solidFill>
                 <a:latin typeface="Arial"/>
               </a:rPr>
-              <a:t>Chatbots beat every model until we hid the place, dates and rate; then no clear edge over ARIMAX.</a:t>
+              <a:t>Historical chatbot tests can be affected by recognition of past events.</a:t>
             </a:r>
           </a:p>
         </p:txBody>
@@ -5682,7 +5682,7 @@
                 </a:solidFill>
                 <a:latin typeface="Arial"/>
               </a:rPr>
-              <a:t>Mortgage rates matter, slowly; jobs didn't improve our model</a:t>
+              <a:t>Rates showed a delayed relationship</a:t>
             </a:r>
           </a:p>
         </p:txBody>
@@ -5728,7 +5728,7 @@
                 </a:solidFill>
                 <a:latin typeface="Arial"/>
               </a:rPr>
-              <a:t>A 1-point rise lowers values about 9% over two years. Turning points stay hard to call.</a:t>
+              <a:t>Adding jobs did not improve our forecast; turning points stayed hard to call.</a:t>
             </a:r>
           </a:p>
         </p:txBody>
@@ -5852,7 +5852,7 @@
                 </a:solidFill>
                 <a:latin typeface="Arial"/>
               </a:rPr>
-              <a:t>The metro average hides a split market</a:t>
+              <a:t>The metro average is only part of the picture</a:t>
             </a:r>
           </a:p>
         </p:txBody>
@@ -5898,7 +5898,7 @@
                 </a:solidFill>
                 <a:latin typeface="Arial"/>
               </a:rPr>
-              <a:t>Separate models per neighborhood beat one shared factor (2.8% vs 4.1% error).</a:t>
+              <a:t>Results varied; per-neighborhood ARIMA beat naive drift (2.8% vs 3.5%).</a:t>
             </a:r>
           </a:p>
         </p:txBody>
@@ -6016,7 +6016,7 @@
                 </a:solidFill>
                 <a:latin typeface="Arial"/>
               </a:rPr>
-              <a:t>LA values grew 5.6% a year for 26 years, then stalled when rates hit 7%</a:t>
+              <a:t>After decades of growth, LA home values have stalled</a:t>
             </a:r>
           </a:p>
         </p:txBody>
@@ -6254,7 +6254,7 @@
                 </a:solidFill>
                 <a:latin typeface="Arial"/>
               </a:rPr>
-              <a:t>typical LA-metro home, August 2026</a:t>
+              <a:t>Typical home value, LA metro, August 2026</a:t>
             </a:r>
           </a:p>
         </p:txBody>
@@ -6346,7 +6346,7 @@
                 </a:solidFill>
                 <a:latin typeface="Arial"/>
               </a:rPr>
-              <a:t>vs the January 2025 peak of $965,634</a:t>
+              <a:t>Below the January 2025 peak</a:t>
             </a:r>
           </a:p>
         </p:txBody>
@@ -6556,7 +6556,7 @@
                 </a:solidFill>
                 <a:latin typeface="Arial"/>
               </a:rPr>
-              <a:t>We compared 14 models across 18 forecast dates</a:t>
+              <a:t>We tested 14 models at 18 forecast dates</a:t>
             </a:r>
           </a:p>
         </p:txBody>
@@ -6795,7 +6795,7 @@
                 </a:solidFill>
                 <a:latin typeface="Arial"/>
               </a:rPr>
-              <a:t>Error = average absolute % gap between the forecast and Zillow's actual value (MAPE), over 1 to 12 months ahead and all 18 start dates. Lower is better; RMSE in dollars agrees.</a:t>
+              <a:t>MAPE measures how far forecasts are from actual values, in percent. We average the absolute errors across months 1 to 12 and all 18 start dates. Lower is better.</a:t>
             </a:r>
           </a:p>
         </p:txBody>
@@ -7193,7 +7193,7 @@
                 </a:solidFill>
                 <a:latin typeface="Arial"/>
               </a:rPr>
-              <a:t>14 MODELS + 3 LLMS</a:t>
+              <a:t>14 MODELS + 3 CHATBOTS</a:t>
             </a:r>
           </a:p>
         </p:txBody>
@@ -7545,7 +7545,7 @@
                 </a:solidFill>
                 <a:latin typeface="Arial"/>
               </a:rPr>
-              <a:t>Plus 3 chat LLMs</a:t>
+              <a:t>Plus 3 AI chatbots</a:t>
             </a:r>
           </a:p>
         </p:txBody>
@@ -7637,7 +7637,7 @@
                 </a:solidFill>
                 <a:latin typeface="Arial"/>
               </a:rPr>
-              <a:t>2 TESTS</a:t>
+              <a:t>HOW WE TESTED</a:t>
             </a:r>
           </a:p>
         </p:txBody>
@@ -7681,7 +7681,7 @@
         <p:spPr>
           <a:xfrm>
             <a:off x="6217919" y="1792224"/>
-            <a:ext cx="2560319" cy="170688"/>
+            <a:ext cx="2560319" cy="341376"/>
           </a:xfrm>
           <a:prstGeom prst="rect">
             <a:avLst/>
@@ -7713,7 +7713,7 @@
                 </a:solidFill>
                 <a:latin typeface="Arial"/>
               </a:rPr>
-              <a:t>1. Rolling origin (main)</a:t>
+              <a:t>1. Repeated 12-month forecasts (main)</a:t>
             </a:r>
           </a:p>
         </p:txBody>
@@ -7726,7 +7726,7 @@
         </p:nvSpPr>
         <p:spPr>
           <a:xfrm>
-            <a:off x="6217919" y="1962912"/>
+            <a:off x="6217919" y="2133600"/>
             <a:ext cx="2560319" cy="298704"/>
           </a:xfrm>
           <a:prstGeom prst="rect">
@@ -7759,7 +7759,7 @@
                 </a:solidFill>
                 <a:latin typeface="Arial"/>
               </a:rPr>
-              <a:t>Refit every 3 months, forecast 12 months ahead, 18 times</a:t>
+              <a:t>Update each model every 3 months; repeat at 18 start dates</a:t>
             </a:r>
           </a:p>
         </p:txBody>
@@ -7772,7 +7772,7 @@
         </p:nvSpPr>
         <p:spPr>
           <a:xfrm>
-            <a:off x="6217919" y="2334768"/>
+            <a:off x="6217919" y="2505456"/>
             <a:ext cx="2560319" cy="170688"/>
           </a:xfrm>
           <a:prstGeom prst="rect">
@@ -7805,7 +7805,7 @@
                 </a:solidFill>
                 <a:latin typeface="Arial"/>
               </a:rPr>
-              <a:t>2. Single blind 80/20</a:t>
+              <a:t>2. One long forecast</a:t>
             </a:r>
           </a:p>
         </p:txBody>
@@ -7818,7 +7818,7 @@
         </p:nvSpPr>
         <p:spPr>
           <a:xfrm>
-            <a:off x="6217919" y="2505456"/>
+            <a:off x="6217919" y="2676144"/>
             <a:ext cx="2560319" cy="298704"/>
           </a:xfrm>
           <a:prstGeom prst="rect">
@@ -7851,7 +7851,7 @@
                 </a:solidFill>
                 <a:latin typeface="Arial"/>
               </a:rPr>
-              <a:t>Train to Apr 2021, forecast 64 months in one shot</a:t>
+              <a:t>Train through April 2021, then forecast the next 64 months</a:t>
             </a:r>
           </a:p>
         </p:txBody>
@@ -7923,7 +7923,7 @@
                 </a:solidFill>
                 <a:latin typeface="Arial"/>
               </a:rPr>
-              <a:t>RESULT 1 · ROLLING TEST</a:t>
+              <a:t>RESULT 1 · REPEATED 12-MONTH FORECASTS</a:t>
             </a:r>
           </a:p>
         </p:txBody>
@@ -7937,7 +7937,7 @@
         <p:spPr>
           <a:xfrm>
             <a:off x="502920" y="493776"/>
-            <a:ext cx="8138160" cy="792479"/>
+            <a:ext cx="8138160" cy="640080"/>
           </a:xfrm>
           <a:prstGeom prst="rect">
             <a:avLst/>
@@ -7969,7 +7969,7 @@
                 </a:solidFill>
                 <a:latin typeface="Arial"/>
               </a:rPr>
-              <a:t>In the fair test, ARIMA-family models beat machine learning</a:t>
+              <a:t>ARIMAX had the lowest average forecast error</a:t>
             </a:r>
           </a:p>
         </p:txBody>
@@ -7982,7 +7982,7 @@
         </p:nvSpPr>
         <p:spPr>
           <a:xfrm>
-            <a:off x="521207" y="1341120"/>
+            <a:off x="521207" y="1060704"/>
             <a:ext cx="1005840" cy="41148"/>
           </a:xfrm>
           <a:prstGeom prst="rect">
@@ -8105,8 +8105,8 @@
           <p:nvPr/>
         </p:nvGraphicFramePr>
         <p:xfrm>
-          <a:off x="457200" y="1569720"/>
-          <a:ext cx="5394960" cy="2979419"/>
+          <a:off x="457200" y="1289304"/>
+          <a:ext cx="5394960" cy="3259835"/>
         </p:xfrm>
         <a:graphic>
           <a:graphicData uri="http://schemas.openxmlformats.org/drawingml/2006/chart">
@@ -8122,7 +8122,7 @@
         </p:nvSpPr>
         <p:spPr>
           <a:xfrm>
-            <a:off x="6126480" y="1661160"/>
+            <a:off x="6126480" y="1380744"/>
             <a:ext cx="2606040" cy="274320"/>
           </a:xfrm>
           <a:prstGeom prst="rect">
@@ -8168,7 +8168,7 @@
         </p:nvSpPr>
         <p:spPr>
           <a:xfrm>
-            <a:off x="6126480" y="1972056"/>
+            <a:off x="6126480" y="1691640"/>
             <a:ext cx="2606040" cy="822960"/>
           </a:xfrm>
           <a:prstGeom prst="rect">
@@ -8214,8 +8214,8 @@
         </p:nvSpPr>
         <p:spPr>
           <a:xfrm>
-            <a:off x="6126480" y="2849880"/>
-            <a:ext cx="2606040" cy="1280160"/>
+            <a:off x="6126480" y="2569464"/>
+            <a:ext cx="2606040" cy="1536191"/>
           </a:xfrm>
           <a:prstGeom prst="rect">
             <a:avLst/>
@@ -8247,7 +8247,7 @@
                 </a:solidFill>
                 <a:latin typeface="Arial"/>
               </a:rPr>
-              <a:t>ARIMAX (ARIMA + mortgage rate), average error 1 to 12 months ahead; ARIMA 2.77%. At 12 months: ARIMAX 5.0%, naive drift 4.9%.</a:t>
+              <a:t>average error across months 1 to 12. ARIMAX adds mortgage-rate information to ARIMA; plain ARIMA was close, at 2.77%. At month 12 alone: ARIMAX 5.0%, naive drift 4.9%.</a:t>
             </a:r>
           </a:p>
         </p:txBody>
@@ -8319,7 +8319,7 @@
                 </a:solidFill>
                 <a:latin typeface="Arial"/>
               </a:rPr>
-              <a:t>RESULT 2 · SINGLE BLIND TEST (ONE WINDOW)</a:t>
+              <a:t>RESULT 2 · ONE LONG FORECAST</a:t>
             </a:r>
           </a:p>
         </p:txBody>
@@ -8365,7 +8365,7 @@
                 </a:solidFill>
                 <a:latin typeface="Arial"/>
               </a:rPr>
-              <a:t>One test window crowned LightGBM; 18 windows ranked it tenth</a:t>
+              <a:t>LightGBM ranked first in one long test, but tenth in repeated 12-month tests</a:t>
             </a:r>
           </a:p>
         </p:txBody>
@@ -8649,7 +8649,7 @@
                 </a:solidFill>
                 <a:latin typeface="Arial"/>
               </a:rPr>
-              <a:t>LightGBM won the single 64-month test (2.2% error) but ranked 10th across 18 rolling 12-month tests: its lead did not hold.</a:t>
+              <a:t>1st in the 64-month test (2.2% error), 10th in repeated 12-month tests. LightGBM's lead did not hold under our main evaluation.</a:t>
             </a:r>
           </a:p>
         </p:txBody>
@@ -8767,7 +8767,7 @@
                 </a:solidFill>
                 <a:latin typeface="Arial"/>
               </a:rPr>
-              <a:t>An alternative tool: AI won by memory, not forecasting</a:t>
+              <a:t>An alternative tool: AI's edge faded once we removed the clues</a:t>
             </a:r>
           </a:p>
         </p:txBody>
@@ -8959,7 +8959,7 @@
                 </a:solidFill>
                 <a:latin typeface="Arial"/>
               </a:rPr>
-              <a:t>SAME MODEL, DATES HIDDEN</a:t>
+              <a:t>CLAUDE: NAMED → MASKED</a:t>
             </a:r>
           </a:p>
         </p:txBody>
@@ -9051,7 +9051,7 @@
                 </a:solidFill>
                 <a:latin typeface="Arial"/>
               </a:rPr>
-              <a:t>Claude's error once it could not tell the place, dates or mortgage rate (ARIMAX 2.67%). All test dates are inside the LLMs' training data.</a:t>
+              <a:t>Claude's average error rose from 1.3% to 2.8%, close to ARIMAX's 2.67%. These historical periods may already be familiar to the chatbots.</a:t>
             </a:r>
           </a:p>
         </p:txBody>
@@ -9169,7 +9169,7 @@
                 </a:solidFill>
                 <a:latin typeface="Arial"/>
               </a:rPr>
-              <a:t>The LLMs' edge disappears once we mask the data</a:t>
+              <a:t>Masking cut recognition, but didn't remove it</a:t>
             </a:r>
           </a:p>
         </p:txBody>
@@ -9408,7 +9408,7 @@
                 </a:solidFill>
                 <a:latin typeface="Arial"/>
               </a:rPr>
-              <a:t>LA identified: blind 16 of 18 (dates exactly right); masked 0 of 18. The period can still be guessed from the shape.</a:t>
+              <a:t>Claude identified LA in 16/18 blind prompts and 0/18 masked prompts. It could still estimate the period from the masked data.</a:t>
             </a:r>
           </a:p>
         </p:txBody>
@@ -9532,7 +9532,7 @@
                 </a:solidFill>
                 <a:latin typeface="Arial"/>
               </a:rPr>
-              <a:t>LA, real dates, dollars, mortgage rate</a:t>
+              <a:t>LA, real dates, dollars, rates</a:t>
             </a:r>
           </a:p>
         </p:txBody>
@@ -9578,7 +9578,7 @@
                 </a:solidFill>
                 <a:latin typeface="Arial"/>
               </a:rPr>
-              <a:t>Leaks: it knows the place and the years</a:t>
+              <a:t>Most clues</a:t>
             </a:r>
           </a:p>
         </p:txBody>
@@ -9702,7 +9702,7 @@
                 </a:solidFill>
                 <a:latin typeface="Arial"/>
               </a:rPr>
-              <a:t>No place or dates, but the real rate</a:t>
+              <a:t>Place, dates hidden; rates kept</a:t>
             </a:r>
           </a:p>
         </p:txBody>
@@ -9748,7 +9748,7 @@
                 </a:solidFill>
                 <a:latin typeface="Arial"/>
               </a:rPr>
-              <a:t>Leaks: the 2022 rate jump dates the series</a:t>
+              <a:t>Rates can reveal dates</a:t>
             </a:r>
           </a:p>
         </p:txBody>
@@ -9872,7 +9872,7 @@
                 </a:solidFill>
                 <a:latin typeface="Arial"/>
               </a:rPr>
-              <a:t>Last 10 years, rescaled; no place or rate</a:t>
+              <a:t>10 years, rescaled; no place, dates, rates</a:t>
             </a:r>
           </a:p>
         </p:txBody>
@@ -9918,7 +9918,7 @@
                 </a:solidFill>
                 <a:latin typeface="Arial"/>
               </a:rPr>
-              <a:t>Fewest clues; period still guessable</a:t>
+              <a:t>Fewest clues</a:t>
             </a:r>
           </a:p>
         </p:txBody>
@@ -10060,7 +10060,7 @@
                 </a:solidFill>
                 <a:latin typeface="Arial"/>
               </a:rPr>
-              <a:t>Rates act slowly; we forecast +5% by Aug 2027</a:t>
+              <a:t>Rates act with a delay; we forecast +4.8%</a:t>
             </a:r>
           </a:p>
         </p:txBody>
@@ -10228,7 +10228,7 @@
                 </a:solidFill>
                 <a:latin typeface="Arial"/>
               </a:rPr>
-              <a:t>LA HOUSING VALUE VS MORTGAGE RATES</a:t>
+              <a:t>ESTIMATED HOME-VALUE RESPONSE TO A 1-POINT MORTGAGE-RATE SHOCK</a:t>
             </a:r>
           </a:p>
         </p:txBody>
@@ -10344,7 +10344,7 @@
                 </a:solidFill>
                 <a:latin typeface="Arial"/>
               </a:rPr>
-              <a:t>two years after a 1-point rate rise (−4.5% after one)</a:t>
+              <a:t>VAR-estimated response after two years (−4.5% after one)</a:t>
             </a:r>
           </a:p>
         </p:txBody>
@@ -10436,7 +10436,7 @@
                 </a:solidFill>
                 <a:latin typeface="Arial"/>
               </a:rPr>
-              <a:t>rates lead prices (Granger, borderline). ARIMAX: rate p = 0.16, jobs p = 0.29</a:t>
+              <a:t>Granger: borderline. ARIMAX: rate p = 0.16, jobs p = 0.29</a:t>
             </a:r>
           </a:p>
         </p:txBody>
@@ -10688,7 +10688,7 @@
         <p:spPr>
           <a:xfrm>
             <a:off x="6263640" y="4016502"/>
-            <a:ext cx="2514600" cy="135128"/>
+            <a:ext cx="2514600" cy="270256"/>
           </a:xfrm>
           <a:prstGeom prst="rect">
             <a:avLst/>
@@ -10720,7 +10720,7 @@
                 </a:solidFill>
                 <a:latin typeface="Arial"/>
               </a:rPr>
-              <a:t>ARIMA 80% interval for Aug 2027, for context</a:t>
+              <a:t>for context: ARIMA's 80% interval by August 2027</a:t>
             </a:r>
           </a:p>
         </p:txBody>
@@ -10838,7 +10838,7 @@
                 </a:solidFill>
                 <a:latin typeface="Arial"/>
               </a:rPr>
-              <a:t>The metro average hides a split market, neighborhood by neighborhood</a:t>
+              <a:t>Some neighborhoods are rising while others are falling</a:t>
             </a:r>
           </a:p>
         </p:txBody>
@@ -11076,7 +11076,7 @@
                 </a:solidFill>
                 <a:latin typeface="Arial"/>
               </a:rPr>
-              <a:t>neighborhoods rising &gt;2% / within ±2% / falling &gt;2%, last 12 months (496 with recent data)</a:t>
+              <a:t>rising &gt;2% · within ±2% · falling &gt;2%, last 12 months (496 neighborhoods with recent data)</a:t>
             </a:r>
           </a:p>
         </p:txBody>
@@ -11260,7 +11260,7 @@
                 </a:solidFill>
                 <a:latin typeface="Arial"/>
               </a:rPr>
-              <a:t>deeper 2022 drop per doubling of price in LA County (reverses in Orange County)</a:t>
+              <a:t>in LA County, doubling the starting home value went with a 1.2-point larger decline after the 2022 peak</a:t>
             </a:r>
           </a:p>
         </p:txBody>

</xml_diff>

<commit_message>
Slides 3-5: name the tests 'rolling-origin' and 'single 80/20 split' with plain explanations
Co-Authored-By: Claude Opus 5.5 <noreply@anthropic.com>
Claude-Session: https://claude.ai/code/session_01MGxrqNkCGgpin2owaUrbi7
</commit_message>
<xml_diff>
--- a/slides/LA_home_values_slides.pptx
+++ b/slides/LA_home_values_slides.pptx
@@ -1080,7 +1080,7 @@
           <a:lstStyle/>
           <a:p>
             <a:r>
-              <a:t>That history gives us a difficult forecasting test. Our data: the Zillow index, about 500 neighborhoods, the mortgage rate, and payroll jobs for LA and Orange County. We compared fourteen models, from a simple naive-drift benchmark to neural networks and Amazon's Chronos foundation model, plus three AI chatbots. Every model setting, including the mortgage-rate lag, was chosen on training data only. Our main test repeats a twelve-month forecast at eighteen start dates, every three months. The score is the average absolute percentage error across those months and dates. Lower is better.</a:t>
+              <a:t>That history gives us a difficult forecasting test. Our data: the Zillow index, about 500 neighborhoods, the mortgage rate, and payroll jobs for LA and Orange County. We compared fourteen models, from a simple naive-drift benchmark to neural networks and Amazon's Chronos foundation model, plus three AI chatbots. Every model setting, including the mortgage-rate lag, was chosen on training data only. Our main test is a rolling-origin test: we repeat a twelve-month forecast at eighteen start dates, every three months. The score is the average absolute percentage error across those months and dates. Lower is better.</a:t>
             </a:r>
           </a:p>
         </p:txBody>
@@ -7681,7 +7681,7 @@
         <p:spPr>
           <a:xfrm>
             <a:off x="6217919" y="1792224"/>
-            <a:ext cx="2560319" cy="341376"/>
+            <a:ext cx="2560319" cy="170688"/>
           </a:xfrm>
           <a:prstGeom prst="rect">
             <a:avLst/>
@@ -7713,7 +7713,7 @@
                 </a:solidFill>
                 <a:latin typeface="Arial"/>
               </a:rPr>
-              <a:t>1. Repeated 12-month forecasts (main)</a:t>
+              <a:t>1. Rolling-origin test (main)</a:t>
             </a:r>
           </a:p>
         </p:txBody>
@@ -7726,7 +7726,7 @@
         </p:nvSpPr>
         <p:spPr>
           <a:xfrm>
-            <a:off x="6217919" y="2133600"/>
+            <a:off x="6217919" y="1962912"/>
             <a:ext cx="2560319" cy="298704"/>
           </a:xfrm>
           <a:prstGeom prst="rect">
@@ -7759,7 +7759,7 @@
                 </a:solidFill>
                 <a:latin typeface="Arial"/>
               </a:rPr>
-              <a:t>Update each model every 3 months; repeat at 18 start dates</a:t>
+              <a:t>Repeated 12-month forecasts: update every 3 months, 18 start dates</a:t>
             </a:r>
           </a:p>
         </p:txBody>
@@ -7772,7 +7772,7 @@
         </p:nvSpPr>
         <p:spPr>
           <a:xfrm>
-            <a:off x="6217919" y="2505456"/>
+            <a:off x="6217919" y="2334768"/>
             <a:ext cx="2560319" cy="170688"/>
           </a:xfrm>
           <a:prstGeom prst="rect">
@@ -7805,7 +7805,7 @@
                 </a:solidFill>
                 <a:latin typeface="Arial"/>
               </a:rPr>
-              <a:t>2. One long forecast</a:t>
+              <a:t>2. Single 80/20 split</a:t>
             </a:r>
           </a:p>
         </p:txBody>
@@ -7818,7 +7818,7 @@
         </p:nvSpPr>
         <p:spPr>
           <a:xfrm>
-            <a:off x="6217919" y="2676144"/>
+            <a:off x="6217919" y="2505456"/>
             <a:ext cx="2560319" cy="298704"/>
           </a:xfrm>
           <a:prstGeom prst="rect">
@@ -7923,7 +7923,7 @@
                 </a:solidFill>
                 <a:latin typeface="Arial"/>
               </a:rPr>
-              <a:t>RESULT 1 · REPEATED 12-MONTH FORECASTS</a:t>
+              <a:t>RESULT 1 · ROLLING-ORIGIN TEST</a:t>
             </a:r>
           </a:p>
         </p:txBody>
@@ -8319,7 +8319,7 @@
                 </a:solidFill>
                 <a:latin typeface="Arial"/>
               </a:rPr>
-              <a:t>RESULT 2 · ONE LONG FORECAST</a:t>
+              <a:t>RESULT 2 · SINGLE 80/20 SPLIT</a:t>
             </a:r>
           </a:p>
         </p:txBody>

</xml_diff>

<commit_message>
Slides 3 and 5: call test 2 'one long forecast'
Co-Authored-By: Claude Opus 5.5 <noreply@anthropic.com>
Claude-Session: https://claude.ai/code/session_01MGxrqNkCGgpin2owaUrbi7
</commit_message>
<xml_diff>
--- a/slides/LA_home_values_slides.pptx
+++ b/slides/LA_home_values_slides.pptx
@@ -7805,7 +7805,7 @@
                 </a:solidFill>
                 <a:latin typeface="Arial"/>
               </a:rPr>
-              <a:t>2. Single 80/20 split</a:t>
+              <a:t>2. One long forecast</a:t>
             </a:r>
           </a:p>
         </p:txBody>
@@ -7851,7 +7851,7 @@
                 </a:solidFill>
                 <a:latin typeface="Arial"/>
               </a:rPr>
-              <a:t>Train through April 2021, then forecast the next 64 months</a:t>
+              <a:t>Train on the first 80% (to April 2021), then forecast the next 64 months in one shot</a:t>
             </a:r>
           </a:p>
         </p:txBody>
@@ -8319,7 +8319,7 @@
                 </a:solidFill>
                 <a:latin typeface="Arial"/>
               </a:rPr>
-              <a:t>RESULT 2 · SINGLE 80/20 SPLIT</a:t>
+              <a:t>RESULT 2 · ONE LONG FORECAST</a:t>
             </a:r>
           </a:p>
         </p:txBody>

</xml_diff>

<commit_message>
Apply Jeremy's repo review: slide fixes, appendix pack, result tables
- Slide 2: before/after inflation chart (fig 23) with the rate; -7.1% vs the 2022 real peak; 39% crash
- "AI" wording throughout; slide 7 adds the full-history check; next steps drop altered histories
- Takeaway 3: rates matter slowly; jobs, income and crime didn't help
- Speaker notes tagged by presenter (Yang 1-3, 10; Neil 4, 5, 8; Jeremy 6, 7; Jin 9)
- Appendix pack A1-A6 replaces the crime-only appendix
- Commit analysis/figures/*.csv; README: DM p >= 0.84 at 12 months, 108 prompts, data provenance

Co-Authored-By: Claude Opus 5.5 <noreply@anthropic.com>
Claude-Session: https://claude.ai/code/session_01MGxrqNkCGgpin2owaUrbi7
</commit_message>
<xml_diff>
--- a/slides/LA_home_values_slides.pptx
+++ b/slides/LA_home_values_slides.pptx
@@ -870,7 +870,7 @@
           <a:lstStyle/>
           <a:p>
             <a:r>
-              <a:t>Hi everyone. We forecast home values in the Los Angeles metro, using Zillow's monthly index from 2000 to August 2026. The line shows the whole story: a boom and bust in the 2000s, a long recovery, a pandemic surge, then a stall. Our question: how well can we forecast LA home values up to a year ahead, and what works best? We compare traditional time-series models with an alternative many people now try first: asking an AI chatbot.</a:t>
+              <a:t>[Yang] Hi everyone. We forecast home values in the Los Angeles metro, using Zillow's monthly index from 2000 to August 2026. The line shows the whole story: a boom and bust in the 2000s, a long recovery, a pandemic surge, then a stall. Our question: how well can we forecast LA home values up to a year ahead, and what works best? We compare traditional time-series models with an alternative many people now try first: asking an AI chatbot. From here on we just say AI, or LLM. We asked each one through its API, one fresh question at a time, with no conversation history.</a:t>
             </a:r>
           </a:p>
         </p:txBody>
@@ -940,7 +940,7 @@
           <a:lstStyle/>
           <a:p>
             <a:r>
-              <a:t>Our answer: a simple ARIMAX had the lowest average error, about 2.7 percent; a full year out, the naive benchmark was just as good; and masked AI showed no clear advantage. Four takeaways. Simple models were competitive. Chatbots need tests on new outcomes before we can judge their forecasting value; the recognition checks suggest historical familiarity contributed to their apparent advantage. Rates showed a delayed relationship, and jobs did not improve our forecast. And the metro average is only part of the picture. Next, we would test more cities, score the AI live after its training cutoff, and feed it altered histories to see whether it forecasts or recalls. Thank you.</a:t>
+              <a:t>[Yang] Our answer: a simple ARIMAX had the lowest average error, about 2.7 percent; a full year out, the naive benchmark was just as good; and masked AI showed no clear advantage. Four takeaways. Simple models were competitive. AI needs tests on new outcomes before we can judge its forecasting value; the recognition checks suggest historical familiarity contributed to its apparent advantage. Mortgage rates matter, slowly, while jobs, income and crime didn't improve the forecast. And the metro average is only part of the picture. Next, we would test more cities, and score the AI live after its training cutoff. Thank you.</a:t>
             </a:r>
           </a:p>
         </p:txBody>
@@ -1010,7 +1010,7 @@
           <a:lstStyle/>
           <a:p>
             <a:r>
-              <a:t>From 2000 to 2026, LA home values grew about 5.6 percent a year on average, with a 37 percent crash from 2006 to 2012. The dashed line is a fitted trend, about 4.5 percent a year, and prices today sit close to it. The typical home is worth about 952 thousand dollars, 1.3 percent below the January 2025 peak. The bottom panel shows why this is a hard test: the 30-year mortgage rate went from 2.7 percent in 2021 to 7.6 percent in 2023, and the shaded test window runs right through that shock.</a:t>
+              <a:t>[Yang] From 2000 to 2026, LA home values grew about 5.6 percent a year on average, with a 39 percent crash from 2006 to 2012. The typical home is worth about 952 thousand dollars, 1.3 percent below the January 2025 peak. The orange line takes out inflation: in today's dollars, LA is about 7 percent below its 2022 peak, not 1 percent. The bottom panel shows why this is a hard test: the 30-year mortgage rate went from 2.7 percent in 2021 to 7.6 percent in 2023, and the shaded test window runs right through that shock.</a:t>
             </a:r>
           </a:p>
         </p:txBody>
@@ -1080,7 +1080,7 @@
           <a:lstStyle/>
           <a:p>
             <a:r>
-              <a:t>That history gives us a difficult forecasting test. Our data: the Zillow index, about 500 neighborhoods, the mortgage rate, and payroll jobs for LA and Orange County. We compared fourteen models, from a simple naive-drift benchmark to neural networks and Amazon's Chronos foundation model, plus three AI chatbots. Every model setting, including the mortgage-rate lag, was chosen on training data only. Our main test is a rolling-origin test: we repeat a twelve-month forecast at eighteen start dates, every three months. The score is the average absolute percentage error across those months and dates. Lower is better.</a:t>
+              <a:t>[Yang] That history gives us a difficult forecasting test. Our data: the Zillow index, about 500 neighborhoods, the mortgage rate, and payroll jobs for LA and Orange County. We compared fourteen models, from a simple naive-drift benchmark to neural networks and Amazon's Chronos foundation model, plus three AI models. Every model setting, including the mortgage-rate lag, was chosen on training data only. Our main test is a rolling-origin test: we repeat a twelve-month forecast at eighteen start dates, every three months. The score is the average absolute percentage error across those months and dates. Lower is better.</a:t>
             </a:r>
           </a:p>
         </p:txBody>
@@ -1150,7 +1150,7 @@
           <a:lstStyle/>
           <a:p>
             <a:r>
-              <a:t>ARIMAX, which is ARIMA plus the mortgage rate, had the lowest average error, 2.67 percent, just ahead of plain ARIMA at 2.77. The gap is small. Neural networks landed in the middle, tree models lower, and Prophet had the highest error in our test. The ranking holds in dollars too. One honest point: at twelve months ahead, ARIMAX and naive drift, which just extends the historical average growth, both have errors of about five percent: 5.0 and 4.9.</a:t>
+              <a:t>[Neil] ARIMAX, which is ARIMA plus the mortgage rate, had the lowest average error, 2.67 percent, just ahead of plain ARIMA at 2.77. The gap is small. Neural networks landed in the middle, tree models lower, and Prophet had the highest error in our test. The ranking holds in dollars too. One honest point: at twelve months ahead, ARIMAX and naive drift, which just extends the historical average growth, both have errors of about five percent: 5.0 and 4.9.</a:t>
             </a:r>
           </a:p>
         </p:txBody>
@@ -1220,7 +1220,7 @@
           <a:lstStyle/>
           <a:p>
             <a:r>
-              <a:t>Why test at eighteen dates instead of one? In a single 80/20 split, LightGBM, circled in red, won with 2.2 percent error. Across our rolling tests it ranked tenth, and ARIMAX, in green, was first. The long test forecasts 64 months at once, so it is a different task. The ranking depends on the forecast period and horizon, so we put more weight on repeated tests.</a:t>
+              <a:t>[Neil] Why test at eighteen dates instead of one? In a single 80/20 split, LightGBM, circled in red, won with 2.2 percent error. Across our rolling tests it ranked tenth, and ARIMAX, in green, was first. The long test forecasts 64 months at once, so it is a different task. The ranking depends on the forecast period and horizon, so we put more weight on repeated tests.</a:t>
             </a:r>
           </a:p>
         </p:txBody>
@@ -1290,7 +1290,7 @@
           <a:lstStyle/>
           <a:p>
             <a:r>
-              <a:t>We then asked whether chatbots could improve on these results. Chatbots introduce another testing problem: they may recognize the historical period. We asked Claude, GPT and Gemini to forecast the same eighteen dates, each as a fresh API request with only the data up to that date. At first they looked brilliant: 1.3 to 1.6 percent error, better than every model. But all eighteen dates are before their training cutoff, so these periods may already be familiar to them. When we hid the place, the dates and the mortgage rate, Claude's error rose to 2.8 percent, GPT's to 2.7 and Gemini's to 3.0. Their average errors were close to ARIMAX's, and at month 12 our statistical test did not detect a difference.</a:t>
+              <a:t>[Jeremy] We then asked whether AI could improve on these results. AI introduces another testing problem: they may recognize the historical period. We asked Claude, GPT and Gemini to forecast the same eighteen dates, each as a fresh API request with only the data up to that date. At first they looked brilliant: 1.3 to 1.6 percent error, better than every model. But all eighteen dates are before their training cutoff, so these periods may already be familiar to them. When we hid the place, the dates and the mortgage rate, Claude's error rose to 2.8 percent, GPT's to 2.7 and Gemini's to 3.0. Their average errors were close to ARIMAX's, and at month 12 our statistical test did not detect a difference.</a:t>
             </a:r>
           </a:p>
         </p:txBody>
@@ -1360,7 +1360,7 @@
           <a:lstStyle/>
           <a:p>
             <a:r>
-              <a:t>Here is how we gave the AI fewer clues. Named says Los Angeles, with real dates. Blind hides the place and dates but keeps the real mortgage rate, and that is enough: asked to identify the blind series, Claude named Los Angeles 16 times out of 18 and got the dates exactly right. Masked shows only the last ten years, rescaled, with no rate. Claude never named LA, though it could still guess the period from the shape, so masking reduces the clues rather than removing them. The chart shows a forecast made in April 2022, just before the downturn. With the clues, Claude forecast a fall, close to what happened. With the masked prompt, Claude predicted continued growth, as ARIMAX did. The masked forecast and ARIMAX both missed the downturn.</a:t>
+              <a:t>[Jeremy] Here is how we gave the AI fewer clues. Named says Los Angeles, with real dates. Blind hides the place and dates but keeps the real mortgage rate, and that is enough: asked to identify the blind series, Claude named Los Angeles 16 times out of 18 and got the dates exactly right. Masked shows only the last ten years, rescaled, with no rate. Claude never named LA, though it could still guess the period from the shape, so masking reduces the clues rather than removing them. The chart shows a forecast made in April 2022, just before the downturn. With the clues, Claude forecast a fall, close to what happened. With the masked prompt, Claude predicted continued growth, as ARIMAX did. The masked forecast and ARIMAX both missed the downturn. One more check: given 26 years of masked data instead of 10, Claude called the 2022 fall and scored 2.47 percent. A longer history gives the dates away, so masking is a dial, not a switch.</a:t>
             </a:r>
           </a:p>
         </p:txBody>
@@ -1430,7 +1430,7 @@
           <a:lstStyle/>
           <a:p>
             <a:r>
-              <a:t>We also examined the relationship with rates and produced a forecast for August 2027. Top: our VAR estimates how LA values respond after a one-point rise in the mortgage rate: little at first, about 4.5 percent lower after a year and 9 after two. That is a predictive relationship, not a proven causal effect, and the Granger test is borderline, p equals 0.052. Inside ARIMAX neither the rate nor jobs is significant on its own, but the rate still helps out of sample. It enters with a two-year lag, so a twelve-month forecast never needs future rates. Bottom: ARIMAX forecasts about 998 thousand dollars by August 2027, up 4.8 percent. The band is the ARIMA 80 percent interval, for context: from minus 6 to plus 17 percent.</a:t>
+              <a:t>[Neil] We also examined the relationship with rates and produced a forecast for August 2027. Top: our VAR estimates how LA values respond after a one-point rise in the mortgage rate: little at first, about 4.5 percent lower after a year and 9 after two. That is a predictive relationship, not a proven causal effect, and the Granger test is borderline, p equals 0.052. Inside ARIMAX neither the rate nor jobs is significant on its own, and jobs, income and crime didn't improve the forecast. Still, the rate helps out of sample. It enters with a two-year lag, so a twelve-month forecast never needs future rates. Bottom: ARIMAX forecasts about 998 thousand dollars by August 2027, up 4.8 percent. The band is the ARIMA 80 percent interval, for context: from minus 6 to plus 17 percent.</a:t>
             </a:r>
           </a:p>
         </p:txBody>
@@ -1500,7 +1500,7 @@
           <a:lstStyle/>
           <a:p>
             <a:r>
-              <a:t>That forecast describes the metro average. Individual neighborhoods look very different. Of 496 neighborhoods with recent data, 220 rose more than 2 percent in the last year, 216 stayed within 2 percent, and 60 fell. [Switch to the browser.] Blue is rising, red is falling. The map shows gains in selected coastal neighborhoods, including North of Montana, Point Dume and Corona del Mar, and declines in parts of central LA such as Koreatown. [Click one neighborhood.] Each shows its value, its change and our 12-month forecast. [Back to the slides.] Higher starting prices were associated with larger declines in LA County after 2022. We tested neighborhood forecasts the same rolling way, at five yearly dates for about 400 neighborhoods: ARIMA for each neighborhood had 2.8 percent error, the naive benchmark 3.5.</a:t>
+              <a:t>[Jin] That forecast describes the metro average. Individual neighborhoods look very different. Of 496 neighborhoods with recent data, 220 rose more than 2 percent in the last year, 216 stayed within 2 percent, and 60 fell. [Switch to the browser.] Blue is rising, red is falling. The map shows gains in selected coastal neighborhoods, including North of Montana, Point Dume and Corona del Mar, and declines in parts of central LA such as Koreatown and Downtown. [Click one neighborhood.] Each shows its value, its change and our 12-month forecast. [Back to the slides.] Higher starting prices were associated with larger declines in LA County after 2022. We tested neighborhood forecasts the same rolling way, at five yearly dates for about 400 neighborhoods: ARIMA for each neighborhood had 2.8 percent error, the naive benchmark 3.5.</a:t>
             </a:r>
           </a:p>
         </p:txBody>
@@ -5114,8 +5114,8 @@
         </p:nvSpPr>
         <p:spPr>
           <a:xfrm>
-            <a:off x="457200" y="3826763"/>
-            <a:ext cx="8229600" cy="722376"/>
+            <a:off x="457200" y="4050791"/>
+            <a:ext cx="8229600" cy="498347"/>
           </a:xfrm>
           <a:prstGeom prst="roundRect">
             <a:avLst>
@@ -5146,8 +5146,8 @@
         </p:nvSpPr>
         <p:spPr>
           <a:xfrm>
-            <a:off x="457200" y="3884554"/>
-            <a:ext cx="64008" cy="606795"/>
+            <a:off x="457200" y="4090659"/>
+            <a:ext cx="64008" cy="418612"/>
           </a:xfrm>
           <a:prstGeom prst="rect">
             <a:avLst/>
@@ -5176,8 +5176,8 @@
         </p:nvSpPr>
         <p:spPr>
           <a:xfrm>
-            <a:off x="676656" y="3826763"/>
-            <a:ext cx="7827264" cy="722376"/>
+            <a:off x="676656" y="4050791"/>
+            <a:ext cx="7827264" cy="498347"/>
           </a:xfrm>
           <a:prstGeom prst="rect">
             <a:avLst/>
@@ -5218,7 +5218,7 @@
                 </a:solidFill>
                 <a:latin typeface="Arial"/>
               </a:rPr>
-              <a:t>Test more cities; score the AI live on months after its training cutoff; feed AI altered histories to check whether it forecasts the data or recalls the past.</a:t>
+              <a:t>Test more cities; score the AI live on months after its training cutoff.</a:t>
             </a:r>
           </a:p>
         </p:txBody>
@@ -5512,7 +5512,7 @@
                 </a:solidFill>
                 <a:latin typeface="Arial"/>
               </a:rPr>
-              <a:t>Test chatbots on outcomes they cannot know</a:t>
+              <a:t>Test AI on outcomes it cannot know</a:t>
             </a:r>
           </a:p>
         </p:txBody>
@@ -5558,7 +5558,7 @@
                 </a:solidFill>
                 <a:latin typeface="Arial"/>
               </a:rPr>
-              <a:t>Historical chatbot tests can be affected by recognition of past events.</a:t>
+              <a:t>Historical AI tests can be affected by recognition of past events.</a:t>
             </a:r>
           </a:p>
         </p:txBody>
@@ -5682,7 +5682,7 @@
                 </a:solidFill>
                 <a:latin typeface="Arial"/>
               </a:rPr>
-              <a:t>Rates showed a delayed relationship</a:t>
+              <a:t>Mortgage rates matter, slowly</a:t>
             </a:r>
           </a:p>
         </p:txBody>
@@ -5728,7 +5728,7 @@
                 </a:solidFill>
                 <a:latin typeface="Arial"/>
               </a:rPr>
-              <a:t>Adding jobs did not improve our forecast; turning points stayed hard to call.</a:t>
+              <a:t>Jobs, income and crime didn't improve the forecast; turning points stayed hard to call.</a:t>
             </a:r>
           </a:p>
         </p:txBody>
@@ -6145,7 +6145,7 @@
       </p:sp>
       <p:pic>
         <p:nvPicPr>
-          <p:cNvPr id="7" name="Picture 6" descr="LA ZHVI 2000-2026 above the 30-year mortgage rate; test window shaded" title="LA ZHVI 2000-2026 above the 30-year mortgage rate; test window shaded"/>
+          <p:cNvPr id="7" name="Picture 6" descr="LA ZHVI 2000-2026 before and after inflation, peaks marked, above the 30-year mortgage rate; test window shaded" title="LA ZHVI 2000-2026 before and after inflation, peaks marked, above the 30-year mortgage rate; test window shaded"/>
           <p:cNvPicPr>
             <a:picLocks noChangeAspect="1"/>
           </p:cNvPicPr>
@@ -6267,7 +6267,7 @@
         </p:nvSpPr>
         <p:spPr>
           <a:xfrm>
-            <a:off x="5989320" y="2418080"/>
+            <a:off x="5989320" y="2363216"/>
             <a:ext cx="2743200" cy="406400"/>
           </a:xfrm>
           <a:prstGeom prst="rect">
@@ -6313,7 +6313,7 @@
         </p:nvSpPr>
         <p:spPr>
           <a:xfrm>
-            <a:off x="5989320" y="2824480"/>
+            <a:off x="5989320" y="2769616"/>
             <a:ext cx="2743200" cy="149352"/>
           </a:xfrm>
           <a:prstGeom prst="rect">
@@ -6346,7 +6346,7 @@
                 </a:solidFill>
                 <a:latin typeface="Arial"/>
               </a:rPr>
-              <a:t>Below the January 2025 peak</a:t>
+              <a:t>Below the January 2025 peak, before inflation</a:t>
             </a:r>
           </a:p>
         </p:txBody>
@@ -6359,7 +6359,7 @@
         </p:nvSpPr>
         <p:spPr>
           <a:xfrm>
-            <a:off x="5989320" y="3175000"/>
+            <a:off x="5989320" y="3065272"/>
             <a:ext cx="2743200" cy="406400"/>
           </a:xfrm>
           <a:prstGeom prst="rect">
@@ -6392,7 +6392,7 @@
                 </a:solidFill>
                 <a:latin typeface="Arial"/>
               </a:rPr>
-              <a:t>2.7% → 7.6%</a:t>
+              <a:t>-7.1%</a:t>
             </a:r>
           </a:p>
         </p:txBody>
@@ -6405,7 +6405,99 @@
         </p:nvSpPr>
         <p:spPr>
           <a:xfrm>
-            <a:off x="5989320" y="3581400"/>
+            <a:off x="5989320" y="3471672"/>
+            <a:ext cx="2743200" cy="149352"/>
+          </a:xfrm>
+          <a:prstGeom prst="rect">
+            <a:avLst/>
+          </a:prstGeom>
+          <a:noFill/>
+          <a:ln/>
+        </p:spPr>
+        <p:txBody>
+          <a:bodyPr wrap="square" anchor="t" lIns="25400" rIns="25400" tIns="25400" bIns="25400">
+            <a:spAutoFit/>
+          </a:bodyPr>
+          <a:lstStyle/>
+          <a:p>
+            <a:pPr algn="l">
+              <a:lnSpc>
+                <a:spcPct val="100000"/>
+              </a:lnSpc>
+              <a:spcBef>
+                <a:spcPts val="0"/>
+              </a:spcBef>
+              <a:spcAft>
+                <a:spcPts val="600"/>
+              </a:spcAft>
+            </a:pPr>
+            <a:r>
+              <a:rPr sz="1050" b="0" i="0">
+                <a:solidFill>
+                  <a:srgbClr val="6B6F76"/>
+                </a:solidFill>
+                <a:latin typeface="Arial"/>
+              </a:rPr>
+              <a:t>Below the May 2022 peak, after inflation</a:t>
+            </a:r>
+          </a:p>
+        </p:txBody>
+      </p:sp>
+      <p:sp>
+        <p:nvSpPr>
+          <p:cNvPr id="14" name="TextBox 13"/>
+          <p:cNvSpPr txBox="1"/>
+          <p:nvPr/>
+        </p:nvSpPr>
+        <p:spPr>
+          <a:xfrm>
+            <a:off x="5989320" y="3767328"/>
+            <a:ext cx="2743200" cy="406400"/>
+          </a:xfrm>
+          <a:prstGeom prst="rect">
+            <a:avLst/>
+          </a:prstGeom>
+          <a:noFill/>
+          <a:ln/>
+        </p:spPr>
+        <p:txBody>
+          <a:bodyPr wrap="none" anchor="t" lIns="25400" rIns="25400" tIns="25400" bIns="25400">
+            <a:spAutoFit/>
+          </a:bodyPr>
+          <a:lstStyle/>
+          <a:p>
+            <a:pPr algn="l">
+              <a:lnSpc>
+                <a:spcPct val="100000"/>
+              </a:lnSpc>
+              <a:spcBef>
+                <a:spcPts val="0"/>
+              </a:spcBef>
+              <a:spcAft>
+                <a:spcPts val="600"/>
+              </a:spcAft>
+            </a:pPr>
+            <a:r>
+              <a:rPr sz="2600" b="1" i="0">
+                <a:solidFill>
+                  <a:srgbClr val="B4400B"/>
+                </a:solidFill>
+                <a:latin typeface="Arial"/>
+              </a:rPr>
+              <a:t>2.7% → 7.6%</a:t>
+            </a:r>
+          </a:p>
+        </p:txBody>
+      </p:sp>
+      <p:sp>
+        <p:nvSpPr>
+          <p:cNvPr id="15" name="TextBox 14"/>
+          <p:cNvSpPr txBox="1"/>
+          <p:nvPr/>
+        </p:nvSpPr>
+        <p:spPr>
+          <a:xfrm>
+            <a:off x="5989320" y="4173728"/>
             <a:ext cx="2743200" cy="149352"/>
           </a:xfrm>
           <a:prstGeom prst="rect">
@@ -7193,7 +7285,7 @@
                 </a:solidFill>
                 <a:latin typeface="Arial"/>
               </a:rPr>
-              <a:t>14 MODELS + 3 CHATBOTS</a:t>
+              <a:t>14 MODELS + 3 AI</a:t>
             </a:r>
           </a:p>
         </p:txBody>
@@ -7545,7 +7637,7 @@
                 </a:solidFill>
                 <a:latin typeface="Arial"/>
               </a:rPr>
-              <a:t>Plus 3 AI chatbots</a:t>
+              <a:t>Plus 3 AI models (LLMs)</a:t>
             </a:r>
           </a:p>
         </p:txBody>
@@ -9051,7 +9143,7 @@
                 </a:solidFill>
                 <a:latin typeface="Arial"/>
               </a:rPr>
-              <a:t>Claude's average error rose from 1.3% to 2.8%, close to ARIMAX's 2.67%. These historical periods may already be familiar to the chatbots.</a:t>
+              <a:t>Claude's average error rose from 1.3% to 2.8%, close to ARIMAX's 2.67%. These historical periods may already be familiar to the AI.</a:t>
             </a:r>
           </a:p>
         </p:txBody>
@@ -9408,7 +9500,7 @@
                 </a:solidFill>
                 <a:latin typeface="Arial"/>
               </a:rPr>
-              <a:t>Claude identified LA in 16/18 blind prompts and 0/18 masked prompts. It could still estimate the period from the masked data.</a:t>
+              <a:t>Claude named LA in 16/18 blind and 0/18 masked prompts, yet dated masked data to about a month. Given 26 years, not 10, it called the 2022 fall (2.47% error).</a:t>
             </a:r>
           </a:p>
         </p:txBody>

</xml_diff>